<commit_message>
docs: user-centric README rewrite + presentation refresh
Rewrite README with OpenClaw-inspired progressive disclosure pattern:
value proposition upfront, install in first 4 lines, governance root
explained from user perspective (standards, skills, agents, context,
state). CLI reference extracted to docs/cli-reference.md.

Update docs/presentation with correct numbers across all layers:
speech-script.md, generate_pptx.py, 4 SVGs, and regenerated PPTX.
Key corrections: 45 skills (was 31), 15 agents (was 8), 60 commands
(was 37), coverage 90% (was 80%).

Co-Authored-By: Claude Opus 4.6 <noreply@anthropic.com>

Ai-Eng-Gate: passed
</commit_message>
<xml_diff>
--- a/docs/presentation/ai-engineering-board.pptx
+++ b/docs/presentation/ai-engineering-board.pptx
@@ -723,12 +723,12 @@
           </a:p>
           <a:p>
             <a:r>
-              <a:t>- decision-store.json: 10 real decisions with SHA-256 context hash.</a:t>
-            </a:r>
-          </a:p>
-          <a:p>
-            <a:r>
-              <a:t>- audit-log.ndjson: 183 recorded events.</a:t>
+              <a:t>- decision-store.json: 17 real decisions with SHA-256 context hash.</a:t>
+            </a:r>
+          </a:p>
+          <a:p>
+            <a:r>
+              <a:t>- audit-log.ndjson: 185 recorded events.</a:t>
             </a:r>
           </a:p>
           <a:p/>
@@ -825,7 +825,7 @@
           <a:p/>
           <a:p>
             <a:r>
-              <a:t>Thresholds: Coverage &gt;=80%, Duplication &lt;=3%, CC &lt;=10, CogC &lt;=15.</a:t>
+              <a:t>Thresholds: Coverage &gt;=90%, Duplication &lt;=3%, CC &lt;=10, CogC &lt;=15.</a:t>
             </a:r>
           </a:p>
           <a:p/>
@@ -906,12 +906,12 @@
           </a:p>
           <a:p>
             <a:r>
-              <a:t>- Engineers: 37 slash commands, quality gates before push.</a:t>
-            </a:r>
-          </a:p>
-          <a:p>
-            <a:r>
-              <a:t>- Governance/Compliance: audit-log with 183 traceable events, decision store with 10 decisions.</a:t>
+              <a:t>- Engineers: 60 slash commands, quality gates before push.</a:t>
+            </a:r>
+          </a:p>
+          <a:p>
+            <a:r>
+              <a:t>- Governance/Compliance: audit-log with 185 traceable events, decision store with 17 decisions.</a:t>
             </a:r>
           </a:p>
           <a:p>
@@ -1097,12 +1097,12 @@
           <a:p/>
           <a:p>
             <a:r>
-              <a:t>Claude Code: CLAUDE.md + 37 slash commands.</a:t>
-            </a:r>
-          </a:p>
-          <a:p>
-            <a:r>
-              <a:t>Copilot: copilot-instructions.md + prompts in .github/copilot/.</a:t>
+              <a:t>Claude Code: CLAUDE.md + 60 slash commands.</a:t>
+            </a:r>
+          </a:p>
+          <a:p>
+            <a:r>
+              <a:t>Copilot: copilot-instructions.md + 45 prompt files in .github/prompts/ + 15 custom agents in .github/agents/.</a:t>
             </a:r>
           </a:p>
           <a:p>
@@ -1882,12 +1882,12 @@
           </a:p>
           <a:p>
             <a:r>
-              <a:t>- skills/ — 31 reusable procedures in 7 categories.</a:t>
-            </a:r>
-          </a:p>
-          <a:p>
-            <a:r>
-              <a:t>- agents/ — 8 specialized personas.</a:t>
+              <a:t>- skills/ — 45 reusable procedures in 6 categories.</a:t>
+            </a:r>
+          </a:p>
+          <a:p>
+            <a:r>
+              <a:t>- agents/ — 15 specialized personas.</a:t>
             </a:r>
           </a:p>
           <a:p>
@@ -1909,7 +1909,7 @@
           <a:p/>
           <a:p>
             <a:r>
-              <a:t>Works with Claude Code (37 slash commands), GitHub Copilot, OpenAI Codex.</a:t>
+              <a:t>Works with Claude Code (60 slash commands), GitHub Copilot (45 prompt files + 15 custom agents), OpenAI Codex.</a:t>
             </a:r>
           </a:p>
           <a:p>
@@ -2190,42 +2190,37 @@
           <a:lstStyle/>
           <a:p>
             <a:r>
-              <a:t>31 skills organized in 7 categories:</a:t>
-            </a:r>
-          </a:p>
-          <a:p>
-            <a:r>
-              <a:t>- Workflows (4): commit, PR, acho, pre-implementation.</a:t>
-            </a:r>
-          </a:p>
-          <a:p>
-            <a:r>
-              <a:t>- Dev (6): debug, refactor, code review, test strategy, migration, deps.</a:t>
-            </a:r>
-          </a:p>
-          <a:p>
-            <a:r>
-              <a:t>- Review (3): architecture, performance, security.</a:t>
-            </a:r>
-          </a:p>
-          <a:p>
-            <a:r>
-              <a:t>- Docs (4): changelog, explain, writer, prompt design.</a:t>
-            </a:r>
-          </a:p>
-          <a:p>
-            <a:r>
-              <a:t>- Govern (9): create/delete specs, skills, agents + risk lifecycle.</a:t>
-            </a:r>
-          </a:p>
-          <a:p>
-            <a:r>
-              <a:t>- Quality (3): audit code, audit report, install check.</a:t>
-            </a:r>
-          </a:p>
-          <a:p>
-            <a:r>
-              <a:t>- Utils (3): git helpers, platform detection, Python patterns.</a:t>
+              <a:t>45 skills organized in 6 categories:</a:t>
+            </a:r>
+          </a:p>
+          <a:p>
+            <a:r>
+              <a:t>- Workflows (6): commit, PR, acho, pre-implementation, cleanup, self-improve.</a:t>
+            </a:r>
+          </a:p>
+          <a:p>
+            <a:r>
+              <a:t>- Dev (10): debug, refactor, code review, test runner, test strategy, migration, deps, data modeling, CI/CD generation, multi-agent.</a:t>
+            </a:r>
+          </a:p>
+          <a:p>
+            <a:r>
+              <a:t>- Review (6): architecture, performance, security, data security, DAST, container security.</a:t>
+            </a:r>
+          </a:p>
+          <a:p>
+            <a:r>
+              <a:t>- Docs (5): changelog, explain, writer, simplify, prompt design.</a:t>
+            </a:r>
+          </a:p>
+          <a:p>
+            <a:r>
+              <a:t>- Govern (12): create/delete specs, skills, agents + integrity check, contract compliance, ownership audit, adaptive standards + risk lifecycle.</a:t>
+            </a:r>
+          </a:p>
+          <a:p>
+            <a:r>
+              <a:t>- Quality (6): audit code, docs audit, install check, release gate, SBOM, test gap analysis.</a:t>
             </a:r>
           </a:p>
           <a:p/>
@@ -2301,47 +2296,38 @@
           <a:lstStyle/>
           <a:p>
             <a:r>
-              <a:t>8 specialized agents:</a:t>
-            </a:r>
-          </a:p>
-          <a:p>
-            <a:r>
-              <a:t>- Principal Engineer: senior code review.</a:t>
-            </a:r>
-          </a:p>
-          <a:p>
-            <a:r>
-              <a:t>- Architect: architectural analysis.</a:t>
-            </a:r>
-          </a:p>
-          <a:p>
-            <a:r>
-              <a:t>- Security Reviewer: security assessment.</a:t>
-            </a:r>
-          </a:p>
-          <a:p>
-            <a:r>
-              <a:t>- Debugger: systematic diagnosis.</a:t>
-            </a:r>
-          </a:p>
-          <a:p>
-            <a:r>
-              <a:t>- Quality Auditor: quality gate enforcement.</a:t>
-            </a:r>
-          </a:p>
-          <a:p>
-            <a:r>
-              <a:t>- Verify App: end-to-end verification.</a:t>
-            </a:r>
-          </a:p>
-          <a:p>
-            <a:r>
-              <a:t>- Codebase Mapper: structure mapping.</a:t>
-            </a:r>
-          </a:p>
-          <a:p>
-            <a:r>
-              <a:t>- Code Simplifier: complexity reduction.</a:t>
+              <a:t>15 specialized agents organized by function:</a:t>
+            </a:r>
+          </a:p>
+          <a:p/>
+          <a:p>
+            <a:r>
+              <a:t>Code quality: Principal Engineer, Code Simplifier, Quality Auditor.</a:t>
+            </a:r>
+          </a:p>
+          <a:p>
+            <a:r>
+              <a:t>Architecture &amp; design: Architect, Navigator.</a:t>
+            </a:r>
+          </a:p>
+          <a:p>
+            <a:r>
+              <a:t>Security: Security Reviewer.</a:t>
+            </a:r>
+          </a:p>
+          <a:p>
+            <a:r>
+              <a:t>Testing &amp; verification: Test Master, Verify App, Debugger.</a:t>
+            </a:r>
+          </a:p>
+          <a:p>
+            <a:r>
+              <a:t>Delivery &amp; ops: Orchestrator, DevOps Engineer, PR Reviewer.</a:t>
+            </a:r>
+          </a:p>
+          <a:p>
+            <a:r>
+              <a:t>Documentation &amp; governance: Docs Writer, Governance Steward, Platform Auditor.</a:t>
             </a:r>
           </a:p>
           <a:p/>
@@ -9202,54 +9188,14 @@
                 </a:solidFill>
                 <a:latin typeface="Inter"/>
               </a:rPr>
-              <a:t>≥ 80%</a:t>
-            </a:r>
-          </a:p>
-        </p:txBody>
-      </p:sp>
-      <p:sp>
-        <p:nvSpPr>
-          <p:cNvPr id="22" name="TextBox 21"/>
-          <p:cNvSpPr txBox="1"/>
-          <p:nvPr/>
-        </p:nvSpPr>
-        <p:spPr>
-          <a:xfrm>
-            <a:off x="1706727" y="4498848"/>
-            <a:ext cx="1920240" cy="182880"/>
-          </a:xfrm>
-          <a:prstGeom prst="rect">
-            <a:avLst/>
-          </a:prstGeom>
-          <a:noFill/>
-        </p:spPr>
-        <p:txBody>
-          <a:bodyPr wrap="square" anchor="t"/>
-          <a:lstStyle/>
-          <a:p>
-            <a:pPr algn="ctr">
-              <a:spcBef>
-                <a:spcPts val="0"/>
-              </a:spcBef>
-              <a:spcAft>
-                <a:spcPts val="0"/>
-              </a:spcAft>
-            </a:pPr>
-            <a:r>
-              <a:rPr sz="800" b="0">
-                <a:solidFill>
-                  <a:srgbClr val="94A3B8"/>
-                </a:solidFill>
-                <a:latin typeface="Inter"/>
-              </a:rPr>
-              <a:t>(≥90% gov-critical)</a:t>
-            </a:r>
-          </a:p>
-        </p:txBody>
-      </p:sp>
-      <p:sp>
-        <p:nvSpPr>
-          <p:cNvPr id="23" name="Rectangle 22"/>
+              <a:t>≥ 90%</a:t>
+            </a:r>
+          </a:p>
+        </p:txBody>
+      </p:sp>
+      <p:sp>
+        <p:nvSpPr>
+          <p:cNvPr id="22" name="Rectangle 21"/>
           <p:cNvSpPr/>
           <p:nvPr/>
         </p:nvSpPr>
@@ -9292,7 +9238,7 @@
       </p:sp>
       <p:sp>
         <p:nvSpPr>
-          <p:cNvPr id="24" name="TextBox 23"/>
+          <p:cNvPr id="23" name="TextBox 22"/>
           <p:cNvSpPr txBox="1"/>
           <p:nvPr/>
         </p:nvSpPr>
@@ -9332,7 +9278,7 @@
       </p:sp>
       <p:sp>
         <p:nvSpPr>
-          <p:cNvPr id="25" name="TextBox 24"/>
+          <p:cNvPr id="24" name="TextBox 23"/>
           <p:cNvSpPr txBox="1"/>
           <p:nvPr/>
         </p:nvSpPr>
@@ -9372,7 +9318,7 @@
       </p:sp>
       <p:sp>
         <p:nvSpPr>
-          <p:cNvPr id="26" name="Rectangle 25"/>
+          <p:cNvPr id="25" name="Rectangle 24"/>
           <p:cNvSpPr/>
           <p:nvPr/>
         </p:nvSpPr>
@@ -9415,7 +9361,7 @@
       </p:sp>
       <p:sp>
         <p:nvSpPr>
-          <p:cNvPr id="27" name="TextBox 26"/>
+          <p:cNvPr id="26" name="TextBox 25"/>
           <p:cNvSpPr txBox="1"/>
           <p:nvPr/>
         </p:nvSpPr>
@@ -9455,7 +9401,7 @@
       </p:sp>
       <p:sp>
         <p:nvSpPr>
-          <p:cNvPr id="28" name="TextBox 27"/>
+          <p:cNvPr id="27" name="TextBox 26"/>
           <p:cNvSpPr txBox="1"/>
           <p:nvPr/>
         </p:nvSpPr>
@@ -9495,7 +9441,7 @@
       </p:sp>
       <p:sp>
         <p:nvSpPr>
-          <p:cNvPr id="29" name="TextBox 28"/>
+          <p:cNvPr id="28" name="TextBox 27"/>
           <p:cNvSpPr txBox="1"/>
           <p:nvPr/>
         </p:nvSpPr>
@@ -9535,7 +9481,7 @@
       </p:sp>
       <p:sp>
         <p:nvSpPr>
-          <p:cNvPr id="30" name="Rectangle 29"/>
+          <p:cNvPr id="29" name="Rectangle 28"/>
           <p:cNvSpPr/>
           <p:nvPr/>
         </p:nvSpPr>
@@ -9578,7 +9524,7 @@
       </p:sp>
       <p:sp>
         <p:nvSpPr>
-          <p:cNvPr id="31" name="TextBox 30"/>
+          <p:cNvPr id="30" name="TextBox 29"/>
           <p:cNvSpPr txBox="1"/>
           <p:nvPr/>
         </p:nvSpPr>
@@ -9618,7 +9564,7 @@
       </p:sp>
       <p:sp>
         <p:nvSpPr>
-          <p:cNvPr id="32" name="TextBox 31"/>
+          <p:cNvPr id="31" name="TextBox 30"/>
           <p:cNvSpPr txBox="1"/>
           <p:nvPr/>
         </p:nvSpPr>
@@ -9658,7 +9604,7 @@
       </p:sp>
       <p:sp>
         <p:nvSpPr>
-          <p:cNvPr id="33" name="TextBox 32"/>
+          <p:cNvPr id="32" name="TextBox 31"/>
           <p:cNvSpPr txBox="1"/>
           <p:nvPr/>
         </p:nvSpPr>
@@ -9698,7 +9644,7 @@
       </p:sp>
       <p:sp>
         <p:nvSpPr>
-          <p:cNvPr id="34" name="Rectangle 33"/>
+          <p:cNvPr id="33" name="Rectangle 32"/>
           <p:cNvSpPr/>
           <p:nvPr/>
         </p:nvSpPr>
@@ -9743,7 +9689,7 @@
       </p:sp>
       <p:sp>
         <p:nvSpPr>
-          <p:cNvPr id="35" name="Rectangle 34"/>
+          <p:cNvPr id="34" name="Rectangle 33"/>
           <p:cNvSpPr/>
           <p:nvPr/>
         </p:nvSpPr>
@@ -9786,7 +9732,7 @@
       </p:sp>
       <p:sp>
         <p:nvSpPr>
-          <p:cNvPr id="36" name="TextBox 35"/>
+          <p:cNvPr id="35" name="TextBox 34"/>
           <p:cNvSpPr txBox="1"/>
           <p:nvPr/>
         </p:nvSpPr>
@@ -9826,7 +9772,7 @@
       </p:sp>
       <p:sp>
         <p:nvSpPr>
-          <p:cNvPr id="37" name="TextBox 36"/>
+          <p:cNvPr id="36" name="TextBox 35"/>
           <p:cNvSpPr txBox="1"/>
           <p:nvPr/>
         </p:nvSpPr>
@@ -9866,7 +9812,7 @@
       </p:sp>
       <p:sp>
         <p:nvSpPr>
-          <p:cNvPr id="38" name="Rectangle 37"/>
+          <p:cNvPr id="37" name="Rectangle 36"/>
           <p:cNvSpPr/>
           <p:nvPr/>
         </p:nvSpPr>
@@ -9911,7 +9857,7 @@
       </p:sp>
       <p:sp>
         <p:nvSpPr>
-          <p:cNvPr id="39" name="Rectangle 38"/>
+          <p:cNvPr id="38" name="Rectangle 37"/>
           <p:cNvSpPr/>
           <p:nvPr/>
         </p:nvSpPr>
@@ -9954,7 +9900,7 @@
       </p:sp>
       <p:sp>
         <p:nvSpPr>
-          <p:cNvPr id="40" name="TextBox 39"/>
+          <p:cNvPr id="39" name="TextBox 38"/>
           <p:cNvSpPr txBox="1"/>
           <p:nvPr/>
         </p:nvSpPr>
@@ -9994,7 +9940,7 @@
       </p:sp>
       <p:sp>
         <p:nvSpPr>
-          <p:cNvPr id="41" name="TextBox 40"/>
+          <p:cNvPr id="40" name="TextBox 39"/>
           <p:cNvSpPr txBox="1"/>
           <p:nvPr/>
         </p:nvSpPr>
@@ -10034,7 +9980,7 @@
       </p:sp>
       <p:sp>
         <p:nvSpPr>
-          <p:cNvPr id="42" name="Rectangle 41"/>
+          <p:cNvPr id="41" name="Rectangle 40"/>
           <p:cNvSpPr/>
           <p:nvPr/>
         </p:nvSpPr>
@@ -10079,7 +10025,7 @@
       </p:sp>
       <p:sp>
         <p:nvSpPr>
-          <p:cNvPr id="43" name="Rectangle 42"/>
+          <p:cNvPr id="42" name="Rectangle 41"/>
           <p:cNvSpPr/>
           <p:nvPr/>
         </p:nvSpPr>
@@ -10122,7 +10068,7 @@
       </p:sp>
       <p:sp>
         <p:nvSpPr>
-          <p:cNvPr id="44" name="TextBox 43"/>
+          <p:cNvPr id="43" name="TextBox 42"/>
           <p:cNvSpPr txBox="1"/>
           <p:nvPr/>
         </p:nvSpPr>
@@ -10162,7 +10108,7 @@
       </p:sp>
       <p:sp>
         <p:nvSpPr>
-          <p:cNvPr id="45" name="TextBox 44"/>
+          <p:cNvPr id="44" name="TextBox 43"/>
           <p:cNvSpPr txBox="1"/>
           <p:nvPr/>
         </p:nvSpPr>
@@ -10202,7 +10148,7 @@
       </p:sp>
       <p:sp>
         <p:nvSpPr>
-          <p:cNvPr id="46" name="Rectangle 45"/>
+          <p:cNvPr id="45" name="Rectangle 44"/>
           <p:cNvSpPr/>
           <p:nvPr/>
         </p:nvSpPr>
@@ -10247,7 +10193,7 @@
       </p:sp>
       <p:sp>
         <p:nvSpPr>
-          <p:cNvPr id="47" name="Rectangle 46"/>
+          <p:cNvPr id="46" name="Rectangle 45"/>
           <p:cNvSpPr/>
           <p:nvPr/>
         </p:nvSpPr>
@@ -10290,7 +10236,7 @@
       </p:sp>
       <p:sp>
         <p:nvSpPr>
-          <p:cNvPr id="48" name="TextBox 47"/>
+          <p:cNvPr id="47" name="TextBox 46"/>
           <p:cNvSpPr txBox="1"/>
           <p:nvPr/>
         </p:nvSpPr>
@@ -10330,7 +10276,7 @@
       </p:sp>
       <p:sp>
         <p:nvSpPr>
-          <p:cNvPr id="49" name="TextBox 48"/>
+          <p:cNvPr id="48" name="TextBox 47"/>
           <p:cNvSpPr txBox="1"/>
           <p:nvPr/>
         </p:nvSpPr>
@@ -10604,7 +10550,7 @@
                           </a:solidFill>
                           <a:latin typeface="Inter"/>
                         </a:rPr>
-                        <a:t>Fast workflows — 37 slash commands</a:t>
+                        <a:t>Fast workflows — 60 slash commands</a:t>
                       </a:r>
                     </a:p>
                   </a:txBody>
@@ -10667,7 +10613,7 @@
                           </a:solidFill>
                           <a:latin typeface="Inter"/>
                         </a:rPr>
-                        <a:t>audit-log with 183 traceable events</a:t>
+                        <a:t>audit-log with 185 traceable events</a:t>
                       </a:r>
                     </a:p>
                   </a:txBody>
@@ -10690,7 +10636,7 @@
                           </a:solidFill>
                           <a:latin typeface="Inter"/>
                         </a:rPr>
-                        <a:t>Decision store with 10 decisions</a:t>
+                        <a:t>Decision store with 17 decisions</a:t>
                       </a:r>
                     </a:p>
                   </a:txBody>
@@ -12194,7 +12140,7 @@
                 <a:latin typeface="Inter"/>
               </a:rPr>
               <a:t>CLAUDE.md
-37 slash commands
+60 slash commands
 .claude/commands/</a:t>
             </a:r>
           </a:p>
@@ -12364,7 +12310,7 @@
                 <a:latin typeface="Inter"/>
               </a:rPr>
               <a:t>copilot-instructions.md
-.github/copilot/</a:t>
+.github/prompts/ + .github/agents/</a:t>
             </a:r>
           </a:p>
         </p:txBody>
@@ -19792,8 +19738,8 @@
                 </a:solidFill>
                 <a:latin typeface="Inter"/>
               </a:rPr>
-              <a:t>31 procedures
-in 7 categories</a:t>
+              <a:t>45 procedures
+in 6 categories</a:t>
             </a:r>
           </a:p>
         </p:txBody>
@@ -19916,7 +19862,7 @@
                 </a:solidFill>
                 <a:latin typeface="Inter"/>
               </a:rPr>
-              <a:t>8 specialized
+              <a:t>15 specialized
 personas</a:t>
             </a:r>
           </a:p>
@@ -20374,7 +20320,7 @@
                 <a:latin typeface="Inter"/>
               </a:rPr>
               <a:t>CLAUDE.md
-37 slash commands</a:t>
+60 slash commands</a:t>
             </a:r>
           </a:p>
         </p:txBody>
@@ -20500,7 +20446,7 @@
                 <a:latin typeface="Inter"/>
               </a:rPr>
               <a:t>copilot-instructions.md
-.github/copilot/</a:t>
+45 prompts + 15 agents</a:t>
             </a:r>
           </a:p>
         </p:txBody>
@@ -23422,7 +23368,7 @@
                 </a:solidFill>
                 <a:latin typeface="JetBrains Mono"/>
               </a:rPr>
-              <a:t>Skills: 31 Reusable Procedures</a:t>
+              <a:t>Skills: 45 Reusable Procedures</a:t>
             </a:r>
           </a:p>
         </p:txBody>
@@ -23590,7 +23536,7 @@
                 </a:solidFill>
                 <a:latin typeface="Inter"/>
               </a:rPr>
-              <a:t>4</a:t>
+              <a:t>6</a:t>
             </a:r>
           </a:p>
         </p:txBody>
@@ -23670,8 +23616,8 @@
                 </a:solidFill>
                 <a:latin typeface="Inter"/>
               </a:rPr>
-              <a:t>commit, PR, acho,
-pre-implementation</a:t>
+              <a:t>commit, PR, acho, cleanup,
+pre-impl, self-improve</a:t>
             </a:r>
           </a:p>
         </p:txBody>
@@ -23839,7 +23785,7 @@
                 </a:solidFill>
                 <a:latin typeface="Inter"/>
               </a:rPr>
-              <a:t>6</a:t>
+              <a:t>10</a:t>
             </a:r>
           </a:p>
         </p:txBody>
@@ -23919,8 +23865,8 @@
                 </a:solidFill>
                 <a:latin typeface="Inter"/>
               </a:rPr>
-              <a:t>debug, refactor, code-review,
-test, migration, deps</a:t>
+              <a:t>debug, refactor, review,
+test, migrate, CI/CD, ...</a:t>
             </a:r>
           </a:p>
         </p:txBody>
@@ -24088,7 +24034,7 @@
                 </a:solidFill>
                 <a:latin typeface="Inter"/>
               </a:rPr>
-              <a:t>3</a:t>
+              <a:t>6</a:t>
             </a:r>
           </a:p>
         </p:txBody>
@@ -24168,8 +24114,8 @@
                 </a:solidFill>
                 <a:latin typeface="Inter"/>
               </a:rPr>
-              <a:t>architecture, performance,
-security</a:t>
+              <a:t>architecture, security,
+data-sec, DAST, ...</a:t>
             </a:r>
           </a:p>
         </p:txBody>
@@ -24337,7 +24283,7 @@
                 </a:solidFill>
                 <a:latin typeface="Inter"/>
               </a:rPr>
-              <a:t>4</a:t>
+              <a:t>5</a:t>
             </a:r>
           </a:p>
         </p:txBody>
@@ -24417,8 +24363,8 @@
                 </a:solidFill>
                 <a:latin typeface="Inter"/>
               </a:rPr>
-              <a:t>changelog, explain,
-writer, prompt-design</a:t>
+              <a:t>changelog, explain, writer,
+simplify, prompt-design</a:t>
             </a:r>
           </a:p>
         </p:txBody>
@@ -24431,7 +24377,7 @@
         </p:nvSpPr>
         <p:spPr>
           <a:xfrm>
-            <a:off x="2483967" y="3794760"/>
+            <a:off x="3718407" y="3794760"/>
             <a:ext cx="2286000" cy="1645920"/>
           </a:xfrm>
           <a:prstGeom prst="rect">
@@ -24476,7 +24422,7 @@
         </p:nvSpPr>
         <p:spPr>
           <a:xfrm>
-            <a:off x="2483967" y="3794760"/>
+            <a:off x="3718407" y="3794760"/>
             <a:ext cx="54864" cy="1645920"/>
           </a:xfrm>
           <a:prstGeom prst="rect">
@@ -24519,7 +24465,7 @@
         </p:nvSpPr>
         <p:spPr>
           <a:xfrm>
-            <a:off x="2648559" y="3886200"/>
+            <a:off x="3882999" y="3886200"/>
             <a:ext cx="2011680" cy="274320"/>
           </a:xfrm>
           <a:prstGeom prst="rect">
@@ -24559,7 +24505,7 @@
         </p:nvSpPr>
         <p:spPr>
           <a:xfrm>
-            <a:off x="2648559" y="4160520"/>
+            <a:off x="3882999" y="4160520"/>
             <a:ext cx="548640" cy="548640"/>
           </a:xfrm>
           <a:prstGeom prst="rect">
@@ -24586,7 +24532,7 @@
                 </a:solidFill>
                 <a:latin typeface="Inter"/>
               </a:rPr>
-              <a:t>9</a:t>
+              <a:t>12</a:t>
             </a:r>
           </a:p>
         </p:txBody>
@@ -24599,7 +24545,7 @@
         </p:nvSpPr>
         <p:spPr>
           <a:xfrm>
-            <a:off x="3215487" y="4251960"/>
+            <a:off x="4449927" y="4251960"/>
             <a:ext cx="1371600" cy="457200"/>
           </a:xfrm>
           <a:prstGeom prst="rect">
@@ -24639,7 +24585,7 @@
         </p:nvSpPr>
         <p:spPr>
           <a:xfrm>
-            <a:off x="2648559" y="4754880"/>
+            <a:off x="3882999" y="4754880"/>
             <a:ext cx="2011680" cy="594360"/>
           </a:xfrm>
           <a:prstGeom prst="rect">
@@ -24666,8 +24612,8 @@
                 </a:solidFill>
                 <a:latin typeface="Inter"/>
               </a:rPr>
-              <a:t>create/delete specs, skills,
-agents + risk lifecycle</a:t>
+              <a:t>specs, skills, agents +
+integrity + risk lifecycle</a:t>
             </a:r>
           </a:p>
         </p:txBody>
@@ -24680,7 +24626,7 @@
         </p:nvSpPr>
         <p:spPr>
           <a:xfrm>
-            <a:off x="4952847" y="3794760"/>
+            <a:off x="6187287" y="3794760"/>
             <a:ext cx="2286000" cy="1645920"/>
           </a:xfrm>
           <a:prstGeom prst="rect">
@@ -24725,7 +24671,7 @@
         </p:nvSpPr>
         <p:spPr>
           <a:xfrm>
-            <a:off x="4952847" y="3794760"/>
+            <a:off x="6187287" y="3794760"/>
             <a:ext cx="54864" cy="1645920"/>
           </a:xfrm>
           <a:prstGeom prst="rect">
@@ -24768,7 +24714,7 @@
         </p:nvSpPr>
         <p:spPr>
           <a:xfrm>
-            <a:off x="5117439" y="3886200"/>
+            <a:off x="6351879" y="3886200"/>
             <a:ext cx="2011680" cy="274320"/>
           </a:xfrm>
           <a:prstGeom prst="rect">
@@ -24808,7 +24754,7 @@
         </p:nvSpPr>
         <p:spPr>
           <a:xfrm>
-            <a:off x="5117439" y="4160520"/>
+            <a:off x="6351879" y="4160520"/>
             <a:ext cx="548640" cy="548640"/>
           </a:xfrm>
           <a:prstGeom prst="rect">
@@ -24835,7 +24781,7 @@
                 </a:solidFill>
                 <a:latin typeface="Inter"/>
               </a:rPr>
-              <a:t>3</a:t>
+              <a:t>6</a:t>
             </a:r>
           </a:p>
         </p:txBody>
@@ -24848,7 +24794,7 @@
         </p:nvSpPr>
         <p:spPr>
           <a:xfrm>
-            <a:off x="5684367" y="4251960"/>
+            <a:off x="6918807" y="4251960"/>
             <a:ext cx="1371600" cy="457200"/>
           </a:xfrm>
           <a:prstGeom prst="rect">
@@ -24888,7 +24834,7 @@
         </p:nvSpPr>
         <p:spPr>
           <a:xfrm>
-            <a:off x="5117439" y="4754880"/>
+            <a:off x="6351879" y="4754880"/>
             <a:ext cx="2011680" cy="594360"/>
           </a:xfrm>
           <a:prstGeom prst="rect">
@@ -24915,264 +24861,15 @@
                 </a:solidFill>
                 <a:latin typeface="Inter"/>
               </a:rPr>
-              <a:t>audit-code, audit-report,
-install-check</a:t>
-            </a:r>
-          </a:p>
-        </p:txBody>
-      </p:sp>
-      <p:sp>
-        <p:nvSpPr>
-          <p:cNvPr id="40" name="Rectangle 39"/>
-          <p:cNvSpPr/>
-          <p:nvPr/>
-        </p:nvSpPr>
-        <p:spPr>
-          <a:xfrm>
-            <a:off x="7421727" y="3794760"/>
-            <a:ext cx="2286000" cy="1645920"/>
-          </a:xfrm>
-          <a:prstGeom prst="rect">
-            <a:avLst/>
-          </a:prstGeom>
-          <a:solidFill>
-            <a:srgbClr val="1E293B"/>
-          </a:solidFill>
-          <a:ln w="12700">
-            <a:solidFill>
-              <a:srgbClr val="1A2A40"/>
-            </a:solidFill>
-          </a:ln>
-        </p:spPr>
-        <p:style>
-          <a:lnRef idx="1">
-            <a:schemeClr val="accent1"/>
-          </a:lnRef>
-          <a:fillRef idx="3">
-            <a:schemeClr val="accent1"/>
-          </a:fillRef>
-          <a:effectRef idx="2">
-            <a:schemeClr val="accent1"/>
-          </a:effectRef>
-          <a:fontRef idx="minor">
-            <a:schemeClr val="lt1"/>
-          </a:fontRef>
-        </p:style>
-        <p:txBody>
-          <a:bodyPr rtlCol="0" anchor="ctr"/>
-          <a:lstStyle/>
-          <a:p>
-            <a:pPr algn="ctr"/>
-          </a:p>
-        </p:txBody>
-      </p:sp>
-      <p:sp>
-        <p:nvSpPr>
-          <p:cNvPr id="41" name="Rectangle 40"/>
-          <p:cNvSpPr/>
-          <p:nvPr/>
-        </p:nvSpPr>
-        <p:spPr>
-          <a:xfrm>
-            <a:off x="7421727" y="3794760"/>
-            <a:ext cx="54864" cy="1645920"/>
-          </a:xfrm>
-          <a:prstGeom prst="rect">
-            <a:avLst/>
-          </a:prstGeom>
-          <a:solidFill>
-            <a:srgbClr val="1A3A5C"/>
-          </a:solidFill>
-          <a:ln>
-            <a:noFill/>
-          </a:ln>
-        </p:spPr>
-        <p:style>
-          <a:lnRef idx="1">
-            <a:schemeClr val="accent1"/>
-          </a:lnRef>
-          <a:fillRef idx="3">
-            <a:schemeClr val="accent1"/>
-          </a:fillRef>
-          <a:effectRef idx="2">
-            <a:schemeClr val="accent1"/>
-          </a:effectRef>
-          <a:fontRef idx="minor">
-            <a:schemeClr val="lt1"/>
-          </a:fontRef>
-        </p:style>
-        <p:txBody>
-          <a:bodyPr rtlCol="0" anchor="ctr"/>
-          <a:lstStyle/>
-          <a:p>
-            <a:pPr algn="ctr"/>
-          </a:p>
-        </p:txBody>
-      </p:sp>
-      <p:sp>
-        <p:nvSpPr>
-          <p:cNvPr id="42" name="TextBox 41"/>
-          <p:cNvSpPr txBox="1"/>
-          <p:nvPr/>
-        </p:nvSpPr>
-        <p:spPr>
-          <a:xfrm>
-            <a:off x="7586319" y="3886200"/>
-            <a:ext cx="2011680" cy="274320"/>
-          </a:xfrm>
-          <a:prstGeom prst="rect">
-            <a:avLst/>
-          </a:prstGeom>
-          <a:noFill/>
-        </p:spPr>
-        <p:txBody>
-          <a:bodyPr wrap="square" anchor="t"/>
-          <a:lstStyle/>
-          <a:p>
-            <a:pPr algn="l">
-              <a:spcBef>
-                <a:spcPts val="0"/>
-              </a:spcBef>
-              <a:spcAft>
-                <a:spcPts val="0"/>
-              </a:spcAft>
-            </a:pPr>
-            <a:r>
-              <a:rPr sz="1400" b="1">
-                <a:solidFill>
-                  <a:srgbClr val="E2E8F0"/>
-                </a:solidFill>
-                <a:latin typeface="Inter"/>
-              </a:rPr>
-              <a:t>Utils</a:t>
-            </a:r>
-          </a:p>
-        </p:txBody>
-      </p:sp>
-      <p:sp>
-        <p:nvSpPr>
-          <p:cNvPr id="43" name="TextBox 42"/>
-          <p:cNvSpPr txBox="1"/>
-          <p:nvPr/>
-        </p:nvSpPr>
-        <p:spPr>
-          <a:xfrm>
-            <a:off x="7586319" y="4160520"/>
-            <a:ext cx="548640" cy="548640"/>
-          </a:xfrm>
-          <a:prstGeom prst="rect">
-            <a:avLst/>
-          </a:prstGeom>
-          <a:noFill/>
-        </p:spPr>
-        <p:txBody>
-          <a:bodyPr wrap="square" anchor="t"/>
-          <a:lstStyle/>
-          <a:p>
-            <a:pPr algn="l">
-              <a:spcBef>
-                <a:spcPts val="0"/>
-              </a:spcBef>
-              <a:spcAft>
-                <a:spcPts val="0"/>
-              </a:spcAft>
-            </a:pPr>
-            <a:r>
-              <a:rPr sz="3200" b="1">
-                <a:solidFill>
-                  <a:srgbClr val="1A3A5C"/>
-                </a:solidFill>
-                <a:latin typeface="Inter"/>
-              </a:rPr>
-              <a:t>3</a:t>
-            </a:r>
-          </a:p>
-        </p:txBody>
-      </p:sp>
-      <p:sp>
-        <p:nvSpPr>
-          <p:cNvPr id="44" name="TextBox 43"/>
-          <p:cNvSpPr txBox="1"/>
-          <p:nvPr/>
-        </p:nvSpPr>
-        <p:spPr>
-          <a:xfrm>
-            <a:off x="8153247" y="4251960"/>
-            <a:ext cx="1371600" cy="457200"/>
-          </a:xfrm>
-          <a:prstGeom prst="rect">
-            <a:avLst/>
-          </a:prstGeom>
-          <a:noFill/>
-        </p:spPr>
-        <p:txBody>
-          <a:bodyPr wrap="square" anchor="t"/>
-          <a:lstStyle/>
-          <a:p>
-            <a:pPr algn="l">
-              <a:spcBef>
-                <a:spcPts val="0"/>
-              </a:spcBef>
-              <a:spcAft>
-                <a:spcPts val="0"/>
-              </a:spcAft>
-            </a:pPr>
-            <a:r>
-              <a:rPr sz="900" b="0">
-                <a:solidFill>
-                  <a:srgbClr val="94A3B8"/>
-                </a:solidFill>
-                <a:latin typeface="Inter"/>
-              </a:rPr>
-              <a:t>skills</a:t>
-            </a:r>
-          </a:p>
-        </p:txBody>
-      </p:sp>
-      <p:sp>
-        <p:nvSpPr>
-          <p:cNvPr id="45" name="TextBox 44"/>
-          <p:cNvSpPr txBox="1"/>
-          <p:nvPr/>
-        </p:nvSpPr>
-        <p:spPr>
-          <a:xfrm>
-            <a:off x="7586319" y="4754880"/>
-            <a:ext cx="2011680" cy="594360"/>
-          </a:xfrm>
-          <a:prstGeom prst="rect">
-            <a:avLst/>
-          </a:prstGeom>
-          <a:noFill/>
-        </p:spPr>
-        <p:txBody>
-          <a:bodyPr wrap="square" anchor="t"/>
-          <a:lstStyle/>
-          <a:p>
-            <a:pPr algn="l">
-              <a:spcBef>
-                <a:spcPts val="0"/>
-              </a:spcBef>
-              <a:spcAft>
-                <a:spcPts val="0"/>
-              </a:spcAft>
-            </a:pPr>
-            <a:r>
-              <a:rPr sz="900" b="0">
-                <a:solidFill>
-                  <a:srgbClr val="64748B"/>
-                </a:solidFill>
-                <a:latin typeface="Inter"/>
-              </a:rPr>
-              <a:t>git-helpers, platform-detect,
-python-patterns</a:t>
-            </a:r>
-          </a:p>
-        </p:txBody>
-      </p:sp>
-      <p:sp>
-        <p:nvSpPr>
-          <p:cNvPr id="46" name="TextBox 45"/>
+              <a:t>audit, release-gate,
+SBOM, test-gap, ...</a:t>
+            </a:r>
+          </a:p>
+        </p:txBody>
+      </p:sp>
+      <p:sp>
+        <p:nvSpPr>
+          <p:cNvPr id="40" name="TextBox 39"/>
           <p:cNvSpPr txBox="1"/>
           <p:nvPr/>
         </p:nvSpPr>
@@ -25314,7 +25011,7 @@
                 </a:solidFill>
                 <a:latin typeface="JetBrains Mono"/>
               </a:rPr>
-              <a:t>Agents: 8 Specialized Personas</a:t>
+              <a:t>Agents: 15 Specialized Personas</a:t>
             </a:r>
           </a:p>
         </p:txBody>
@@ -25452,8 +25149,8 @@
         </p:nvSpPr>
         <p:spPr>
           <a:xfrm>
-            <a:off x="5364327" y="1143000"/>
-            <a:ext cx="1463040" cy="1005840"/>
+            <a:off x="5455767" y="845820"/>
+            <a:ext cx="1280160" cy="868680"/>
           </a:xfrm>
           <a:prstGeom prst="rect">
             <a:avLst/>
@@ -25497,7 +25194,7 @@
         </p:nvSpPr>
         <p:spPr>
           <a:xfrm>
-            <a:off x="5437479" y="1216152"/>
+            <a:off x="5528919" y="918972"/>
             <a:ext cx="365760" cy="365760"/>
           </a:xfrm>
           <a:prstGeom prst="ellipse">
@@ -25542,7 +25239,7 @@
         </p:nvSpPr>
         <p:spPr>
           <a:xfrm>
-            <a:off x="5437479" y="1216152"/>
+            <a:off x="5528919" y="918972"/>
             <a:ext cx="365760" cy="365760"/>
           </a:xfrm>
           <a:prstGeom prst="rect">
@@ -25582,8 +25279,8 @@
         </p:nvSpPr>
         <p:spPr>
           <a:xfrm>
-            <a:off x="5821527" y="1188720"/>
-            <a:ext cx="914400" cy="457200"/>
+            <a:off x="5912967" y="891540"/>
+            <a:ext cx="731520" cy="457200"/>
           </a:xfrm>
           <a:prstGeom prst="rect">
             <a:avLst/>
@@ -25623,8 +25320,8 @@
         </p:nvSpPr>
         <p:spPr>
           <a:xfrm>
-            <a:off x="5437479" y="1737360"/>
-            <a:ext cx="1316736" cy="365760"/>
+            <a:off x="5528919" y="1440180"/>
+            <a:ext cx="1133856" cy="365760"/>
           </a:xfrm>
           <a:prstGeom prst="rect">
             <a:avLst/>
@@ -25704,8 +25401,8 @@
         </p:nvSpPr>
         <p:spPr>
           <a:xfrm>
-            <a:off x="3812538" y="1785771"/>
-            <a:ext cx="1463040" cy="1005840"/>
+            <a:off x="4414391" y="1067171"/>
+            <a:ext cx="1280160" cy="868680"/>
           </a:xfrm>
           <a:prstGeom prst="rect">
             <a:avLst/>
@@ -25749,7 +25446,7 @@
         </p:nvSpPr>
         <p:spPr>
           <a:xfrm>
-            <a:off x="3885690" y="1858923"/>
+            <a:off x="4487543" y="1140323"/>
             <a:ext cx="365760" cy="365760"/>
           </a:xfrm>
           <a:prstGeom prst="ellipse">
@@ -25794,7 +25491,7 @@
         </p:nvSpPr>
         <p:spPr>
           <a:xfrm>
-            <a:off x="3885690" y="1858923"/>
+            <a:off x="4487543" y="1140323"/>
             <a:ext cx="365760" cy="365760"/>
           </a:xfrm>
           <a:prstGeom prst="rect">
@@ -25834,8 +25531,8 @@
         </p:nvSpPr>
         <p:spPr>
           <a:xfrm>
-            <a:off x="4269738" y="1831491"/>
-            <a:ext cx="914400" cy="457200"/>
+            <a:off x="4871591" y="1112891"/>
+            <a:ext cx="731520" cy="457200"/>
           </a:xfrm>
           <a:prstGeom prst="rect">
             <a:avLst/>
@@ -25874,8 +25571,8 @@
         </p:nvSpPr>
         <p:spPr>
           <a:xfrm>
-            <a:off x="3885690" y="2380131"/>
-            <a:ext cx="1316736" cy="365760"/>
+            <a:off x="4487543" y="1661531"/>
+            <a:ext cx="1133856" cy="365760"/>
           </a:xfrm>
           <a:prstGeom prst="rect">
             <a:avLst/>
@@ -25901,7 +25598,7 @@
                 </a:solidFill>
                 <a:latin typeface="Inter"/>
               </a:rPr>
-              <a:t>Architectural analysis</a:t>
+              <a:t>Architecture analysis</a:t>
             </a:r>
           </a:p>
         </p:txBody>
@@ -25955,8 +25652,8 @@
         </p:nvSpPr>
         <p:spPr>
           <a:xfrm>
-            <a:off x="3169767" y="3337559"/>
-            <a:ext cx="1463040" cy="1005840"/>
+            <a:off x="3553078" y="1692951"/>
+            <a:ext cx="1280160" cy="868680"/>
           </a:xfrm>
           <a:prstGeom prst="rect">
             <a:avLst/>
@@ -26000,7 +25697,7 @@
         </p:nvSpPr>
         <p:spPr>
           <a:xfrm>
-            <a:off x="3242919" y="3410711"/>
+            <a:off x="3626230" y="1766103"/>
             <a:ext cx="365760" cy="365760"/>
           </a:xfrm>
           <a:prstGeom prst="ellipse">
@@ -26045,7 +25742,7 @@
         </p:nvSpPr>
         <p:spPr>
           <a:xfrm>
-            <a:off x="3242919" y="3410711"/>
+            <a:off x="3626230" y="1766103"/>
             <a:ext cx="365760" cy="365760"/>
           </a:xfrm>
           <a:prstGeom prst="rect">
@@ -26085,8 +25782,8 @@
         </p:nvSpPr>
         <p:spPr>
           <a:xfrm>
-            <a:off x="3626967" y="3383279"/>
-            <a:ext cx="914400" cy="457200"/>
+            <a:off x="4010278" y="1738671"/>
+            <a:ext cx="731520" cy="457200"/>
           </a:xfrm>
           <a:prstGeom prst="rect">
             <a:avLst/>
@@ -26126,8 +25823,8 @@
         </p:nvSpPr>
         <p:spPr>
           <a:xfrm>
-            <a:off x="3242919" y="3931919"/>
-            <a:ext cx="1316736" cy="365760"/>
+            <a:off x="3626230" y="2287311"/>
+            <a:ext cx="1133856" cy="365760"/>
           </a:xfrm>
           <a:prstGeom prst="rect">
             <a:avLst/>
@@ -26153,7 +25850,7 @@
                 </a:solidFill>
                 <a:latin typeface="Inter"/>
               </a:rPr>
-              <a:t>Security assessment</a:t>
+              <a:t>Threat assessment</a:t>
             </a:r>
           </a:p>
         </p:txBody>
@@ -26207,8 +25904,8 @@
         </p:nvSpPr>
         <p:spPr>
           <a:xfrm>
-            <a:off x="3812538" y="4889348"/>
-            <a:ext cx="1463040" cy="1005840"/>
+            <a:off x="3020757" y="2614957"/>
+            <a:ext cx="1280160" cy="868680"/>
           </a:xfrm>
           <a:prstGeom prst="rect">
             <a:avLst/>
@@ -26252,7 +25949,7 @@
         </p:nvSpPr>
         <p:spPr>
           <a:xfrm>
-            <a:off x="3885690" y="4962500"/>
+            <a:off x="3093909" y="2688109"/>
             <a:ext cx="365760" cy="365760"/>
           </a:xfrm>
           <a:prstGeom prst="ellipse">
@@ -26297,7 +25994,7 @@
         </p:nvSpPr>
         <p:spPr>
           <a:xfrm>
-            <a:off x="3885690" y="4962500"/>
+            <a:off x="3093909" y="2688109"/>
             <a:ext cx="365760" cy="365760"/>
           </a:xfrm>
           <a:prstGeom prst="rect">
@@ -26324,7 +26021,7 @@
                 </a:solidFill>
                 <a:latin typeface="Inter"/>
               </a:rPr>
-              <a:t>DB</a:t>
+              <a:t>TM</a:t>
             </a:r>
           </a:p>
         </p:txBody>
@@ -26337,8 +26034,8 @@
         </p:nvSpPr>
         <p:spPr>
           <a:xfrm>
-            <a:off x="4269738" y="4935068"/>
-            <a:ext cx="914400" cy="457200"/>
+            <a:off x="3477957" y="2660677"/>
+            <a:ext cx="731520" cy="457200"/>
           </a:xfrm>
           <a:prstGeom prst="rect">
             <a:avLst/>
@@ -26364,7 +26061,8 @@
                 </a:solidFill>
                 <a:latin typeface="Inter"/>
               </a:rPr>
-              <a:t>Debugger</a:t>
+              <a:t>Test
+Master</a:t>
             </a:r>
           </a:p>
         </p:txBody>
@@ -26377,8 +26075,8 @@
         </p:nvSpPr>
         <p:spPr>
           <a:xfrm>
-            <a:off x="3885690" y="5483708"/>
-            <a:ext cx="1316736" cy="365760"/>
+            <a:off x="3093909" y="3209317"/>
+            <a:ext cx="1133856" cy="365760"/>
           </a:xfrm>
           <a:prstGeom prst="rect">
             <a:avLst/>
@@ -26404,7 +26102,7 @@
                 </a:solidFill>
                 <a:latin typeface="Inter"/>
               </a:rPr>
-              <a:t>Systematic diagnosis</a:t>
+              <a:t>Test strategy</a:t>
             </a:r>
           </a:p>
         </p:txBody>
@@ -26458,8 +26156,8 @@
         </p:nvSpPr>
         <p:spPr>
           <a:xfrm>
-            <a:off x="5364327" y="5532120"/>
-            <a:ext cx="1463040" cy="1005840"/>
+            <a:off x="2909472" y="3673766"/>
+            <a:ext cx="1280160" cy="868680"/>
           </a:xfrm>
           <a:prstGeom prst="rect">
             <a:avLst/>
@@ -26503,7 +26201,7 @@
         </p:nvSpPr>
         <p:spPr>
           <a:xfrm>
-            <a:off x="5437479" y="5605272"/>
+            <a:off x="2982624" y="3746918"/>
             <a:ext cx="365760" cy="365760"/>
           </a:xfrm>
           <a:prstGeom prst="ellipse">
@@ -26548,7 +26246,7 @@
         </p:nvSpPr>
         <p:spPr>
           <a:xfrm>
-            <a:off x="5437479" y="5605272"/>
+            <a:off x="2982624" y="3746918"/>
             <a:ext cx="365760" cy="365760"/>
           </a:xfrm>
           <a:prstGeom prst="rect">
@@ -26575,7 +26273,7 @@
                 </a:solidFill>
                 <a:latin typeface="Inter"/>
               </a:rPr>
-              <a:t>QA</a:t>
+              <a:t>DB</a:t>
             </a:r>
           </a:p>
         </p:txBody>
@@ -26588,8 +26286,8 @@
         </p:nvSpPr>
         <p:spPr>
           <a:xfrm>
-            <a:off x="5821527" y="5577840"/>
-            <a:ext cx="914400" cy="457200"/>
+            <a:off x="3366672" y="3719486"/>
+            <a:ext cx="731520" cy="457200"/>
           </a:xfrm>
           <a:prstGeom prst="rect">
             <a:avLst/>
@@ -26615,8 +26313,7 @@
                 </a:solidFill>
                 <a:latin typeface="Inter"/>
               </a:rPr>
-              <a:t>Quality
-Auditor</a:t>
+              <a:t>Debugger</a:t>
             </a:r>
           </a:p>
         </p:txBody>
@@ -26629,8 +26326,8 @@
         </p:nvSpPr>
         <p:spPr>
           <a:xfrm>
-            <a:off x="5437479" y="6126480"/>
-            <a:ext cx="1316736" cy="365760"/>
+            <a:off x="2982624" y="4268126"/>
+            <a:ext cx="1133856" cy="365760"/>
           </a:xfrm>
           <a:prstGeom prst="rect">
             <a:avLst/>
@@ -26656,7 +26353,7 @@
                 </a:solidFill>
                 <a:latin typeface="Inter"/>
               </a:rPr>
-              <a:t>Quality gates</a:t>
+              <a:t>Root cause analysis</a:t>
             </a:r>
           </a:p>
         </p:txBody>
@@ -26710,8 +26407,8 @@
         </p:nvSpPr>
         <p:spPr>
           <a:xfrm>
-            <a:off x="6916115" y="4889348"/>
-            <a:ext cx="1463040" cy="1005840"/>
+            <a:off x="3238464" y="4686300"/>
+            <a:ext cx="1280160" cy="868680"/>
           </a:xfrm>
           <a:prstGeom prst="rect">
             <a:avLst/>
@@ -26755,7 +26452,7 @@
         </p:nvSpPr>
         <p:spPr>
           <a:xfrm>
-            <a:off x="6989267" y="4962500"/>
+            <a:off x="3311616" y="4759452"/>
             <a:ext cx="365760" cy="365760"/>
           </a:xfrm>
           <a:prstGeom prst="ellipse">
@@ -26800,7 +26497,7 @@
         </p:nvSpPr>
         <p:spPr>
           <a:xfrm>
-            <a:off x="6989267" y="4962500"/>
+            <a:off x="3311616" y="4759452"/>
             <a:ext cx="365760" cy="365760"/>
           </a:xfrm>
           <a:prstGeom prst="rect">
@@ -26827,7 +26524,7 @@
                 </a:solidFill>
                 <a:latin typeface="Inter"/>
               </a:rPr>
-              <a:t>VA</a:t>
+              <a:t>QA</a:t>
             </a:r>
           </a:p>
         </p:txBody>
@@ -26840,8 +26537,8 @@
         </p:nvSpPr>
         <p:spPr>
           <a:xfrm>
-            <a:off x="7373315" y="4935068"/>
-            <a:ext cx="914400" cy="457200"/>
+            <a:off x="3695664" y="4732020"/>
+            <a:ext cx="731520" cy="457200"/>
           </a:xfrm>
           <a:prstGeom prst="rect">
             <a:avLst/>
@@ -26867,8 +26564,8 @@
                 </a:solidFill>
                 <a:latin typeface="Inter"/>
               </a:rPr>
-              <a:t>Verify
-App</a:t>
+              <a:t>Quality
+Auditor</a:t>
             </a:r>
           </a:p>
         </p:txBody>
@@ -26881,8 +26578,8 @@
         </p:nvSpPr>
         <p:spPr>
           <a:xfrm>
-            <a:off x="6989267" y="5483708"/>
-            <a:ext cx="1316736" cy="365760"/>
+            <a:off x="3311616" y="5280660"/>
+            <a:ext cx="1133856" cy="365760"/>
           </a:xfrm>
           <a:prstGeom prst="rect">
             <a:avLst/>
@@ -26908,7 +26605,7 @@
                 </a:solidFill>
                 <a:latin typeface="Inter"/>
               </a:rPr>
-              <a:t>E2E verification</a:t>
+              <a:t>Quality gates</a:t>
             </a:r>
           </a:p>
         </p:txBody>
@@ -26962,8 +26659,8 @@
         </p:nvSpPr>
         <p:spPr>
           <a:xfrm>
-            <a:off x="7558887" y="3337560"/>
-            <a:ext cx="1463040" cy="1005840"/>
+            <a:off x="3950848" y="5477482"/>
+            <a:ext cx="1280160" cy="868680"/>
           </a:xfrm>
           <a:prstGeom prst="rect">
             <a:avLst/>
@@ -27007,7 +26704,7 @@
         </p:nvSpPr>
         <p:spPr>
           <a:xfrm>
-            <a:off x="7632039" y="3410712"/>
+            <a:off x="4024000" y="5550634"/>
             <a:ext cx="365760" cy="365760"/>
           </a:xfrm>
           <a:prstGeom prst="ellipse">
@@ -27052,7 +26749,7 @@
         </p:nvSpPr>
         <p:spPr>
           <a:xfrm>
-            <a:off x="7632039" y="3410712"/>
+            <a:off x="4024000" y="5550634"/>
             <a:ext cx="365760" cy="365760"/>
           </a:xfrm>
           <a:prstGeom prst="rect">
@@ -27079,7 +26776,7 @@
                 </a:solidFill>
                 <a:latin typeface="Inter"/>
               </a:rPr>
-              <a:t>CM</a:t>
+              <a:t>VA</a:t>
             </a:r>
           </a:p>
         </p:txBody>
@@ -27092,8 +26789,8 @@
         </p:nvSpPr>
         <p:spPr>
           <a:xfrm>
-            <a:off x="8016087" y="3383280"/>
-            <a:ext cx="914400" cy="457200"/>
+            <a:off x="4408048" y="5523202"/>
+            <a:ext cx="731520" cy="457200"/>
           </a:xfrm>
           <a:prstGeom prst="rect">
             <a:avLst/>
@@ -27119,8 +26816,8 @@
                 </a:solidFill>
                 <a:latin typeface="Inter"/>
               </a:rPr>
-              <a:t>Codebase
-Mapper</a:t>
+              <a:t>Verify
+App</a:t>
             </a:r>
           </a:p>
         </p:txBody>
@@ -27133,8 +26830,8 @@
         </p:nvSpPr>
         <p:spPr>
           <a:xfrm>
-            <a:off x="7632039" y="3931920"/>
-            <a:ext cx="1316736" cy="365760"/>
+            <a:off x="4024000" y="6071842"/>
+            <a:ext cx="1133856" cy="365760"/>
           </a:xfrm>
           <a:prstGeom prst="rect">
             <a:avLst/>
@@ -27160,7 +26857,7 @@
                 </a:solidFill>
                 <a:latin typeface="Inter"/>
               </a:rPr>
-              <a:t>Structure mapping</a:t>
+              <a:t>E2E verification</a:t>
             </a:r>
           </a:p>
         </p:txBody>
@@ -27214,8 +26911,8 @@
         </p:nvSpPr>
         <p:spPr>
           <a:xfrm>
-            <a:off x="6916115" y="1785771"/>
-            <a:ext cx="1463040" cy="1005840"/>
+            <a:off x="4923446" y="5910510"/>
+            <a:ext cx="1280160" cy="868680"/>
           </a:xfrm>
           <a:prstGeom prst="rect">
             <a:avLst/>
@@ -27259,7 +26956,7 @@
         </p:nvSpPr>
         <p:spPr>
           <a:xfrm>
-            <a:off x="6989267" y="1858923"/>
+            <a:off x="4996598" y="5983662"/>
             <a:ext cx="365760" cy="365760"/>
           </a:xfrm>
           <a:prstGeom prst="ellipse">
@@ -27304,7 +27001,7 @@
         </p:nvSpPr>
         <p:spPr>
           <a:xfrm>
-            <a:off x="6989267" y="1858923"/>
+            <a:off x="4996598" y="5983662"/>
             <a:ext cx="365760" cy="365760"/>
           </a:xfrm>
           <a:prstGeom prst="rect">
@@ -27344,8 +27041,8 @@
         </p:nvSpPr>
         <p:spPr>
           <a:xfrm>
-            <a:off x="7373315" y="1831491"/>
-            <a:ext cx="914400" cy="457200"/>
+            <a:off x="5380646" y="5956230"/>
+            <a:ext cx="731520" cy="457200"/>
           </a:xfrm>
           <a:prstGeom prst="rect">
             <a:avLst/>
@@ -27385,8 +27082,8 @@
         </p:nvSpPr>
         <p:spPr>
           <a:xfrm>
-            <a:off x="6989267" y="2380131"/>
-            <a:ext cx="1316736" cy="365760"/>
+            <a:off x="4996598" y="6504870"/>
+            <a:ext cx="1133856" cy="365760"/>
           </a:xfrm>
           <a:prstGeom prst="rect">
             <a:avLst/>
@@ -27413,6 +27110,1768 @@
                 <a:latin typeface="Inter"/>
               </a:rPr>
               <a:t>Complexity reduction</a:t>
+            </a:r>
+          </a:p>
+        </p:txBody>
+      </p:sp>
+      <p:sp>
+        <p:nvSpPr>
+          <p:cNvPr id="54" name="Rectangle 53"/>
+          <p:cNvSpPr/>
+          <p:nvPr/>
+        </p:nvSpPr>
+        <p:spPr>
+          <a:xfrm>
+            <a:off x="6095847" y="3840480"/>
+            <a:ext cx="18288" cy="18288"/>
+          </a:xfrm>
+          <a:prstGeom prst="rect">
+            <a:avLst/>
+          </a:prstGeom>
+          <a:noFill/>
+          <a:ln>
+            <a:noFill/>
+          </a:ln>
+        </p:spPr>
+        <p:style>
+          <a:lnRef idx="1">
+            <a:schemeClr val="accent1"/>
+          </a:lnRef>
+          <a:fillRef idx="3">
+            <a:schemeClr val="accent1"/>
+          </a:fillRef>
+          <a:effectRef idx="2">
+            <a:schemeClr val="accent1"/>
+          </a:effectRef>
+          <a:fontRef idx="minor">
+            <a:schemeClr val="lt1"/>
+          </a:fontRef>
+        </p:style>
+        <p:txBody>
+          <a:bodyPr rtlCol="0" anchor="ctr"/>
+          <a:lstStyle/>
+          <a:p>
+            <a:pPr algn="ctr"/>
+          </a:p>
+        </p:txBody>
+      </p:sp>
+      <p:sp>
+        <p:nvSpPr>
+          <p:cNvPr id="55" name="Rectangle 54"/>
+          <p:cNvSpPr/>
+          <p:nvPr/>
+        </p:nvSpPr>
+        <p:spPr>
+          <a:xfrm>
+            <a:off x="5988087" y="5910510"/>
+            <a:ext cx="1280160" cy="868680"/>
+          </a:xfrm>
+          <a:prstGeom prst="rect">
+            <a:avLst/>
+          </a:prstGeom>
+          <a:solidFill>
+            <a:srgbClr val="1E293B"/>
+          </a:solidFill>
+          <a:ln w="12700">
+            <a:solidFill>
+              <a:srgbClr val="1A2A40"/>
+            </a:solidFill>
+          </a:ln>
+        </p:spPr>
+        <p:style>
+          <a:lnRef idx="1">
+            <a:schemeClr val="accent1"/>
+          </a:lnRef>
+          <a:fillRef idx="3">
+            <a:schemeClr val="accent1"/>
+          </a:fillRef>
+          <a:effectRef idx="2">
+            <a:schemeClr val="accent1"/>
+          </a:effectRef>
+          <a:fontRef idx="minor">
+            <a:schemeClr val="lt1"/>
+          </a:fontRef>
+        </p:style>
+        <p:txBody>
+          <a:bodyPr rtlCol="0" anchor="ctr"/>
+          <a:lstStyle/>
+          <a:p>
+            <a:pPr algn="ctr"/>
+          </a:p>
+        </p:txBody>
+      </p:sp>
+      <p:sp>
+        <p:nvSpPr>
+          <p:cNvPr id="56" name="Oval 55"/>
+          <p:cNvSpPr/>
+          <p:nvPr/>
+        </p:nvSpPr>
+        <p:spPr>
+          <a:xfrm>
+            <a:off x="6061239" y="5983662"/>
+            <a:ext cx="365760" cy="365760"/>
+          </a:xfrm>
+          <a:prstGeom prst="ellipse">
+            <a:avLst/>
+          </a:prstGeom>
+          <a:solidFill>
+            <a:srgbClr val="1E3A5F"/>
+          </a:solidFill>
+          <a:ln w="12700">
+            <a:solidFill>
+              <a:srgbClr val="00D4AA"/>
+            </a:solidFill>
+          </a:ln>
+        </p:spPr>
+        <p:style>
+          <a:lnRef idx="1">
+            <a:schemeClr val="accent1"/>
+          </a:lnRef>
+          <a:fillRef idx="3">
+            <a:schemeClr val="accent1"/>
+          </a:fillRef>
+          <a:effectRef idx="2">
+            <a:schemeClr val="accent1"/>
+          </a:effectRef>
+          <a:fontRef idx="minor">
+            <a:schemeClr val="lt1"/>
+          </a:fontRef>
+        </p:style>
+        <p:txBody>
+          <a:bodyPr rtlCol="0" anchor="ctr"/>
+          <a:lstStyle/>
+          <a:p>
+            <a:pPr algn="ctr"/>
+          </a:p>
+        </p:txBody>
+      </p:sp>
+      <p:sp>
+        <p:nvSpPr>
+          <p:cNvPr id="57" name="TextBox 56"/>
+          <p:cNvSpPr txBox="1"/>
+          <p:nvPr/>
+        </p:nvSpPr>
+        <p:spPr>
+          <a:xfrm>
+            <a:off x="6061239" y="5983662"/>
+            <a:ext cx="365760" cy="365760"/>
+          </a:xfrm>
+          <a:prstGeom prst="rect">
+            <a:avLst/>
+          </a:prstGeom>
+          <a:noFill/>
+        </p:spPr>
+        <p:txBody>
+          <a:bodyPr wrap="square" anchor="ctr"/>
+          <a:lstStyle/>
+          <a:p>
+            <a:pPr algn="ctr">
+              <a:spcBef>
+                <a:spcPts val="0"/>
+              </a:spcBef>
+              <a:spcAft>
+                <a:spcPts val="0"/>
+              </a:spcAft>
+            </a:pPr>
+            <a:r>
+              <a:rPr sz="900" b="1">
+                <a:solidFill>
+                  <a:srgbClr val="00D4AA"/>
+                </a:solidFill>
+                <a:latin typeface="Inter"/>
+              </a:rPr>
+              <a:t>OR</a:t>
+            </a:r>
+          </a:p>
+        </p:txBody>
+      </p:sp>
+      <p:sp>
+        <p:nvSpPr>
+          <p:cNvPr id="58" name="TextBox 57"/>
+          <p:cNvSpPr txBox="1"/>
+          <p:nvPr/>
+        </p:nvSpPr>
+        <p:spPr>
+          <a:xfrm>
+            <a:off x="6445287" y="5956230"/>
+            <a:ext cx="731520" cy="457200"/>
+          </a:xfrm>
+          <a:prstGeom prst="rect">
+            <a:avLst/>
+          </a:prstGeom>
+          <a:noFill/>
+        </p:spPr>
+        <p:txBody>
+          <a:bodyPr wrap="square" anchor="t"/>
+          <a:lstStyle/>
+          <a:p>
+            <a:pPr algn="l">
+              <a:spcBef>
+                <a:spcPts val="0"/>
+              </a:spcBef>
+              <a:spcAft>
+                <a:spcPts val="0"/>
+              </a:spcAft>
+            </a:pPr>
+            <a:r>
+              <a:rPr sz="1000" b="1">
+                <a:solidFill>
+                  <a:srgbClr val="E2E8F0"/>
+                </a:solidFill>
+                <a:latin typeface="Inter"/>
+              </a:rPr>
+              <a:t>Orchestrator</a:t>
+            </a:r>
+          </a:p>
+        </p:txBody>
+      </p:sp>
+      <p:sp>
+        <p:nvSpPr>
+          <p:cNvPr id="59" name="TextBox 58"/>
+          <p:cNvSpPr txBox="1"/>
+          <p:nvPr/>
+        </p:nvSpPr>
+        <p:spPr>
+          <a:xfrm>
+            <a:off x="6061239" y="6504870"/>
+            <a:ext cx="1133856" cy="365760"/>
+          </a:xfrm>
+          <a:prstGeom prst="rect">
+            <a:avLst/>
+          </a:prstGeom>
+          <a:noFill/>
+        </p:spPr>
+        <p:txBody>
+          <a:bodyPr wrap="square" anchor="t"/>
+          <a:lstStyle/>
+          <a:p>
+            <a:pPr algn="ctr">
+              <a:spcBef>
+                <a:spcPts val="0"/>
+              </a:spcBef>
+              <a:spcAft>
+                <a:spcPts val="0"/>
+              </a:spcAft>
+            </a:pPr>
+            <a:r>
+              <a:rPr sz="800" b="0">
+                <a:solidFill>
+                  <a:srgbClr val="64748B"/>
+                </a:solidFill>
+                <a:latin typeface="Inter"/>
+              </a:rPr>
+              <a:t>Multi-phase coord.</a:t>
+            </a:r>
+          </a:p>
+        </p:txBody>
+      </p:sp>
+      <p:sp>
+        <p:nvSpPr>
+          <p:cNvPr id="60" name="Rectangle 59"/>
+          <p:cNvSpPr/>
+          <p:nvPr/>
+        </p:nvSpPr>
+        <p:spPr>
+          <a:xfrm>
+            <a:off x="6095847" y="3840480"/>
+            <a:ext cx="18288" cy="18288"/>
+          </a:xfrm>
+          <a:prstGeom prst="rect">
+            <a:avLst/>
+          </a:prstGeom>
+          <a:noFill/>
+          <a:ln>
+            <a:noFill/>
+          </a:ln>
+        </p:spPr>
+        <p:style>
+          <a:lnRef idx="1">
+            <a:schemeClr val="accent1"/>
+          </a:lnRef>
+          <a:fillRef idx="3">
+            <a:schemeClr val="accent1"/>
+          </a:fillRef>
+          <a:effectRef idx="2">
+            <a:schemeClr val="accent1"/>
+          </a:effectRef>
+          <a:fontRef idx="minor">
+            <a:schemeClr val="lt1"/>
+          </a:fontRef>
+        </p:style>
+        <p:txBody>
+          <a:bodyPr rtlCol="0" anchor="ctr"/>
+          <a:lstStyle/>
+          <a:p>
+            <a:pPr algn="ctr"/>
+          </a:p>
+        </p:txBody>
+      </p:sp>
+      <p:sp>
+        <p:nvSpPr>
+          <p:cNvPr id="61" name="Rectangle 60"/>
+          <p:cNvSpPr/>
+          <p:nvPr/>
+        </p:nvSpPr>
+        <p:spPr>
+          <a:xfrm>
+            <a:off x="6960685" y="5477482"/>
+            <a:ext cx="1280160" cy="868680"/>
+          </a:xfrm>
+          <a:prstGeom prst="rect">
+            <a:avLst/>
+          </a:prstGeom>
+          <a:solidFill>
+            <a:srgbClr val="1E293B"/>
+          </a:solidFill>
+          <a:ln w="12700">
+            <a:solidFill>
+              <a:srgbClr val="1A2A40"/>
+            </a:solidFill>
+          </a:ln>
+        </p:spPr>
+        <p:style>
+          <a:lnRef idx="1">
+            <a:schemeClr val="accent1"/>
+          </a:lnRef>
+          <a:fillRef idx="3">
+            <a:schemeClr val="accent1"/>
+          </a:fillRef>
+          <a:effectRef idx="2">
+            <a:schemeClr val="accent1"/>
+          </a:effectRef>
+          <a:fontRef idx="minor">
+            <a:schemeClr val="lt1"/>
+          </a:fontRef>
+        </p:style>
+        <p:txBody>
+          <a:bodyPr rtlCol="0" anchor="ctr"/>
+          <a:lstStyle/>
+          <a:p>
+            <a:pPr algn="ctr"/>
+          </a:p>
+        </p:txBody>
+      </p:sp>
+      <p:sp>
+        <p:nvSpPr>
+          <p:cNvPr id="62" name="Oval 61"/>
+          <p:cNvSpPr/>
+          <p:nvPr/>
+        </p:nvSpPr>
+        <p:spPr>
+          <a:xfrm>
+            <a:off x="7033837" y="5550634"/>
+            <a:ext cx="365760" cy="365760"/>
+          </a:xfrm>
+          <a:prstGeom prst="ellipse">
+            <a:avLst/>
+          </a:prstGeom>
+          <a:solidFill>
+            <a:srgbClr val="1E3A5F"/>
+          </a:solidFill>
+          <a:ln w="12700">
+            <a:solidFill>
+              <a:srgbClr val="00D4AA"/>
+            </a:solidFill>
+          </a:ln>
+        </p:spPr>
+        <p:style>
+          <a:lnRef idx="1">
+            <a:schemeClr val="accent1"/>
+          </a:lnRef>
+          <a:fillRef idx="3">
+            <a:schemeClr val="accent1"/>
+          </a:fillRef>
+          <a:effectRef idx="2">
+            <a:schemeClr val="accent1"/>
+          </a:effectRef>
+          <a:fontRef idx="minor">
+            <a:schemeClr val="lt1"/>
+          </a:fontRef>
+        </p:style>
+        <p:txBody>
+          <a:bodyPr rtlCol="0" anchor="ctr"/>
+          <a:lstStyle/>
+          <a:p>
+            <a:pPr algn="ctr"/>
+          </a:p>
+        </p:txBody>
+      </p:sp>
+      <p:sp>
+        <p:nvSpPr>
+          <p:cNvPr id="63" name="TextBox 62"/>
+          <p:cNvSpPr txBox="1"/>
+          <p:nvPr/>
+        </p:nvSpPr>
+        <p:spPr>
+          <a:xfrm>
+            <a:off x="7033837" y="5550634"/>
+            <a:ext cx="365760" cy="365760"/>
+          </a:xfrm>
+          <a:prstGeom prst="rect">
+            <a:avLst/>
+          </a:prstGeom>
+          <a:noFill/>
+        </p:spPr>
+        <p:txBody>
+          <a:bodyPr wrap="square" anchor="ctr"/>
+          <a:lstStyle/>
+          <a:p>
+            <a:pPr algn="ctr">
+              <a:spcBef>
+                <a:spcPts val="0"/>
+              </a:spcBef>
+              <a:spcAft>
+                <a:spcPts val="0"/>
+              </a:spcAft>
+            </a:pPr>
+            <a:r>
+              <a:rPr sz="900" b="1">
+                <a:solidFill>
+                  <a:srgbClr val="00D4AA"/>
+                </a:solidFill>
+                <a:latin typeface="Inter"/>
+              </a:rPr>
+              <a:t>DE</a:t>
+            </a:r>
+          </a:p>
+        </p:txBody>
+      </p:sp>
+      <p:sp>
+        <p:nvSpPr>
+          <p:cNvPr id="64" name="TextBox 63"/>
+          <p:cNvSpPr txBox="1"/>
+          <p:nvPr/>
+        </p:nvSpPr>
+        <p:spPr>
+          <a:xfrm>
+            <a:off x="7417885" y="5523202"/>
+            <a:ext cx="731520" cy="457200"/>
+          </a:xfrm>
+          <a:prstGeom prst="rect">
+            <a:avLst/>
+          </a:prstGeom>
+          <a:noFill/>
+        </p:spPr>
+        <p:txBody>
+          <a:bodyPr wrap="square" anchor="t"/>
+          <a:lstStyle/>
+          <a:p>
+            <a:pPr algn="l">
+              <a:spcBef>
+                <a:spcPts val="0"/>
+              </a:spcBef>
+              <a:spcAft>
+                <a:spcPts val="0"/>
+              </a:spcAft>
+            </a:pPr>
+            <a:r>
+              <a:rPr sz="1000" b="1">
+                <a:solidFill>
+                  <a:srgbClr val="E2E8F0"/>
+                </a:solidFill>
+                <a:latin typeface="Inter"/>
+              </a:rPr>
+              <a:t>DevOps
+Engineer</a:t>
+            </a:r>
+          </a:p>
+        </p:txBody>
+      </p:sp>
+      <p:sp>
+        <p:nvSpPr>
+          <p:cNvPr id="65" name="TextBox 64"/>
+          <p:cNvSpPr txBox="1"/>
+          <p:nvPr/>
+        </p:nvSpPr>
+        <p:spPr>
+          <a:xfrm>
+            <a:off x="7033837" y="6071842"/>
+            <a:ext cx="1133856" cy="365760"/>
+          </a:xfrm>
+          <a:prstGeom prst="rect">
+            <a:avLst/>
+          </a:prstGeom>
+          <a:noFill/>
+        </p:spPr>
+        <p:txBody>
+          <a:bodyPr wrap="square" anchor="t"/>
+          <a:lstStyle/>
+          <a:p>
+            <a:pPr algn="ctr">
+              <a:spcBef>
+                <a:spcPts val="0"/>
+              </a:spcBef>
+              <a:spcAft>
+                <a:spcPts val="0"/>
+              </a:spcAft>
+            </a:pPr>
+            <a:r>
+              <a:rPr sz="800" b="0">
+                <a:solidFill>
+                  <a:srgbClr val="64748B"/>
+                </a:solidFill>
+                <a:latin typeface="Inter"/>
+              </a:rPr>
+              <a:t>CI/CD automation</a:t>
+            </a:r>
+          </a:p>
+        </p:txBody>
+      </p:sp>
+      <p:sp>
+        <p:nvSpPr>
+          <p:cNvPr id="66" name="Rectangle 65"/>
+          <p:cNvSpPr/>
+          <p:nvPr/>
+        </p:nvSpPr>
+        <p:spPr>
+          <a:xfrm>
+            <a:off x="6095847" y="3840480"/>
+            <a:ext cx="18288" cy="18288"/>
+          </a:xfrm>
+          <a:prstGeom prst="rect">
+            <a:avLst/>
+          </a:prstGeom>
+          <a:noFill/>
+          <a:ln>
+            <a:noFill/>
+          </a:ln>
+        </p:spPr>
+        <p:style>
+          <a:lnRef idx="1">
+            <a:schemeClr val="accent1"/>
+          </a:lnRef>
+          <a:fillRef idx="3">
+            <a:schemeClr val="accent1"/>
+          </a:fillRef>
+          <a:effectRef idx="2">
+            <a:schemeClr val="accent1"/>
+          </a:effectRef>
+          <a:fontRef idx="minor">
+            <a:schemeClr val="lt1"/>
+          </a:fontRef>
+        </p:style>
+        <p:txBody>
+          <a:bodyPr rtlCol="0" anchor="ctr"/>
+          <a:lstStyle/>
+          <a:p>
+            <a:pPr algn="ctr"/>
+          </a:p>
+        </p:txBody>
+      </p:sp>
+      <p:sp>
+        <p:nvSpPr>
+          <p:cNvPr id="67" name="Rectangle 66"/>
+          <p:cNvSpPr/>
+          <p:nvPr/>
+        </p:nvSpPr>
+        <p:spPr>
+          <a:xfrm>
+            <a:off x="7673069" y="4686300"/>
+            <a:ext cx="1280160" cy="868680"/>
+          </a:xfrm>
+          <a:prstGeom prst="rect">
+            <a:avLst/>
+          </a:prstGeom>
+          <a:solidFill>
+            <a:srgbClr val="1E293B"/>
+          </a:solidFill>
+          <a:ln w="12700">
+            <a:solidFill>
+              <a:srgbClr val="1A2A40"/>
+            </a:solidFill>
+          </a:ln>
+        </p:spPr>
+        <p:style>
+          <a:lnRef idx="1">
+            <a:schemeClr val="accent1"/>
+          </a:lnRef>
+          <a:fillRef idx="3">
+            <a:schemeClr val="accent1"/>
+          </a:fillRef>
+          <a:effectRef idx="2">
+            <a:schemeClr val="accent1"/>
+          </a:effectRef>
+          <a:fontRef idx="minor">
+            <a:schemeClr val="lt1"/>
+          </a:fontRef>
+        </p:style>
+        <p:txBody>
+          <a:bodyPr rtlCol="0" anchor="ctr"/>
+          <a:lstStyle/>
+          <a:p>
+            <a:pPr algn="ctr"/>
+          </a:p>
+        </p:txBody>
+      </p:sp>
+      <p:sp>
+        <p:nvSpPr>
+          <p:cNvPr id="68" name="Oval 67"/>
+          <p:cNvSpPr/>
+          <p:nvPr/>
+        </p:nvSpPr>
+        <p:spPr>
+          <a:xfrm>
+            <a:off x="7746221" y="4759452"/>
+            <a:ext cx="365760" cy="365760"/>
+          </a:xfrm>
+          <a:prstGeom prst="ellipse">
+            <a:avLst/>
+          </a:prstGeom>
+          <a:solidFill>
+            <a:srgbClr val="1E3A5F"/>
+          </a:solidFill>
+          <a:ln w="12700">
+            <a:solidFill>
+              <a:srgbClr val="00D4AA"/>
+            </a:solidFill>
+          </a:ln>
+        </p:spPr>
+        <p:style>
+          <a:lnRef idx="1">
+            <a:schemeClr val="accent1"/>
+          </a:lnRef>
+          <a:fillRef idx="3">
+            <a:schemeClr val="accent1"/>
+          </a:fillRef>
+          <a:effectRef idx="2">
+            <a:schemeClr val="accent1"/>
+          </a:effectRef>
+          <a:fontRef idx="minor">
+            <a:schemeClr val="lt1"/>
+          </a:fontRef>
+        </p:style>
+        <p:txBody>
+          <a:bodyPr rtlCol="0" anchor="ctr"/>
+          <a:lstStyle/>
+          <a:p>
+            <a:pPr algn="ctr"/>
+          </a:p>
+        </p:txBody>
+      </p:sp>
+      <p:sp>
+        <p:nvSpPr>
+          <p:cNvPr id="69" name="TextBox 68"/>
+          <p:cNvSpPr txBox="1"/>
+          <p:nvPr/>
+        </p:nvSpPr>
+        <p:spPr>
+          <a:xfrm>
+            <a:off x="7746221" y="4759452"/>
+            <a:ext cx="365760" cy="365760"/>
+          </a:xfrm>
+          <a:prstGeom prst="rect">
+            <a:avLst/>
+          </a:prstGeom>
+          <a:noFill/>
+        </p:spPr>
+        <p:txBody>
+          <a:bodyPr wrap="square" anchor="ctr"/>
+          <a:lstStyle/>
+          <a:p>
+            <a:pPr algn="ctr">
+              <a:spcBef>
+                <a:spcPts val="0"/>
+              </a:spcBef>
+              <a:spcAft>
+                <a:spcPts val="0"/>
+              </a:spcAft>
+            </a:pPr>
+            <a:r>
+              <a:rPr sz="900" b="1">
+                <a:solidFill>
+                  <a:srgbClr val="00D4AA"/>
+                </a:solidFill>
+                <a:latin typeface="Inter"/>
+              </a:rPr>
+              <a:t>PR</a:t>
+            </a:r>
+          </a:p>
+        </p:txBody>
+      </p:sp>
+      <p:sp>
+        <p:nvSpPr>
+          <p:cNvPr id="70" name="TextBox 69"/>
+          <p:cNvSpPr txBox="1"/>
+          <p:nvPr/>
+        </p:nvSpPr>
+        <p:spPr>
+          <a:xfrm>
+            <a:off x="8130269" y="4732020"/>
+            <a:ext cx="731520" cy="457200"/>
+          </a:xfrm>
+          <a:prstGeom prst="rect">
+            <a:avLst/>
+          </a:prstGeom>
+          <a:noFill/>
+        </p:spPr>
+        <p:txBody>
+          <a:bodyPr wrap="square" anchor="t"/>
+          <a:lstStyle/>
+          <a:p>
+            <a:pPr algn="l">
+              <a:spcBef>
+                <a:spcPts val="0"/>
+              </a:spcBef>
+              <a:spcAft>
+                <a:spcPts val="0"/>
+              </a:spcAft>
+            </a:pPr>
+            <a:r>
+              <a:rPr sz="1000" b="1">
+                <a:solidFill>
+                  <a:srgbClr val="E2E8F0"/>
+                </a:solidFill>
+                <a:latin typeface="Inter"/>
+              </a:rPr>
+              <a:t>PR
+Reviewer</a:t>
+            </a:r>
+          </a:p>
+        </p:txBody>
+      </p:sp>
+      <p:sp>
+        <p:nvSpPr>
+          <p:cNvPr id="71" name="TextBox 70"/>
+          <p:cNvSpPr txBox="1"/>
+          <p:nvPr/>
+        </p:nvSpPr>
+        <p:spPr>
+          <a:xfrm>
+            <a:off x="7746221" y="5280660"/>
+            <a:ext cx="1133856" cy="365760"/>
+          </a:xfrm>
+          <a:prstGeom prst="rect">
+            <a:avLst/>
+          </a:prstGeom>
+          <a:noFill/>
+        </p:spPr>
+        <p:txBody>
+          <a:bodyPr wrap="square" anchor="t"/>
+          <a:lstStyle/>
+          <a:p>
+            <a:pPr algn="ctr">
+              <a:spcBef>
+                <a:spcPts val="0"/>
+              </a:spcBef>
+              <a:spcAft>
+                <a:spcPts val="0"/>
+              </a:spcAft>
+            </a:pPr>
+            <a:r>
+              <a:rPr sz="800" b="0">
+                <a:solidFill>
+                  <a:srgbClr val="64748B"/>
+                </a:solidFill>
+                <a:latin typeface="Inter"/>
+              </a:rPr>
+              <a:t>Headless PR review</a:t>
+            </a:r>
+          </a:p>
+        </p:txBody>
+      </p:sp>
+      <p:sp>
+        <p:nvSpPr>
+          <p:cNvPr id="72" name="Rectangle 71"/>
+          <p:cNvSpPr/>
+          <p:nvPr/>
+        </p:nvSpPr>
+        <p:spPr>
+          <a:xfrm>
+            <a:off x="6095847" y="3840480"/>
+            <a:ext cx="18288" cy="18288"/>
+          </a:xfrm>
+          <a:prstGeom prst="rect">
+            <a:avLst/>
+          </a:prstGeom>
+          <a:noFill/>
+          <a:ln>
+            <a:noFill/>
+          </a:ln>
+        </p:spPr>
+        <p:style>
+          <a:lnRef idx="1">
+            <a:schemeClr val="accent1"/>
+          </a:lnRef>
+          <a:fillRef idx="3">
+            <a:schemeClr val="accent1"/>
+          </a:fillRef>
+          <a:effectRef idx="2">
+            <a:schemeClr val="accent1"/>
+          </a:effectRef>
+          <a:fontRef idx="minor">
+            <a:schemeClr val="lt1"/>
+          </a:fontRef>
+        </p:style>
+        <p:txBody>
+          <a:bodyPr rtlCol="0" anchor="ctr"/>
+          <a:lstStyle/>
+          <a:p>
+            <a:pPr algn="ctr"/>
+          </a:p>
+        </p:txBody>
+      </p:sp>
+      <p:sp>
+        <p:nvSpPr>
+          <p:cNvPr id="73" name="Rectangle 72"/>
+          <p:cNvSpPr/>
+          <p:nvPr/>
+        </p:nvSpPr>
+        <p:spPr>
+          <a:xfrm>
+            <a:off x="8002061" y="3673766"/>
+            <a:ext cx="1280160" cy="868680"/>
+          </a:xfrm>
+          <a:prstGeom prst="rect">
+            <a:avLst/>
+          </a:prstGeom>
+          <a:solidFill>
+            <a:srgbClr val="1E293B"/>
+          </a:solidFill>
+          <a:ln w="12700">
+            <a:solidFill>
+              <a:srgbClr val="1A2A40"/>
+            </a:solidFill>
+          </a:ln>
+        </p:spPr>
+        <p:style>
+          <a:lnRef idx="1">
+            <a:schemeClr val="accent1"/>
+          </a:lnRef>
+          <a:fillRef idx="3">
+            <a:schemeClr val="accent1"/>
+          </a:fillRef>
+          <a:effectRef idx="2">
+            <a:schemeClr val="accent1"/>
+          </a:effectRef>
+          <a:fontRef idx="minor">
+            <a:schemeClr val="lt1"/>
+          </a:fontRef>
+        </p:style>
+        <p:txBody>
+          <a:bodyPr rtlCol="0" anchor="ctr"/>
+          <a:lstStyle/>
+          <a:p>
+            <a:pPr algn="ctr"/>
+          </a:p>
+        </p:txBody>
+      </p:sp>
+      <p:sp>
+        <p:nvSpPr>
+          <p:cNvPr id="74" name="Oval 73"/>
+          <p:cNvSpPr/>
+          <p:nvPr/>
+        </p:nvSpPr>
+        <p:spPr>
+          <a:xfrm>
+            <a:off x="8075213" y="3746918"/>
+            <a:ext cx="365760" cy="365760"/>
+          </a:xfrm>
+          <a:prstGeom prst="ellipse">
+            <a:avLst/>
+          </a:prstGeom>
+          <a:solidFill>
+            <a:srgbClr val="1E3A5F"/>
+          </a:solidFill>
+          <a:ln w="12700">
+            <a:solidFill>
+              <a:srgbClr val="00D4AA"/>
+            </a:solidFill>
+          </a:ln>
+        </p:spPr>
+        <p:style>
+          <a:lnRef idx="1">
+            <a:schemeClr val="accent1"/>
+          </a:lnRef>
+          <a:fillRef idx="3">
+            <a:schemeClr val="accent1"/>
+          </a:fillRef>
+          <a:effectRef idx="2">
+            <a:schemeClr val="accent1"/>
+          </a:effectRef>
+          <a:fontRef idx="minor">
+            <a:schemeClr val="lt1"/>
+          </a:fontRef>
+        </p:style>
+        <p:txBody>
+          <a:bodyPr rtlCol="0" anchor="ctr"/>
+          <a:lstStyle/>
+          <a:p>
+            <a:pPr algn="ctr"/>
+          </a:p>
+        </p:txBody>
+      </p:sp>
+      <p:sp>
+        <p:nvSpPr>
+          <p:cNvPr id="75" name="TextBox 74"/>
+          <p:cNvSpPr txBox="1"/>
+          <p:nvPr/>
+        </p:nvSpPr>
+        <p:spPr>
+          <a:xfrm>
+            <a:off x="8075213" y="3746918"/>
+            <a:ext cx="365760" cy="365760"/>
+          </a:xfrm>
+          <a:prstGeom prst="rect">
+            <a:avLst/>
+          </a:prstGeom>
+          <a:noFill/>
+        </p:spPr>
+        <p:txBody>
+          <a:bodyPr wrap="square" anchor="ctr"/>
+          <a:lstStyle/>
+          <a:p>
+            <a:pPr algn="ctr">
+              <a:spcBef>
+                <a:spcPts val="0"/>
+              </a:spcBef>
+              <a:spcAft>
+                <a:spcPts val="0"/>
+              </a:spcAft>
+            </a:pPr>
+            <a:r>
+              <a:rPr sz="900" b="1">
+                <a:solidFill>
+                  <a:srgbClr val="00D4AA"/>
+                </a:solidFill>
+                <a:latin typeface="Inter"/>
+              </a:rPr>
+              <a:t>DW</a:t>
+            </a:r>
+          </a:p>
+        </p:txBody>
+      </p:sp>
+      <p:sp>
+        <p:nvSpPr>
+          <p:cNvPr id="76" name="TextBox 75"/>
+          <p:cNvSpPr txBox="1"/>
+          <p:nvPr/>
+        </p:nvSpPr>
+        <p:spPr>
+          <a:xfrm>
+            <a:off x="8459261" y="3719486"/>
+            <a:ext cx="731520" cy="457200"/>
+          </a:xfrm>
+          <a:prstGeom prst="rect">
+            <a:avLst/>
+          </a:prstGeom>
+          <a:noFill/>
+        </p:spPr>
+        <p:txBody>
+          <a:bodyPr wrap="square" anchor="t"/>
+          <a:lstStyle/>
+          <a:p>
+            <a:pPr algn="l">
+              <a:spcBef>
+                <a:spcPts val="0"/>
+              </a:spcBef>
+              <a:spcAft>
+                <a:spcPts val="0"/>
+              </a:spcAft>
+            </a:pPr>
+            <a:r>
+              <a:rPr sz="1000" b="1">
+                <a:solidFill>
+                  <a:srgbClr val="E2E8F0"/>
+                </a:solidFill>
+                <a:latin typeface="Inter"/>
+              </a:rPr>
+              <a:t>Docs
+Writer</a:t>
+            </a:r>
+          </a:p>
+        </p:txBody>
+      </p:sp>
+      <p:sp>
+        <p:nvSpPr>
+          <p:cNvPr id="77" name="TextBox 76"/>
+          <p:cNvSpPr txBox="1"/>
+          <p:nvPr/>
+        </p:nvSpPr>
+        <p:spPr>
+          <a:xfrm>
+            <a:off x="8075213" y="4268126"/>
+            <a:ext cx="1133856" cy="365760"/>
+          </a:xfrm>
+          <a:prstGeom prst="rect">
+            <a:avLst/>
+          </a:prstGeom>
+          <a:noFill/>
+        </p:spPr>
+        <p:txBody>
+          <a:bodyPr wrap="square" anchor="t"/>
+          <a:lstStyle/>
+          <a:p>
+            <a:pPr algn="ctr">
+              <a:spcBef>
+                <a:spcPts val="0"/>
+              </a:spcBef>
+              <a:spcAft>
+                <a:spcPts val="0"/>
+              </a:spcAft>
+            </a:pPr>
+            <a:r>
+              <a:rPr sz="800" b="0">
+                <a:solidFill>
+                  <a:srgbClr val="64748B"/>
+                </a:solidFill>
+                <a:latin typeface="Inter"/>
+              </a:rPr>
+              <a:t>Documentation</a:t>
+            </a:r>
+          </a:p>
+        </p:txBody>
+      </p:sp>
+      <p:sp>
+        <p:nvSpPr>
+          <p:cNvPr id="78" name="Rectangle 77"/>
+          <p:cNvSpPr/>
+          <p:nvPr/>
+        </p:nvSpPr>
+        <p:spPr>
+          <a:xfrm>
+            <a:off x="6095847" y="3840480"/>
+            <a:ext cx="18288" cy="18288"/>
+          </a:xfrm>
+          <a:prstGeom prst="rect">
+            <a:avLst/>
+          </a:prstGeom>
+          <a:noFill/>
+          <a:ln>
+            <a:noFill/>
+          </a:ln>
+        </p:spPr>
+        <p:style>
+          <a:lnRef idx="1">
+            <a:schemeClr val="accent1"/>
+          </a:lnRef>
+          <a:fillRef idx="3">
+            <a:schemeClr val="accent1"/>
+          </a:fillRef>
+          <a:effectRef idx="2">
+            <a:schemeClr val="accent1"/>
+          </a:effectRef>
+          <a:fontRef idx="minor">
+            <a:schemeClr val="lt1"/>
+          </a:fontRef>
+        </p:style>
+        <p:txBody>
+          <a:bodyPr rtlCol="0" anchor="ctr"/>
+          <a:lstStyle/>
+          <a:p>
+            <a:pPr algn="ctr"/>
+          </a:p>
+        </p:txBody>
+      </p:sp>
+      <p:sp>
+        <p:nvSpPr>
+          <p:cNvPr id="79" name="Rectangle 78"/>
+          <p:cNvSpPr/>
+          <p:nvPr/>
+        </p:nvSpPr>
+        <p:spPr>
+          <a:xfrm>
+            <a:off x="7890776" y="2614957"/>
+            <a:ext cx="1280160" cy="868680"/>
+          </a:xfrm>
+          <a:prstGeom prst="rect">
+            <a:avLst/>
+          </a:prstGeom>
+          <a:solidFill>
+            <a:srgbClr val="1E293B"/>
+          </a:solidFill>
+          <a:ln w="12700">
+            <a:solidFill>
+              <a:srgbClr val="1A2A40"/>
+            </a:solidFill>
+          </a:ln>
+        </p:spPr>
+        <p:style>
+          <a:lnRef idx="1">
+            <a:schemeClr val="accent1"/>
+          </a:lnRef>
+          <a:fillRef idx="3">
+            <a:schemeClr val="accent1"/>
+          </a:fillRef>
+          <a:effectRef idx="2">
+            <a:schemeClr val="accent1"/>
+          </a:effectRef>
+          <a:fontRef idx="minor">
+            <a:schemeClr val="lt1"/>
+          </a:fontRef>
+        </p:style>
+        <p:txBody>
+          <a:bodyPr rtlCol="0" anchor="ctr"/>
+          <a:lstStyle/>
+          <a:p>
+            <a:pPr algn="ctr"/>
+          </a:p>
+        </p:txBody>
+      </p:sp>
+      <p:sp>
+        <p:nvSpPr>
+          <p:cNvPr id="80" name="Oval 79"/>
+          <p:cNvSpPr/>
+          <p:nvPr/>
+        </p:nvSpPr>
+        <p:spPr>
+          <a:xfrm>
+            <a:off x="7963928" y="2688109"/>
+            <a:ext cx="365760" cy="365760"/>
+          </a:xfrm>
+          <a:prstGeom prst="ellipse">
+            <a:avLst/>
+          </a:prstGeom>
+          <a:solidFill>
+            <a:srgbClr val="1E3A5F"/>
+          </a:solidFill>
+          <a:ln w="12700">
+            <a:solidFill>
+              <a:srgbClr val="00D4AA"/>
+            </a:solidFill>
+          </a:ln>
+        </p:spPr>
+        <p:style>
+          <a:lnRef idx="1">
+            <a:schemeClr val="accent1"/>
+          </a:lnRef>
+          <a:fillRef idx="3">
+            <a:schemeClr val="accent1"/>
+          </a:fillRef>
+          <a:effectRef idx="2">
+            <a:schemeClr val="accent1"/>
+          </a:effectRef>
+          <a:fontRef idx="minor">
+            <a:schemeClr val="lt1"/>
+          </a:fontRef>
+        </p:style>
+        <p:txBody>
+          <a:bodyPr rtlCol="0" anchor="ctr"/>
+          <a:lstStyle/>
+          <a:p>
+            <a:pPr algn="ctr"/>
+          </a:p>
+        </p:txBody>
+      </p:sp>
+      <p:sp>
+        <p:nvSpPr>
+          <p:cNvPr id="81" name="TextBox 80"/>
+          <p:cNvSpPr txBox="1"/>
+          <p:nvPr/>
+        </p:nvSpPr>
+        <p:spPr>
+          <a:xfrm>
+            <a:off x="7963928" y="2688109"/>
+            <a:ext cx="365760" cy="365760"/>
+          </a:xfrm>
+          <a:prstGeom prst="rect">
+            <a:avLst/>
+          </a:prstGeom>
+          <a:noFill/>
+        </p:spPr>
+        <p:txBody>
+          <a:bodyPr wrap="square" anchor="ctr"/>
+          <a:lstStyle/>
+          <a:p>
+            <a:pPr algn="ctr">
+              <a:spcBef>
+                <a:spcPts val="0"/>
+              </a:spcBef>
+              <a:spcAft>
+                <a:spcPts val="0"/>
+              </a:spcAft>
+            </a:pPr>
+            <a:r>
+              <a:rPr sz="900" b="1">
+                <a:solidFill>
+                  <a:srgbClr val="00D4AA"/>
+                </a:solidFill>
+                <a:latin typeface="Inter"/>
+              </a:rPr>
+              <a:t>GS</a:t>
+            </a:r>
+          </a:p>
+        </p:txBody>
+      </p:sp>
+      <p:sp>
+        <p:nvSpPr>
+          <p:cNvPr id="82" name="TextBox 81"/>
+          <p:cNvSpPr txBox="1"/>
+          <p:nvPr/>
+        </p:nvSpPr>
+        <p:spPr>
+          <a:xfrm>
+            <a:off x="8347976" y="2660677"/>
+            <a:ext cx="731520" cy="457200"/>
+          </a:xfrm>
+          <a:prstGeom prst="rect">
+            <a:avLst/>
+          </a:prstGeom>
+          <a:noFill/>
+        </p:spPr>
+        <p:txBody>
+          <a:bodyPr wrap="square" anchor="t"/>
+          <a:lstStyle/>
+          <a:p>
+            <a:pPr algn="l">
+              <a:spcBef>
+                <a:spcPts val="0"/>
+              </a:spcBef>
+              <a:spcAft>
+                <a:spcPts val="0"/>
+              </a:spcAft>
+            </a:pPr>
+            <a:r>
+              <a:rPr sz="1000" b="1">
+                <a:solidFill>
+                  <a:srgbClr val="E2E8F0"/>
+                </a:solidFill>
+                <a:latin typeface="Inter"/>
+              </a:rPr>
+              <a:t>Governance
+Steward</a:t>
+            </a:r>
+          </a:p>
+        </p:txBody>
+      </p:sp>
+      <p:sp>
+        <p:nvSpPr>
+          <p:cNvPr id="83" name="TextBox 82"/>
+          <p:cNvSpPr txBox="1"/>
+          <p:nvPr/>
+        </p:nvSpPr>
+        <p:spPr>
+          <a:xfrm>
+            <a:off x="7963928" y="3209317"/>
+            <a:ext cx="1133856" cy="365760"/>
+          </a:xfrm>
+          <a:prstGeom prst="rect">
+            <a:avLst/>
+          </a:prstGeom>
+          <a:noFill/>
+        </p:spPr>
+        <p:txBody>
+          <a:bodyPr wrap="square" anchor="t"/>
+          <a:lstStyle/>
+          <a:p>
+            <a:pPr algn="ctr">
+              <a:spcBef>
+                <a:spcPts val="0"/>
+              </a:spcBef>
+              <a:spcAft>
+                <a:spcPts val="0"/>
+              </a:spcAft>
+            </a:pPr>
+            <a:r>
+              <a:rPr sz="800" b="0">
+                <a:solidFill>
+                  <a:srgbClr val="64748B"/>
+                </a:solidFill>
+                <a:latin typeface="Inter"/>
+              </a:rPr>
+              <a:t>Gov. lifecycle</a:t>
+            </a:r>
+          </a:p>
+        </p:txBody>
+      </p:sp>
+      <p:sp>
+        <p:nvSpPr>
+          <p:cNvPr id="84" name="Rectangle 83"/>
+          <p:cNvSpPr/>
+          <p:nvPr/>
+        </p:nvSpPr>
+        <p:spPr>
+          <a:xfrm>
+            <a:off x="6095847" y="3840480"/>
+            <a:ext cx="18288" cy="18288"/>
+          </a:xfrm>
+          <a:prstGeom prst="rect">
+            <a:avLst/>
+          </a:prstGeom>
+          <a:noFill/>
+          <a:ln>
+            <a:noFill/>
+          </a:ln>
+        </p:spPr>
+        <p:style>
+          <a:lnRef idx="1">
+            <a:schemeClr val="accent1"/>
+          </a:lnRef>
+          <a:fillRef idx="3">
+            <a:schemeClr val="accent1"/>
+          </a:fillRef>
+          <a:effectRef idx="2">
+            <a:schemeClr val="accent1"/>
+          </a:effectRef>
+          <a:fontRef idx="minor">
+            <a:schemeClr val="lt1"/>
+          </a:fontRef>
+        </p:style>
+        <p:txBody>
+          <a:bodyPr rtlCol="0" anchor="ctr"/>
+          <a:lstStyle/>
+          <a:p>
+            <a:pPr algn="ctr"/>
+          </a:p>
+        </p:txBody>
+      </p:sp>
+      <p:sp>
+        <p:nvSpPr>
+          <p:cNvPr id="85" name="Rectangle 84"/>
+          <p:cNvSpPr/>
+          <p:nvPr/>
+        </p:nvSpPr>
+        <p:spPr>
+          <a:xfrm>
+            <a:off x="7358455" y="1692951"/>
+            <a:ext cx="1280160" cy="868680"/>
+          </a:xfrm>
+          <a:prstGeom prst="rect">
+            <a:avLst/>
+          </a:prstGeom>
+          <a:solidFill>
+            <a:srgbClr val="1E293B"/>
+          </a:solidFill>
+          <a:ln w="12700">
+            <a:solidFill>
+              <a:srgbClr val="1A2A40"/>
+            </a:solidFill>
+          </a:ln>
+        </p:spPr>
+        <p:style>
+          <a:lnRef idx="1">
+            <a:schemeClr val="accent1"/>
+          </a:lnRef>
+          <a:fillRef idx="3">
+            <a:schemeClr val="accent1"/>
+          </a:fillRef>
+          <a:effectRef idx="2">
+            <a:schemeClr val="accent1"/>
+          </a:effectRef>
+          <a:fontRef idx="minor">
+            <a:schemeClr val="lt1"/>
+          </a:fontRef>
+        </p:style>
+        <p:txBody>
+          <a:bodyPr rtlCol="0" anchor="ctr"/>
+          <a:lstStyle/>
+          <a:p>
+            <a:pPr algn="ctr"/>
+          </a:p>
+        </p:txBody>
+      </p:sp>
+      <p:sp>
+        <p:nvSpPr>
+          <p:cNvPr id="86" name="Oval 85"/>
+          <p:cNvSpPr/>
+          <p:nvPr/>
+        </p:nvSpPr>
+        <p:spPr>
+          <a:xfrm>
+            <a:off x="7431607" y="1766103"/>
+            <a:ext cx="365760" cy="365760"/>
+          </a:xfrm>
+          <a:prstGeom prst="ellipse">
+            <a:avLst/>
+          </a:prstGeom>
+          <a:solidFill>
+            <a:srgbClr val="1E3A5F"/>
+          </a:solidFill>
+          <a:ln w="12700">
+            <a:solidFill>
+              <a:srgbClr val="00D4AA"/>
+            </a:solidFill>
+          </a:ln>
+        </p:spPr>
+        <p:style>
+          <a:lnRef idx="1">
+            <a:schemeClr val="accent1"/>
+          </a:lnRef>
+          <a:fillRef idx="3">
+            <a:schemeClr val="accent1"/>
+          </a:fillRef>
+          <a:effectRef idx="2">
+            <a:schemeClr val="accent1"/>
+          </a:effectRef>
+          <a:fontRef idx="minor">
+            <a:schemeClr val="lt1"/>
+          </a:fontRef>
+        </p:style>
+        <p:txBody>
+          <a:bodyPr rtlCol="0" anchor="ctr"/>
+          <a:lstStyle/>
+          <a:p>
+            <a:pPr algn="ctr"/>
+          </a:p>
+        </p:txBody>
+      </p:sp>
+      <p:sp>
+        <p:nvSpPr>
+          <p:cNvPr id="87" name="TextBox 86"/>
+          <p:cNvSpPr txBox="1"/>
+          <p:nvPr/>
+        </p:nvSpPr>
+        <p:spPr>
+          <a:xfrm>
+            <a:off x="7431607" y="1766103"/>
+            <a:ext cx="365760" cy="365760"/>
+          </a:xfrm>
+          <a:prstGeom prst="rect">
+            <a:avLst/>
+          </a:prstGeom>
+          <a:noFill/>
+        </p:spPr>
+        <p:txBody>
+          <a:bodyPr wrap="square" anchor="ctr"/>
+          <a:lstStyle/>
+          <a:p>
+            <a:pPr algn="ctr">
+              <a:spcBef>
+                <a:spcPts val="0"/>
+              </a:spcBef>
+              <a:spcAft>
+                <a:spcPts val="0"/>
+              </a:spcAft>
+            </a:pPr>
+            <a:r>
+              <a:rPr sz="900" b="1">
+                <a:solidFill>
+                  <a:srgbClr val="00D4AA"/>
+                </a:solidFill>
+                <a:latin typeface="Inter"/>
+              </a:rPr>
+              <a:t>NV</a:t>
+            </a:r>
+          </a:p>
+        </p:txBody>
+      </p:sp>
+      <p:sp>
+        <p:nvSpPr>
+          <p:cNvPr id="88" name="TextBox 87"/>
+          <p:cNvSpPr txBox="1"/>
+          <p:nvPr/>
+        </p:nvSpPr>
+        <p:spPr>
+          <a:xfrm>
+            <a:off x="7815655" y="1738671"/>
+            <a:ext cx="731520" cy="457200"/>
+          </a:xfrm>
+          <a:prstGeom prst="rect">
+            <a:avLst/>
+          </a:prstGeom>
+          <a:noFill/>
+        </p:spPr>
+        <p:txBody>
+          <a:bodyPr wrap="square" anchor="t"/>
+          <a:lstStyle/>
+          <a:p>
+            <a:pPr algn="l">
+              <a:spcBef>
+                <a:spcPts val="0"/>
+              </a:spcBef>
+              <a:spcAft>
+                <a:spcPts val="0"/>
+              </a:spcAft>
+            </a:pPr>
+            <a:r>
+              <a:rPr sz="1000" b="1">
+                <a:solidFill>
+                  <a:srgbClr val="E2E8F0"/>
+                </a:solidFill>
+                <a:latin typeface="Inter"/>
+              </a:rPr>
+              <a:t>Navigator</a:t>
+            </a:r>
+          </a:p>
+        </p:txBody>
+      </p:sp>
+      <p:sp>
+        <p:nvSpPr>
+          <p:cNvPr id="89" name="TextBox 88"/>
+          <p:cNvSpPr txBox="1"/>
+          <p:nvPr/>
+        </p:nvSpPr>
+        <p:spPr>
+          <a:xfrm>
+            <a:off x="7431607" y="2287311"/>
+            <a:ext cx="1133856" cy="365760"/>
+          </a:xfrm>
+          <a:prstGeom prst="rect">
+            <a:avLst/>
+          </a:prstGeom>
+          <a:noFill/>
+        </p:spPr>
+        <p:txBody>
+          <a:bodyPr wrap="square" anchor="t"/>
+          <a:lstStyle/>
+          <a:p>
+            <a:pPr algn="ctr">
+              <a:spcBef>
+                <a:spcPts val="0"/>
+              </a:spcBef>
+              <a:spcAft>
+                <a:spcPts val="0"/>
+              </a:spcAft>
+            </a:pPr>
+            <a:r>
+              <a:rPr sz="800" b="0">
+                <a:solidFill>
+                  <a:srgbClr val="64748B"/>
+                </a:solidFill>
+                <a:latin typeface="Inter"/>
+              </a:rPr>
+              <a:t>Strategic analysis</a:t>
+            </a:r>
+          </a:p>
+        </p:txBody>
+      </p:sp>
+      <p:sp>
+        <p:nvSpPr>
+          <p:cNvPr id="90" name="Rectangle 89"/>
+          <p:cNvSpPr/>
+          <p:nvPr/>
+        </p:nvSpPr>
+        <p:spPr>
+          <a:xfrm>
+            <a:off x="6095847" y="3840480"/>
+            <a:ext cx="18288" cy="18288"/>
+          </a:xfrm>
+          <a:prstGeom prst="rect">
+            <a:avLst/>
+          </a:prstGeom>
+          <a:noFill/>
+          <a:ln>
+            <a:noFill/>
+          </a:ln>
+        </p:spPr>
+        <p:style>
+          <a:lnRef idx="1">
+            <a:schemeClr val="accent1"/>
+          </a:lnRef>
+          <a:fillRef idx="3">
+            <a:schemeClr val="accent1"/>
+          </a:fillRef>
+          <a:effectRef idx="2">
+            <a:schemeClr val="accent1"/>
+          </a:effectRef>
+          <a:fontRef idx="minor">
+            <a:schemeClr val="lt1"/>
+          </a:fontRef>
+        </p:style>
+        <p:txBody>
+          <a:bodyPr rtlCol="0" anchor="ctr"/>
+          <a:lstStyle/>
+          <a:p>
+            <a:pPr algn="ctr"/>
+          </a:p>
+        </p:txBody>
+      </p:sp>
+      <p:sp>
+        <p:nvSpPr>
+          <p:cNvPr id="91" name="Rectangle 90"/>
+          <p:cNvSpPr/>
+          <p:nvPr/>
+        </p:nvSpPr>
+        <p:spPr>
+          <a:xfrm>
+            <a:off x="6497142" y="1067171"/>
+            <a:ext cx="1280160" cy="868680"/>
+          </a:xfrm>
+          <a:prstGeom prst="rect">
+            <a:avLst/>
+          </a:prstGeom>
+          <a:solidFill>
+            <a:srgbClr val="1E293B"/>
+          </a:solidFill>
+          <a:ln w="12700">
+            <a:solidFill>
+              <a:srgbClr val="1A2A40"/>
+            </a:solidFill>
+          </a:ln>
+        </p:spPr>
+        <p:style>
+          <a:lnRef idx="1">
+            <a:schemeClr val="accent1"/>
+          </a:lnRef>
+          <a:fillRef idx="3">
+            <a:schemeClr val="accent1"/>
+          </a:fillRef>
+          <a:effectRef idx="2">
+            <a:schemeClr val="accent1"/>
+          </a:effectRef>
+          <a:fontRef idx="minor">
+            <a:schemeClr val="lt1"/>
+          </a:fontRef>
+        </p:style>
+        <p:txBody>
+          <a:bodyPr rtlCol="0" anchor="ctr"/>
+          <a:lstStyle/>
+          <a:p>
+            <a:pPr algn="ctr"/>
+          </a:p>
+        </p:txBody>
+      </p:sp>
+      <p:sp>
+        <p:nvSpPr>
+          <p:cNvPr id="92" name="Oval 91"/>
+          <p:cNvSpPr/>
+          <p:nvPr/>
+        </p:nvSpPr>
+        <p:spPr>
+          <a:xfrm>
+            <a:off x="6570294" y="1140323"/>
+            <a:ext cx="365760" cy="365760"/>
+          </a:xfrm>
+          <a:prstGeom prst="ellipse">
+            <a:avLst/>
+          </a:prstGeom>
+          <a:solidFill>
+            <a:srgbClr val="1E3A5F"/>
+          </a:solidFill>
+          <a:ln w="12700">
+            <a:solidFill>
+              <a:srgbClr val="00D4AA"/>
+            </a:solidFill>
+          </a:ln>
+        </p:spPr>
+        <p:style>
+          <a:lnRef idx="1">
+            <a:schemeClr val="accent1"/>
+          </a:lnRef>
+          <a:fillRef idx="3">
+            <a:schemeClr val="accent1"/>
+          </a:fillRef>
+          <a:effectRef idx="2">
+            <a:schemeClr val="accent1"/>
+          </a:effectRef>
+          <a:fontRef idx="minor">
+            <a:schemeClr val="lt1"/>
+          </a:fontRef>
+        </p:style>
+        <p:txBody>
+          <a:bodyPr rtlCol="0" anchor="ctr"/>
+          <a:lstStyle/>
+          <a:p>
+            <a:pPr algn="ctr"/>
+          </a:p>
+        </p:txBody>
+      </p:sp>
+      <p:sp>
+        <p:nvSpPr>
+          <p:cNvPr id="93" name="TextBox 92"/>
+          <p:cNvSpPr txBox="1"/>
+          <p:nvPr/>
+        </p:nvSpPr>
+        <p:spPr>
+          <a:xfrm>
+            <a:off x="6570294" y="1140323"/>
+            <a:ext cx="365760" cy="365760"/>
+          </a:xfrm>
+          <a:prstGeom prst="rect">
+            <a:avLst/>
+          </a:prstGeom>
+          <a:noFill/>
+        </p:spPr>
+        <p:txBody>
+          <a:bodyPr wrap="square" anchor="ctr"/>
+          <a:lstStyle/>
+          <a:p>
+            <a:pPr algn="ctr">
+              <a:spcBef>
+                <a:spcPts val="0"/>
+              </a:spcBef>
+              <a:spcAft>
+                <a:spcPts val="0"/>
+              </a:spcAft>
+            </a:pPr>
+            <a:r>
+              <a:rPr sz="900" b="1">
+                <a:solidFill>
+                  <a:srgbClr val="00D4AA"/>
+                </a:solidFill>
+                <a:latin typeface="Inter"/>
+              </a:rPr>
+              <a:t>PA</a:t>
+            </a:r>
+          </a:p>
+        </p:txBody>
+      </p:sp>
+      <p:sp>
+        <p:nvSpPr>
+          <p:cNvPr id="94" name="TextBox 93"/>
+          <p:cNvSpPr txBox="1"/>
+          <p:nvPr/>
+        </p:nvSpPr>
+        <p:spPr>
+          <a:xfrm>
+            <a:off x="6954342" y="1112891"/>
+            <a:ext cx="731520" cy="457200"/>
+          </a:xfrm>
+          <a:prstGeom prst="rect">
+            <a:avLst/>
+          </a:prstGeom>
+          <a:noFill/>
+        </p:spPr>
+        <p:txBody>
+          <a:bodyPr wrap="square" anchor="t"/>
+          <a:lstStyle/>
+          <a:p>
+            <a:pPr algn="l">
+              <a:spcBef>
+                <a:spcPts val="0"/>
+              </a:spcBef>
+              <a:spcAft>
+                <a:spcPts val="0"/>
+              </a:spcAft>
+            </a:pPr>
+            <a:r>
+              <a:rPr sz="1000" b="1">
+                <a:solidFill>
+                  <a:srgbClr val="E2E8F0"/>
+                </a:solidFill>
+                <a:latin typeface="Inter"/>
+              </a:rPr>
+              <a:t>Platform
+Auditor</a:t>
+            </a:r>
+          </a:p>
+        </p:txBody>
+      </p:sp>
+      <p:sp>
+        <p:nvSpPr>
+          <p:cNvPr id="95" name="TextBox 94"/>
+          <p:cNvSpPr txBox="1"/>
+          <p:nvPr/>
+        </p:nvSpPr>
+        <p:spPr>
+          <a:xfrm>
+            <a:off x="6570294" y="1661531"/>
+            <a:ext cx="1133856" cy="365760"/>
+          </a:xfrm>
+          <a:prstGeom prst="rect">
+            <a:avLst/>
+          </a:prstGeom>
+          <a:noFill/>
+        </p:spPr>
+        <p:txBody>
+          <a:bodyPr wrap="square" anchor="t"/>
+          <a:lstStyle/>
+          <a:p>
+            <a:pPr algn="ctr">
+              <a:spcBef>
+                <a:spcPts val="0"/>
+              </a:spcBef>
+              <a:spcAft>
+                <a:spcPts val="0"/>
+              </a:spcAft>
+            </a:pPr>
+            <a:r>
+              <a:rPr sz="800" b="0">
+                <a:solidFill>
+                  <a:srgbClr val="64748B"/>
+                </a:solidFill>
+                <a:latin typeface="Inter"/>
+              </a:rPr>
+              <a:t>Full-spectrum audit</a:t>
             </a:r>
           </a:p>
         </p:txBody>

</xml_diff>

<commit_message>
docs: user-centric README rewrite + presentation refresh (#56)
* docs: user-centric README rewrite + presentation refresh

Rewrite README with OpenClaw-inspired progressive disclosure pattern:
value proposition upfront, install in first 4 lines, governance root
explained from user perspective (standards, skills, agents, context,
state). CLI reference extracted to docs/cli-reference.md.

Update docs/presentation with correct numbers across all layers:
speech-script.md, generate_pptx.py, 4 SVGs, and regenerated PPTX.
Key corrections: 45 skills (was 31), 15 agents (was 8), 60 commands
(was 37), coverage 90% (was 80%).

Co-Authored-By: Claude Opus 4.6 <noreply@anthropic.com>

Ai-Eng-Gate: passed

* chore: add gate trailer follow-up

Ai-Eng-Gate: passed
</commit_message>
<xml_diff>
--- a/docs/presentation/ai-engineering-board.pptx
+++ b/docs/presentation/ai-engineering-board.pptx
@@ -723,12 +723,12 @@
           </a:p>
           <a:p>
             <a:r>
-              <a:t>- decision-store.json: 10 real decisions with SHA-256 context hash.</a:t>
-            </a:r>
-          </a:p>
-          <a:p>
-            <a:r>
-              <a:t>- audit-log.ndjson: 183 recorded events.</a:t>
+              <a:t>- decision-store.json: 17 real decisions with SHA-256 context hash.</a:t>
+            </a:r>
+          </a:p>
+          <a:p>
+            <a:r>
+              <a:t>- audit-log.ndjson: 185 recorded events.</a:t>
             </a:r>
           </a:p>
           <a:p/>
@@ -825,7 +825,7 @@
           <a:p/>
           <a:p>
             <a:r>
-              <a:t>Thresholds: Coverage &gt;=80%, Duplication &lt;=3%, CC &lt;=10, CogC &lt;=15.</a:t>
+              <a:t>Thresholds: Coverage &gt;=90%, Duplication &lt;=3%, CC &lt;=10, CogC &lt;=15.</a:t>
             </a:r>
           </a:p>
           <a:p/>
@@ -906,12 +906,12 @@
           </a:p>
           <a:p>
             <a:r>
-              <a:t>- Engineers: 37 slash commands, quality gates before push.</a:t>
-            </a:r>
-          </a:p>
-          <a:p>
-            <a:r>
-              <a:t>- Governance/Compliance: audit-log with 183 traceable events, decision store with 10 decisions.</a:t>
+              <a:t>- Engineers: 60 slash commands, quality gates before push.</a:t>
+            </a:r>
+          </a:p>
+          <a:p>
+            <a:r>
+              <a:t>- Governance/Compliance: audit-log with 185 traceable events, decision store with 17 decisions.</a:t>
             </a:r>
           </a:p>
           <a:p>
@@ -1097,12 +1097,12 @@
           <a:p/>
           <a:p>
             <a:r>
-              <a:t>Claude Code: CLAUDE.md + 37 slash commands.</a:t>
-            </a:r>
-          </a:p>
-          <a:p>
-            <a:r>
-              <a:t>Copilot: copilot-instructions.md + prompts in .github/copilot/.</a:t>
+              <a:t>Claude Code: CLAUDE.md + 60 slash commands.</a:t>
+            </a:r>
+          </a:p>
+          <a:p>
+            <a:r>
+              <a:t>Copilot: copilot-instructions.md + 45 prompt files in .github/prompts/ + 15 custom agents in .github/agents/.</a:t>
             </a:r>
           </a:p>
           <a:p>
@@ -1882,12 +1882,12 @@
           </a:p>
           <a:p>
             <a:r>
-              <a:t>- skills/ — 31 reusable procedures in 7 categories.</a:t>
-            </a:r>
-          </a:p>
-          <a:p>
-            <a:r>
-              <a:t>- agents/ — 8 specialized personas.</a:t>
+              <a:t>- skills/ — 45 reusable procedures in 6 categories.</a:t>
+            </a:r>
+          </a:p>
+          <a:p>
+            <a:r>
+              <a:t>- agents/ — 15 specialized personas.</a:t>
             </a:r>
           </a:p>
           <a:p>
@@ -1909,7 +1909,7 @@
           <a:p/>
           <a:p>
             <a:r>
-              <a:t>Works with Claude Code (37 slash commands), GitHub Copilot, OpenAI Codex.</a:t>
+              <a:t>Works with Claude Code (60 slash commands), GitHub Copilot (45 prompt files + 15 custom agents), OpenAI Codex.</a:t>
             </a:r>
           </a:p>
           <a:p>
@@ -2190,42 +2190,37 @@
           <a:lstStyle/>
           <a:p>
             <a:r>
-              <a:t>31 skills organized in 7 categories:</a:t>
-            </a:r>
-          </a:p>
-          <a:p>
-            <a:r>
-              <a:t>- Workflows (4): commit, PR, acho, pre-implementation.</a:t>
-            </a:r>
-          </a:p>
-          <a:p>
-            <a:r>
-              <a:t>- Dev (6): debug, refactor, code review, test strategy, migration, deps.</a:t>
-            </a:r>
-          </a:p>
-          <a:p>
-            <a:r>
-              <a:t>- Review (3): architecture, performance, security.</a:t>
-            </a:r>
-          </a:p>
-          <a:p>
-            <a:r>
-              <a:t>- Docs (4): changelog, explain, writer, prompt design.</a:t>
-            </a:r>
-          </a:p>
-          <a:p>
-            <a:r>
-              <a:t>- Govern (9): create/delete specs, skills, agents + risk lifecycle.</a:t>
-            </a:r>
-          </a:p>
-          <a:p>
-            <a:r>
-              <a:t>- Quality (3): audit code, audit report, install check.</a:t>
-            </a:r>
-          </a:p>
-          <a:p>
-            <a:r>
-              <a:t>- Utils (3): git helpers, platform detection, Python patterns.</a:t>
+              <a:t>45 skills organized in 6 categories:</a:t>
+            </a:r>
+          </a:p>
+          <a:p>
+            <a:r>
+              <a:t>- Workflows (6): commit, PR, acho, pre-implementation, cleanup, self-improve.</a:t>
+            </a:r>
+          </a:p>
+          <a:p>
+            <a:r>
+              <a:t>- Dev (10): debug, refactor, code review, test runner, test strategy, migration, deps, data modeling, CI/CD generation, multi-agent.</a:t>
+            </a:r>
+          </a:p>
+          <a:p>
+            <a:r>
+              <a:t>- Review (6): architecture, performance, security, data security, DAST, container security.</a:t>
+            </a:r>
+          </a:p>
+          <a:p>
+            <a:r>
+              <a:t>- Docs (5): changelog, explain, writer, simplify, prompt design.</a:t>
+            </a:r>
+          </a:p>
+          <a:p>
+            <a:r>
+              <a:t>- Govern (12): create/delete specs, skills, agents + integrity check, contract compliance, ownership audit, adaptive standards + risk lifecycle.</a:t>
+            </a:r>
+          </a:p>
+          <a:p>
+            <a:r>
+              <a:t>- Quality (6): audit code, docs audit, install check, release gate, SBOM, test gap analysis.</a:t>
             </a:r>
           </a:p>
           <a:p/>
@@ -2301,47 +2296,38 @@
           <a:lstStyle/>
           <a:p>
             <a:r>
-              <a:t>8 specialized agents:</a:t>
-            </a:r>
-          </a:p>
-          <a:p>
-            <a:r>
-              <a:t>- Principal Engineer: senior code review.</a:t>
-            </a:r>
-          </a:p>
-          <a:p>
-            <a:r>
-              <a:t>- Architect: architectural analysis.</a:t>
-            </a:r>
-          </a:p>
-          <a:p>
-            <a:r>
-              <a:t>- Security Reviewer: security assessment.</a:t>
-            </a:r>
-          </a:p>
-          <a:p>
-            <a:r>
-              <a:t>- Debugger: systematic diagnosis.</a:t>
-            </a:r>
-          </a:p>
-          <a:p>
-            <a:r>
-              <a:t>- Quality Auditor: quality gate enforcement.</a:t>
-            </a:r>
-          </a:p>
-          <a:p>
-            <a:r>
-              <a:t>- Verify App: end-to-end verification.</a:t>
-            </a:r>
-          </a:p>
-          <a:p>
-            <a:r>
-              <a:t>- Codebase Mapper: structure mapping.</a:t>
-            </a:r>
-          </a:p>
-          <a:p>
-            <a:r>
-              <a:t>- Code Simplifier: complexity reduction.</a:t>
+              <a:t>15 specialized agents organized by function:</a:t>
+            </a:r>
+          </a:p>
+          <a:p/>
+          <a:p>
+            <a:r>
+              <a:t>Code quality: Principal Engineer, Code Simplifier, Quality Auditor.</a:t>
+            </a:r>
+          </a:p>
+          <a:p>
+            <a:r>
+              <a:t>Architecture &amp; design: Architect, Navigator.</a:t>
+            </a:r>
+          </a:p>
+          <a:p>
+            <a:r>
+              <a:t>Security: Security Reviewer.</a:t>
+            </a:r>
+          </a:p>
+          <a:p>
+            <a:r>
+              <a:t>Testing &amp; verification: Test Master, Verify App, Debugger.</a:t>
+            </a:r>
+          </a:p>
+          <a:p>
+            <a:r>
+              <a:t>Delivery &amp; ops: Orchestrator, DevOps Engineer, PR Reviewer.</a:t>
+            </a:r>
+          </a:p>
+          <a:p>
+            <a:r>
+              <a:t>Documentation &amp; governance: Docs Writer, Governance Steward, Platform Auditor.</a:t>
             </a:r>
           </a:p>
           <a:p/>
@@ -9202,54 +9188,14 @@
                 </a:solidFill>
                 <a:latin typeface="Inter"/>
               </a:rPr>
-              <a:t>≥ 80%</a:t>
-            </a:r>
-          </a:p>
-        </p:txBody>
-      </p:sp>
-      <p:sp>
-        <p:nvSpPr>
-          <p:cNvPr id="22" name="TextBox 21"/>
-          <p:cNvSpPr txBox="1"/>
-          <p:nvPr/>
-        </p:nvSpPr>
-        <p:spPr>
-          <a:xfrm>
-            <a:off x="1706727" y="4498848"/>
-            <a:ext cx="1920240" cy="182880"/>
-          </a:xfrm>
-          <a:prstGeom prst="rect">
-            <a:avLst/>
-          </a:prstGeom>
-          <a:noFill/>
-        </p:spPr>
-        <p:txBody>
-          <a:bodyPr wrap="square" anchor="t"/>
-          <a:lstStyle/>
-          <a:p>
-            <a:pPr algn="ctr">
-              <a:spcBef>
-                <a:spcPts val="0"/>
-              </a:spcBef>
-              <a:spcAft>
-                <a:spcPts val="0"/>
-              </a:spcAft>
-            </a:pPr>
-            <a:r>
-              <a:rPr sz="800" b="0">
-                <a:solidFill>
-                  <a:srgbClr val="94A3B8"/>
-                </a:solidFill>
-                <a:latin typeface="Inter"/>
-              </a:rPr>
-              <a:t>(≥90% gov-critical)</a:t>
-            </a:r>
-          </a:p>
-        </p:txBody>
-      </p:sp>
-      <p:sp>
-        <p:nvSpPr>
-          <p:cNvPr id="23" name="Rectangle 22"/>
+              <a:t>≥ 90%</a:t>
+            </a:r>
+          </a:p>
+        </p:txBody>
+      </p:sp>
+      <p:sp>
+        <p:nvSpPr>
+          <p:cNvPr id="22" name="Rectangle 21"/>
           <p:cNvSpPr/>
           <p:nvPr/>
         </p:nvSpPr>
@@ -9292,7 +9238,7 @@
       </p:sp>
       <p:sp>
         <p:nvSpPr>
-          <p:cNvPr id="24" name="TextBox 23"/>
+          <p:cNvPr id="23" name="TextBox 22"/>
           <p:cNvSpPr txBox="1"/>
           <p:nvPr/>
         </p:nvSpPr>
@@ -9332,7 +9278,7 @@
       </p:sp>
       <p:sp>
         <p:nvSpPr>
-          <p:cNvPr id="25" name="TextBox 24"/>
+          <p:cNvPr id="24" name="TextBox 23"/>
           <p:cNvSpPr txBox="1"/>
           <p:nvPr/>
         </p:nvSpPr>
@@ -9372,7 +9318,7 @@
       </p:sp>
       <p:sp>
         <p:nvSpPr>
-          <p:cNvPr id="26" name="Rectangle 25"/>
+          <p:cNvPr id="25" name="Rectangle 24"/>
           <p:cNvSpPr/>
           <p:nvPr/>
         </p:nvSpPr>
@@ -9415,7 +9361,7 @@
       </p:sp>
       <p:sp>
         <p:nvSpPr>
-          <p:cNvPr id="27" name="TextBox 26"/>
+          <p:cNvPr id="26" name="TextBox 25"/>
           <p:cNvSpPr txBox="1"/>
           <p:nvPr/>
         </p:nvSpPr>
@@ -9455,7 +9401,7 @@
       </p:sp>
       <p:sp>
         <p:nvSpPr>
-          <p:cNvPr id="28" name="TextBox 27"/>
+          <p:cNvPr id="27" name="TextBox 26"/>
           <p:cNvSpPr txBox="1"/>
           <p:nvPr/>
         </p:nvSpPr>
@@ -9495,7 +9441,7 @@
       </p:sp>
       <p:sp>
         <p:nvSpPr>
-          <p:cNvPr id="29" name="TextBox 28"/>
+          <p:cNvPr id="28" name="TextBox 27"/>
           <p:cNvSpPr txBox="1"/>
           <p:nvPr/>
         </p:nvSpPr>
@@ -9535,7 +9481,7 @@
       </p:sp>
       <p:sp>
         <p:nvSpPr>
-          <p:cNvPr id="30" name="Rectangle 29"/>
+          <p:cNvPr id="29" name="Rectangle 28"/>
           <p:cNvSpPr/>
           <p:nvPr/>
         </p:nvSpPr>
@@ -9578,7 +9524,7 @@
       </p:sp>
       <p:sp>
         <p:nvSpPr>
-          <p:cNvPr id="31" name="TextBox 30"/>
+          <p:cNvPr id="30" name="TextBox 29"/>
           <p:cNvSpPr txBox="1"/>
           <p:nvPr/>
         </p:nvSpPr>
@@ -9618,7 +9564,7 @@
       </p:sp>
       <p:sp>
         <p:nvSpPr>
-          <p:cNvPr id="32" name="TextBox 31"/>
+          <p:cNvPr id="31" name="TextBox 30"/>
           <p:cNvSpPr txBox="1"/>
           <p:nvPr/>
         </p:nvSpPr>
@@ -9658,7 +9604,7 @@
       </p:sp>
       <p:sp>
         <p:nvSpPr>
-          <p:cNvPr id="33" name="TextBox 32"/>
+          <p:cNvPr id="32" name="TextBox 31"/>
           <p:cNvSpPr txBox="1"/>
           <p:nvPr/>
         </p:nvSpPr>
@@ -9698,7 +9644,7 @@
       </p:sp>
       <p:sp>
         <p:nvSpPr>
-          <p:cNvPr id="34" name="Rectangle 33"/>
+          <p:cNvPr id="33" name="Rectangle 32"/>
           <p:cNvSpPr/>
           <p:nvPr/>
         </p:nvSpPr>
@@ -9743,7 +9689,7 @@
       </p:sp>
       <p:sp>
         <p:nvSpPr>
-          <p:cNvPr id="35" name="Rectangle 34"/>
+          <p:cNvPr id="34" name="Rectangle 33"/>
           <p:cNvSpPr/>
           <p:nvPr/>
         </p:nvSpPr>
@@ -9786,7 +9732,7 @@
       </p:sp>
       <p:sp>
         <p:nvSpPr>
-          <p:cNvPr id="36" name="TextBox 35"/>
+          <p:cNvPr id="35" name="TextBox 34"/>
           <p:cNvSpPr txBox="1"/>
           <p:nvPr/>
         </p:nvSpPr>
@@ -9826,7 +9772,7 @@
       </p:sp>
       <p:sp>
         <p:nvSpPr>
-          <p:cNvPr id="37" name="TextBox 36"/>
+          <p:cNvPr id="36" name="TextBox 35"/>
           <p:cNvSpPr txBox="1"/>
           <p:nvPr/>
         </p:nvSpPr>
@@ -9866,7 +9812,7 @@
       </p:sp>
       <p:sp>
         <p:nvSpPr>
-          <p:cNvPr id="38" name="Rectangle 37"/>
+          <p:cNvPr id="37" name="Rectangle 36"/>
           <p:cNvSpPr/>
           <p:nvPr/>
         </p:nvSpPr>
@@ -9911,7 +9857,7 @@
       </p:sp>
       <p:sp>
         <p:nvSpPr>
-          <p:cNvPr id="39" name="Rectangle 38"/>
+          <p:cNvPr id="38" name="Rectangle 37"/>
           <p:cNvSpPr/>
           <p:nvPr/>
         </p:nvSpPr>
@@ -9954,7 +9900,7 @@
       </p:sp>
       <p:sp>
         <p:nvSpPr>
-          <p:cNvPr id="40" name="TextBox 39"/>
+          <p:cNvPr id="39" name="TextBox 38"/>
           <p:cNvSpPr txBox="1"/>
           <p:nvPr/>
         </p:nvSpPr>
@@ -9994,7 +9940,7 @@
       </p:sp>
       <p:sp>
         <p:nvSpPr>
-          <p:cNvPr id="41" name="TextBox 40"/>
+          <p:cNvPr id="40" name="TextBox 39"/>
           <p:cNvSpPr txBox="1"/>
           <p:nvPr/>
         </p:nvSpPr>
@@ -10034,7 +9980,7 @@
       </p:sp>
       <p:sp>
         <p:nvSpPr>
-          <p:cNvPr id="42" name="Rectangle 41"/>
+          <p:cNvPr id="41" name="Rectangle 40"/>
           <p:cNvSpPr/>
           <p:nvPr/>
         </p:nvSpPr>
@@ -10079,7 +10025,7 @@
       </p:sp>
       <p:sp>
         <p:nvSpPr>
-          <p:cNvPr id="43" name="Rectangle 42"/>
+          <p:cNvPr id="42" name="Rectangle 41"/>
           <p:cNvSpPr/>
           <p:nvPr/>
         </p:nvSpPr>
@@ -10122,7 +10068,7 @@
       </p:sp>
       <p:sp>
         <p:nvSpPr>
-          <p:cNvPr id="44" name="TextBox 43"/>
+          <p:cNvPr id="43" name="TextBox 42"/>
           <p:cNvSpPr txBox="1"/>
           <p:nvPr/>
         </p:nvSpPr>
@@ -10162,7 +10108,7 @@
       </p:sp>
       <p:sp>
         <p:nvSpPr>
-          <p:cNvPr id="45" name="TextBox 44"/>
+          <p:cNvPr id="44" name="TextBox 43"/>
           <p:cNvSpPr txBox="1"/>
           <p:nvPr/>
         </p:nvSpPr>
@@ -10202,7 +10148,7 @@
       </p:sp>
       <p:sp>
         <p:nvSpPr>
-          <p:cNvPr id="46" name="Rectangle 45"/>
+          <p:cNvPr id="45" name="Rectangle 44"/>
           <p:cNvSpPr/>
           <p:nvPr/>
         </p:nvSpPr>
@@ -10247,7 +10193,7 @@
       </p:sp>
       <p:sp>
         <p:nvSpPr>
-          <p:cNvPr id="47" name="Rectangle 46"/>
+          <p:cNvPr id="46" name="Rectangle 45"/>
           <p:cNvSpPr/>
           <p:nvPr/>
         </p:nvSpPr>
@@ -10290,7 +10236,7 @@
       </p:sp>
       <p:sp>
         <p:nvSpPr>
-          <p:cNvPr id="48" name="TextBox 47"/>
+          <p:cNvPr id="47" name="TextBox 46"/>
           <p:cNvSpPr txBox="1"/>
           <p:nvPr/>
         </p:nvSpPr>
@@ -10330,7 +10276,7 @@
       </p:sp>
       <p:sp>
         <p:nvSpPr>
-          <p:cNvPr id="49" name="TextBox 48"/>
+          <p:cNvPr id="48" name="TextBox 47"/>
           <p:cNvSpPr txBox="1"/>
           <p:nvPr/>
         </p:nvSpPr>
@@ -10604,7 +10550,7 @@
                           </a:solidFill>
                           <a:latin typeface="Inter"/>
                         </a:rPr>
-                        <a:t>Fast workflows — 37 slash commands</a:t>
+                        <a:t>Fast workflows — 60 slash commands</a:t>
                       </a:r>
                     </a:p>
                   </a:txBody>
@@ -10667,7 +10613,7 @@
                           </a:solidFill>
                           <a:latin typeface="Inter"/>
                         </a:rPr>
-                        <a:t>audit-log with 183 traceable events</a:t>
+                        <a:t>audit-log with 185 traceable events</a:t>
                       </a:r>
                     </a:p>
                   </a:txBody>
@@ -10690,7 +10636,7 @@
                           </a:solidFill>
                           <a:latin typeface="Inter"/>
                         </a:rPr>
-                        <a:t>Decision store with 10 decisions</a:t>
+                        <a:t>Decision store with 17 decisions</a:t>
                       </a:r>
                     </a:p>
                   </a:txBody>
@@ -12194,7 +12140,7 @@
                 <a:latin typeface="Inter"/>
               </a:rPr>
               <a:t>CLAUDE.md
-37 slash commands
+60 slash commands
 .claude/commands/</a:t>
             </a:r>
           </a:p>
@@ -12364,7 +12310,7 @@
                 <a:latin typeface="Inter"/>
               </a:rPr>
               <a:t>copilot-instructions.md
-.github/copilot/</a:t>
+.github/prompts/ + .github/agents/</a:t>
             </a:r>
           </a:p>
         </p:txBody>
@@ -19792,8 +19738,8 @@
                 </a:solidFill>
                 <a:latin typeface="Inter"/>
               </a:rPr>
-              <a:t>31 procedures
-in 7 categories</a:t>
+              <a:t>45 procedures
+in 6 categories</a:t>
             </a:r>
           </a:p>
         </p:txBody>
@@ -19916,7 +19862,7 @@
                 </a:solidFill>
                 <a:latin typeface="Inter"/>
               </a:rPr>
-              <a:t>8 specialized
+              <a:t>15 specialized
 personas</a:t>
             </a:r>
           </a:p>
@@ -20374,7 +20320,7 @@
                 <a:latin typeface="Inter"/>
               </a:rPr>
               <a:t>CLAUDE.md
-37 slash commands</a:t>
+60 slash commands</a:t>
             </a:r>
           </a:p>
         </p:txBody>
@@ -20500,7 +20446,7 @@
                 <a:latin typeface="Inter"/>
               </a:rPr>
               <a:t>copilot-instructions.md
-.github/copilot/</a:t>
+45 prompts + 15 agents</a:t>
             </a:r>
           </a:p>
         </p:txBody>
@@ -23422,7 +23368,7 @@
                 </a:solidFill>
                 <a:latin typeface="JetBrains Mono"/>
               </a:rPr>
-              <a:t>Skills: 31 Reusable Procedures</a:t>
+              <a:t>Skills: 45 Reusable Procedures</a:t>
             </a:r>
           </a:p>
         </p:txBody>
@@ -23590,7 +23536,7 @@
                 </a:solidFill>
                 <a:latin typeface="Inter"/>
               </a:rPr>
-              <a:t>4</a:t>
+              <a:t>6</a:t>
             </a:r>
           </a:p>
         </p:txBody>
@@ -23670,8 +23616,8 @@
                 </a:solidFill>
                 <a:latin typeface="Inter"/>
               </a:rPr>
-              <a:t>commit, PR, acho,
-pre-implementation</a:t>
+              <a:t>commit, PR, acho, cleanup,
+pre-impl, self-improve</a:t>
             </a:r>
           </a:p>
         </p:txBody>
@@ -23839,7 +23785,7 @@
                 </a:solidFill>
                 <a:latin typeface="Inter"/>
               </a:rPr>
-              <a:t>6</a:t>
+              <a:t>10</a:t>
             </a:r>
           </a:p>
         </p:txBody>
@@ -23919,8 +23865,8 @@
                 </a:solidFill>
                 <a:latin typeface="Inter"/>
               </a:rPr>
-              <a:t>debug, refactor, code-review,
-test, migration, deps</a:t>
+              <a:t>debug, refactor, review,
+test, migrate, CI/CD, ...</a:t>
             </a:r>
           </a:p>
         </p:txBody>
@@ -24088,7 +24034,7 @@
                 </a:solidFill>
                 <a:latin typeface="Inter"/>
               </a:rPr>
-              <a:t>3</a:t>
+              <a:t>6</a:t>
             </a:r>
           </a:p>
         </p:txBody>
@@ -24168,8 +24114,8 @@
                 </a:solidFill>
                 <a:latin typeface="Inter"/>
               </a:rPr>
-              <a:t>architecture, performance,
-security</a:t>
+              <a:t>architecture, security,
+data-sec, DAST, ...</a:t>
             </a:r>
           </a:p>
         </p:txBody>
@@ -24337,7 +24283,7 @@
                 </a:solidFill>
                 <a:latin typeface="Inter"/>
               </a:rPr>
-              <a:t>4</a:t>
+              <a:t>5</a:t>
             </a:r>
           </a:p>
         </p:txBody>
@@ -24417,8 +24363,8 @@
                 </a:solidFill>
                 <a:latin typeface="Inter"/>
               </a:rPr>
-              <a:t>changelog, explain,
-writer, prompt-design</a:t>
+              <a:t>changelog, explain, writer,
+simplify, prompt-design</a:t>
             </a:r>
           </a:p>
         </p:txBody>
@@ -24431,7 +24377,7 @@
         </p:nvSpPr>
         <p:spPr>
           <a:xfrm>
-            <a:off x="2483967" y="3794760"/>
+            <a:off x="3718407" y="3794760"/>
             <a:ext cx="2286000" cy="1645920"/>
           </a:xfrm>
           <a:prstGeom prst="rect">
@@ -24476,7 +24422,7 @@
         </p:nvSpPr>
         <p:spPr>
           <a:xfrm>
-            <a:off x="2483967" y="3794760"/>
+            <a:off x="3718407" y="3794760"/>
             <a:ext cx="54864" cy="1645920"/>
           </a:xfrm>
           <a:prstGeom prst="rect">
@@ -24519,7 +24465,7 @@
         </p:nvSpPr>
         <p:spPr>
           <a:xfrm>
-            <a:off x="2648559" y="3886200"/>
+            <a:off x="3882999" y="3886200"/>
             <a:ext cx="2011680" cy="274320"/>
           </a:xfrm>
           <a:prstGeom prst="rect">
@@ -24559,7 +24505,7 @@
         </p:nvSpPr>
         <p:spPr>
           <a:xfrm>
-            <a:off x="2648559" y="4160520"/>
+            <a:off x="3882999" y="4160520"/>
             <a:ext cx="548640" cy="548640"/>
           </a:xfrm>
           <a:prstGeom prst="rect">
@@ -24586,7 +24532,7 @@
                 </a:solidFill>
                 <a:latin typeface="Inter"/>
               </a:rPr>
-              <a:t>9</a:t>
+              <a:t>12</a:t>
             </a:r>
           </a:p>
         </p:txBody>
@@ -24599,7 +24545,7 @@
         </p:nvSpPr>
         <p:spPr>
           <a:xfrm>
-            <a:off x="3215487" y="4251960"/>
+            <a:off x="4449927" y="4251960"/>
             <a:ext cx="1371600" cy="457200"/>
           </a:xfrm>
           <a:prstGeom prst="rect">
@@ -24639,7 +24585,7 @@
         </p:nvSpPr>
         <p:spPr>
           <a:xfrm>
-            <a:off x="2648559" y="4754880"/>
+            <a:off x="3882999" y="4754880"/>
             <a:ext cx="2011680" cy="594360"/>
           </a:xfrm>
           <a:prstGeom prst="rect">
@@ -24666,8 +24612,8 @@
                 </a:solidFill>
                 <a:latin typeface="Inter"/>
               </a:rPr>
-              <a:t>create/delete specs, skills,
-agents + risk lifecycle</a:t>
+              <a:t>specs, skills, agents +
+integrity + risk lifecycle</a:t>
             </a:r>
           </a:p>
         </p:txBody>
@@ -24680,7 +24626,7 @@
         </p:nvSpPr>
         <p:spPr>
           <a:xfrm>
-            <a:off x="4952847" y="3794760"/>
+            <a:off x="6187287" y="3794760"/>
             <a:ext cx="2286000" cy="1645920"/>
           </a:xfrm>
           <a:prstGeom prst="rect">
@@ -24725,7 +24671,7 @@
         </p:nvSpPr>
         <p:spPr>
           <a:xfrm>
-            <a:off x="4952847" y="3794760"/>
+            <a:off x="6187287" y="3794760"/>
             <a:ext cx="54864" cy="1645920"/>
           </a:xfrm>
           <a:prstGeom prst="rect">
@@ -24768,7 +24714,7 @@
         </p:nvSpPr>
         <p:spPr>
           <a:xfrm>
-            <a:off x="5117439" y="3886200"/>
+            <a:off x="6351879" y="3886200"/>
             <a:ext cx="2011680" cy="274320"/>
           </a:xfrm>
           <a:prstGeom prst="rect">
@@ -24808,7 +24754,7 @@
         </p:nvSpPr>
         <p:spPr>
           <a:xfrm>
-            <a:off x="5117439" y="4160520"/>
+            <a:off x="6351879" y="4160520"/>
             <a:ext cx="548640" cy="548640"/>
           </a:xfrm>
           <a:prstGeom prst="rect">
@@ -24835,7 +24781,7 @@
                 </a:solidFill>
                 <a:latin typeface="Inter"/>
               </a:rPr>
-              <a:t>3</a:t>
+              <a:t>6</a:t>
             </a:r>
           </a:p>
         </p:txBody>
@@ -24848,7 +24794,7 @@
         </p:nvSpPr>
         <p:spPr>
           <a:xfrm>
-            <a:off x="5684367" y="4251960"/>
+            <a:off x="6918807" y="4251960"/>
             <a:ext cx="1371600" cy="457200"/>
           </a:xfrm>
           <a:prstGeom prst="rect">
@@ -24888,7 +24834,7 @@
         </p:nvSpPr>
         <p:spPr>
           <a:xfrm>
-            <a:off x="5117439" y="4754880"/>
+            <a:off x="6351879" y="4754880"/>
             <a:ext cx="2011680" cy="594360"/>
           </a:xfrm>
           <a:prstGeom prst="rect">
@@ -24915,264 +24861,15 @@
                 </a:solidFill>
                 <a:latin typeface="Inter"/>
               </a:rPr>
-              <a:t>audit-code, audit-report,
-install-check</a:t>
-            </a:r>
-          </a:p>
-        </p:txBody>
-      </p:sp>
-      <p:sp>
-        <p:nvSpPr>
-          <p:cNvPr id="40" name="Rectangle 39"/>
-          <p:cNvSpPr/>
-          <p:nvPr/>
-        </p:nvSpPr>
-        <p:spPr>
-          <a:xfrm>
-            <a:off x="7421727" y="3794760"/>
-            <a:ext cx="2286000" cy="1645920"/>
-          </a:xfrm>
-          <a:prstGeom prst="rect">
-            <a:avLst/>
-          </a:prstGeom>
-          <a:solidFill>
-            <a:srgbClr val="1E293B"/>
-          </a:solidFill>
-          <a:ln w="12700">
-            <a:solidFill>
-              <a:srgbClr val="1A2A40"/>
-            </a:solidFill>
-          </a:ln>
-        </p:spPr>
-        <p:style>
-          <a:lnRef idx="1">
-            <a:schemeClr val="accent1"/>
-          </a:lnRef>
-          <a:fillRef idx="3">
-            <a:schemeClr val="accent1"/>
-          </a:fillRef>
-          <a:effectRef idx="2">
-            <a:schemeClr val="accent1"/>
-          </a:effectRef>
-          <a:fontRef idx="minor">
-            <a:schemeClr val="lt1"/>
-          </a:fontRef>
-        </p:style>
-        <p:txBody>
-          <a:bodyPr rtlCol="0" anchor="ctr"/>
-          <a:lstStyle/>
-          <a:p>
-            <a:pPr algn="ctr"/>
-          </a:p>
-        </p:txBody>
-      </p:sp>
-      <p:sp>
-        <p:nvSpPr>
-          <p:cNvPr id="41" name="Rectangle 40"/>
-          <p:cNvSpPr/>
-          <p:nvPr/>
-        </p:nvSpPr>
-        <p:spPr>
-          <a:xfrm>
-            <a:off x="7421727" y="3794760"/>
-            <a:ext cx="54864" cy="1645920"/>
-          </a:xfrm>
-          <a:prstGeom prst="rect">
-            <a:avLst/>
-          </a:prstGeom>
-          <a:solidFill>
-            <a:srgbClr val="1A3A5C"/>
-          </a:solidFill>
-          <a:ln>
-            <a:noFill/>
-          </a:ln>
-        </p:spPr>
-        <p:style>
-          <a:lnRef idx="1">
-            <a:schemeClr val="accent1"/>
-          </a:lnRef>
-          <a:fillRef idx="3">
-            <a:schemeClr val="accent1"/>
-          </a:fillRef>
-          <a:effectRef idx="2">
-            <a:schemeClr val="accent1"/>
-          </a:effectRef>
-          <a:fontRef idx="minor">
-            <a:schemeClr val="lt1"/>
-          </a:fontRef>
-        </p:style>
-        <p:txBody>
-          <a:bodyPr rtlCol="0" anchor="ctr"/>
-          <a:lstStyle/>
-          <a:p>
-            <a:pPr algn="ctr"/>
-          </a:p>
-        </p:txBody>
-      </p:sp>
-      <p:sp>
-        <p:nvSpPr>
-          <p:cNvPr id="42" name="TextBox 41"/>
-          <p:cNvSpPr txBox="1"/>
-          <p:nvPr/>
-        </p:nvSpPr>
-        <p:spPr>
-          <a:xfrm>
-            <a:off x="7586319" y="3886200"/>
-            <a:ext cx="2011680" cy="274320"/>
-          </a:xfrm>
-          <a:prstGeom prst="rect">
-            <a:avLst/>
-          </a:prstGeom>
-          <a:noFill/>
-        </p:spPr>
-        <p:txBody>
-          <a:bodyPr wrap="square" anchor="t"/>
-          <a:lstStyle/>
-          <a:p>
-            <a:pPr algn="l">
-              <a:spcBef>
-                <a:spcPts val="0"/>
-              </a:spcBef>
-              <a:spcAft>
-                <a:spcPts val="0"/>
-              </a:spcAft>
-            </a:pPr>
-            <a:r>
-              <a:rPr sz="1400" b="1">
-                <a:solidFill>
-                  <a:srgbClr val="E2E8F0"/>
-                </a:solidFill>
-                <a:latin typeface="Inter"/>
-              </a:rPr>
-              <a:t>Utils</a:t>
-            </a:r>
-          </a:p>
-        </p:txBody>
-      </p:sp>
-      <p:sp>
-        <p:nvSpPr>
-          <p:cNvPr id="43" name="TextBox 42"/>
-          <p:cNvSpPr txBox="1"/>
-          <p:nvPr/>
-        </p:nvSpPr>
-        <p:spPr>
-          <a:xfrm>
-            <a:off x="7586319" y="4160520"/>
-            <a:ext cx="548640" cy="548640"/>
-          </a:xfrm>
-          <a:prstGeom prst="rect">
-            <a:avLst/>
-          </a:prstGeom>
-          <a:noFill/>
-        </p:spPr>
-        <p:txBody>
-          <a:bodyPr wrap="square" anchor="t"/>
-          <a:lstStyle/>
-          <a:p>
-            <a:pPr algn="l">
-              <a:spcBef>
-                <a:spcPts val="0"/>
-              </a:spcBef>
-              <a:spcAft>
-                <a:spcPts val="0"/>
-              </a:spcAft>
-            </a:pPr>
-            <a:r>
-              <a:rPr sz="3200" b="1">
-                <a:solidFill>
-                  <a:srgbClr val="1A3A5C"/>
-                </a:solidFill>
-                <a:latin typeface="Inter"/>
-              </a:rPr>
-              <a:t>3</a:t>
-            </a:r>
-          </a:p>
-        </p:txBody>
-      </p:sp>
-      <p:sp>
-        <p:nvSpPr>
-          <p:cNvPr id="44" name="TextBox 43"/>
-          <p:cNvSpPr txBox="1"/>
-          <p:nvPr/>
-        </p:nvSpPr>
-        <p:spPr>
-          <a:xfrm>
-            <a:off x="8153247" y="4251960"/>
-            <a:ext cx="1371600" cy="457200"/>
-          </a:xfrm>
-          <a:prstGeom prst="rect">
-            <a:avLst/>
-          </a:prstGeom>
-          <a:noFill/>
-        </p:spPr>
-        <p:txBody>
-          <a:bodyPr wrap="square" anchor="t"/>
-          <a:lstStyle/>
-          <a:p>
-            <a:pPr algn="l">
-              <a:spcBef>
-                <a:spcPts val="0"/>
-              </a:spcBef>
-              <a:spcAft>
-                <a:spcPts val="0"/>
-              </a:spcAft>
-            </a:pPr>
-            <a:r>
-              <a:rPr sz="900" b="0">
-                <a:solidFill>
-                  <a:srgbClr val="94A3B8"/>
-                </a:solidFill>
-                <a:latin typeface="Inter"/>
-              </a:rPr>
-              <a:t>skills</a:t>
-            </a:r>
-          </a:p>
-        </p:txBody>
-      </p:sp>
-      <p:sp>
-        <p:nvSpPr>
-          <p:cNvPr id="45" name="TextBox 44"/>
-          <p:cNvSpPr txBox="1"/>
-          <p:nvPr/>
-        </p:nvSpPr>
-        <p:spPr>
-          <a:xfrm>
-            <a:off x="7586319" y="4754880"/>
-            <a:ext cx="2011680" cy="594360"/>
-          </a:xfrm>
-          <a:prstGeom prst="rect">
-            <a:avLst/>
-          </a:prstGeom>
-          <a:noFill/>
-        </p:spPr>
-        <p:txBody>
-          <a:bodyPr wrap="square" anchor="t"/>
-          <a:lstStyle/>
-          <a:p>
-            <a:pPr algn="l">
-              <a:spcBef>
-                <a:spcPts val="0"/>
-              </a:spcBef>
-              <a:spcAft>
-                <a:spcPts val="0"/>
-              </a:spcAft>
-            </a:pPr>
-            <a:r>
-              <a:rPr sz="900" b="0">
-                <a:solidFill>
-                  <a:srgbClr val="64748B"/>
-                </a:solidFill>
-                <a:latin typeface="Inter"/>
-              </a:rPr>
-              <a:t>git-helpers, platform-detect,
-python-patterns</a:t>
-            </a:r>
-          </a:p>
-        </p:txBody>
-      </p:sp>
-      <p:sp>
-        <p:nvSpPr>
-          <p:cNvPr id="46" name="TextBox 45"/>
+              <a:t>audit, release-gate,
+SBOM, test-gap, ...</a:t>
+            </a:r>
+          </a:p>
+        </p:txBody>
+      </p:sp>
+      <p:sp>
+        <p:nvSpPr>
+          <p:cNvPr id="40" name="TextBox 39"/>
           <p:cNvSpPr txBox="1"/>
           <p:nvPr/>
         </p:nvSpPr>
@@ -25314,7 +25011,7 @@
                 </a:solidFill>
                 <a:latin typeface="JetBrains Mono"/>
               </a:rPr>
-              <a:t>Agents: 8 Specialized Personas</a:t>
+              <a:t>Agents: 15 Specialized Personas</a:t>
             </a:r>
           </a:p>
         </p:txBody>
@@ -25452,8 +25149,8 @@
         </p:nvSpPr>
         <p:spPr>
           <a:xfrm>
-            <a:off x="5364327" y="1143000"/>
-            <a:ext cx="1463040" cy="1005840"/>
+            <a:off x="5455767" y="845820"/>
+            <a:ext cx="1280160" cy="868680"/>
           </a:xfrm>
           <a:prstGeom prst="rect">
             <a:avLst/>
@@ -25497,7 +25194,7 @@
         </p:nvSpPr>
         <p:spPr>
           <a:xfrm>
-            <a:off x="5437479" y="1216152"/>
+            <a:off x="5528919" y="918972"/>
             <a:ext cx="365760" cy="365760"/>
           </a:xfrm>
           <a:prstGeom prst="ellipse">
@@ -25542,7 +25239,7 @@
         </p:nvSpPr>
         <p:spPr>
           <a:xfrm>
-            <a:off x="5437479" y="1216152"/>
+            <a:off x="5528919" y="918972"/>
             <a:ext cx="365760" cy="365760"/>
           </a:xfrm>
           <a:prstGeom prst="rect">
@@ -25582,8 +25279,8 @@
         </p:nvSpPr>
         <p:spPr>
           <a:xfrm>
-            <a:off x="5821527" y="1188720"/>
-            <a:ext cx="914400" cy="457200"/>
+            <a:off x="5912967" y="891540"/>
+            <a:ext cx="731520" cy="457200"/>
           </a:xfrm>
           <a:prstGeom prst="rect">
             <a:avLst/>
@@ -25623,8 +25320,8 @@
         </p:nvSpPr>
         <p:spPr>
           <a:xfrm>
-            <a:off x="5437479" y="1737360"/>
-            <a:ext cx="1316736" cy="365760"/>
+            <a:off x="5528919" y="1440180"/>
+            <a:ext cx="1133856" cy="365760"/>
           </a:xfrm>
           <a:prstGeom prst="rect">
             <a:avLst/>
@@ -25704,8 +25401,8 @@
         </p:nvSpPr>
         <p:spPr>
           <a:xfrm>
-            <a:off x="3812538" y="1785771"/>
-            <a:ext cx="1463040" cy="1005840"/>
+            <a:off x="4414391" y="1067171"/>
+            <a:ext cx="1280160" cy="868680"/>
           </a:xfrm>
           <a:prstGeom prst="rect">
             <a:avLst/>
@@ -25749,7 +25446,7 @@
         </p:nvSpPr>
         <p:spPr>
           <a:xfrm>
-            <a:off x="3885690" y="1858923"/>
+            <a:off x="4487543" y="1140323"/>
             <a:ext cx="365760" cy="365760"/>
           </a:xfrm>
           <a:prstGeom prst="ellipse">
@@ -25794,7 +25491,7 @@
         </p:nvSpPr>
         <p:spPr>
           <a:xfrm>
-            <a:off x="3885690" y="1858923"/>
+            <a:off x="4487543" y="1140323"/>
             <a:ext cx="365760" cy="365760"/>
           </a:xfrm>
           <a:prstGeom prst="rect">
@@ -25834,8 +25531,8 @@
         </p:nvSpPr>
         <p:spPr>
           <a:xfrm>
-            <a:off x="4269738" y="1831491"/>
-            <a:ext cx="914400" cy="457200"/>
+            <a:off x="4871591" y="1112891"/>
+            <a:ext cx="731520" cy="457200"/>
           </a:xfrm>
           <a:prstGeom prst="rect">
             <a:avLst/>
@@ -25874,8 +25571,8 @@
         </p:nvSpPr>
         <p:spPr>
           <a:xfrm>
-            <a:off x="3885690" y="2380131"/>
-            <a:ext cx="1316736" cy="365760"/>
+            <a:off x="4487543" y="1661531"/>
+            <a:ext cx="1133856" cy="365760"/>
           </a:xfrm>
           <a:prstGeom prst="rect">
             <a:avLst/>
@@ -25901,7 +25598,7 @@
                 </a:solidFill>
                 <a:latin typeface="Inter"/>
               </a:rPr>
-              <a:t>Architectural analysis</a:t>
+              <a:t>Architecture analysis</a:t>
             </a:r>
           </a:p>
         </p:txBody>
@@ -25955,8 +25652,8 @@
         </p:nvSpPr>
         <p:spPr>
           <a:xfrm>
-            <a:off x="3169767" y="3337559"/>
-            <a:ext cx="1463040" cy="1005840"/>
+            <a:off x="3553078" y="1692951"/>
+            <a:ext cx="1280160" cy="868680"/>
           </a:xfrm>
           <a:prstGeom prst="rect">
             <a:avLst/>
@@ -26000,7 +25697,7 @@
         </p:nvSpPr>
         <p:spPr>
           <a:xfrm>
-            <a:off x="3242919" y="3410711"/>
+            <a:off x="3626230" y="1766103"/>
             <a:ext cx="365760" cy="365760"/>
           </a:xfrm>
           <a:prstGeom prst="ellipse">
@@ -26045,7 +25742,7 @@
         </p:nvSpPr>
         <p:spPr>
           <a:xfrm>
-            <a:off x="3242919" y="3410711"/>
+            <a:off x="3626230" y="1766103"/>
             <a:ext cx="365760" cy="365760"/>
           </a:xfrm>
           <a:prstGeom prst="rect">
@@ -26085,8 +25782,8 @@
         </p:nvSpPr>
         <p:spPr>
           <a:xfrm>
-            <a:off x="3626967" y="3383279"/>
-            <a:ext cx="914400" cy="457200"/>
+            <a:off x="4010278" y="1738671"/>
+            <a:ext cx="731520" cy="457200"/>
           </a:xfrm>
           <a:prstGeom prst="rect">
             <a:avLst/>
@@ -26126,8 +25823,8 @@
         </p:nvSpPr>
         <p:spPr>
           <a:xfrm>
-            <a:off x="3242919" y="3931919"/>
-            <a:ext cx="1316736" cy="365760"/>
+            <a:off x="3626230" y="2287311"/>
+            <a:ext cx="1133856" cy="365760"/>
           </a:xfrm>
           <a:prstGeom prst="rect">
             <a:avLst/>
@@ -26153,7 +25850,7 @@
                 </a:solidFill>
                 <a:latin typeface="Inter"/>
               </a:rPr>
-              <a:t>Security assessment</a:t>
+              <a:t>Threat assessment</a:t>
             </a:r>
           </a:p>
         </p:txBody>
@@ -26207,8 +25904,8 @@
         </p:nvSpPr>
         <p:spPr>
           <a:xfrm>
-            <a:off x="3812538" y="4889348"/>
-            <a:ext cx="1463040" cy="1005840"/>
+            <a:off x="3020757" y="2614957"/>
+            <a:ext cx="1280160" cy="868680"/>
           </a:xfrm>
           <a:prstGeom prst="rect">
             <a:avLst/>
@@ -26252,7 +25949,7 @@
         </p:nvSpPr>
         <p:spPr>
           <a:xfrm>
-            <a:off x="3885690" y="4962500"/>
+            <a:off x="3093909" y="2688109"/>
             <a:ext cx="365760" cy="365760"/>
           </a:xfrm>
           <a:prstGeom prst="ellipse">
@@ -26297,7 +25994,7 @@
         </p:nvSpPr>
         <p:spPr>
           <a:xfrm>
-            <a:off x="3885690" y="4962500"/>
+            <a:off x="3093909" y="2688109"/>
             <a:ext cx="365760" cy="365760"/>
           </a:xfrm>
           <a:prstGeom prst="rect">
@@ -26324,7 +26021,7 @@
                 </a:solidFill>
                 <a:latin typeface="Inter"/>
               </a:rPr>
-              <a:t>DB</a:t>
+              <a:t>TM</a:t>
             </a:r>
           </a:p>
         </p:txBody>
@@ -26337,8 +26034,8 @@
         </p:nvSpPr>
         <p:spPr>
           <a:xfrm>
-            <a:off x="4269738" y="4935068"/>
-            <a:ext cx="914400" cy="457200"/>
+            <a:off x="3477957" y="2660677"/>
+            <a:ext cx="731520" cy="457200"/>
           </a:xfrm>
           <a:prstGeom prst="rect">
             <a:avLst/>
@@ -26364,7 +26061,8 @@
                 </a:solidFill>
                 <a:latin typeface="Inter"/>
               </a:rPr>
-              <a:t>Debugger</a:t>
+              <a:t>Test
+Master</a:t>
             </a:r>
           </a:p>
         </p:txBody>
@@ -26377,8 +26075,8 @@
         </p:nvSpPr>
         <p:spPr>
           <a:xfrm>
-            <a:off x="3885690" y="5483708"/>
-            <a:ext cx="1316736" cy="365760"/>
+            <a:off x="3093909" y="3209317"/>
+            <a:ext cx="1133856" cy="365760"/>
           </a:xfrm>
           <a:prstGeom prst="rect">
             <a:avLst/>
@@ -26404,7 +26102,7 @@
                 </a:solidFill>
                 <a:latin typeface="Inter"/>
               </a:rPr>
-              <a:t>Systematic diagnosis</a:t>
+              <a:t>Test strategy</a:t>
             </a:r>
           </a:p>
         </p:txBody>
@@ -26458,8 +26156,8 @@
         </p:nvSpPr>
         <p:spPr>
           <a:xfrm>
-            <a:off x="5364327" y="5532120"/>
-            <a:ext cx="1463040" cy="1005840"/>
+            <a:off x="2909472" y="3673766"/>
+            <a:ext cx="1280160" cy="868680"/>
           </a:xfrm>
           <a:prstGeom prst="rect">
             <a:avLst/>
@@ -26503,7 +26201,7 @@
         </p:nvSpPr>
         <p:spPr>
           <a:xfrm>
-            <a:off x="5437479" y="5605272"/>
+            <a:off x="2982624" y="3746918"/>
             <a:ext cx="365760" cy="365760"/>
           </a:xfrm>
           <a:prstGeom prst="ellipse">
@@ -26548,7 +26246,7 @@
         </p:nvSpPr>
         <p:spPr>
           <a:xfrm>
-            <a:off x="5437479" y="5605272"/>
+            <a:off x="2982624" y="3746918"/>
             <a:ext cx="365760" cy="365760"/>
           </a:xfrm>
           <a:prstGeom prst="rect">
@@ -26575,7 +26273,7 @@
                 </a:solidFill>
                 <a:latin typeface="Inter"/>
               </a:rPr>
-              <a:t>QA</a:t>
+              <a:t>DB</a:t>
             </a:r>
           </a:p>
         </p:txBody>
@@ -26588,8 +26286,8 @@
         </p:nvSpPr>
         <p:spPr>
           <a:xfrm>
-            <a:off x="5821527" y="5577840"/>
-            <a:ext cx="914400" cy="457200"/>
+            <a:off x="3366672" y="3719486"/>
+            <a:ext cx="731520" cy="457200"/>
           </a:xfrm>
           <a:prstGeom prst="rect">
             <a:avLst/>
@@ -26615,8 +26313,7 @@
                 </a:solidFill>
                 <a:latin typeface="Inter"/>
               </a:rPr>
-              <a:t>Quality
-Auditor</a:t>
+              <a:t>Debugger</a:t>
             </a:r>
           </a:p>
         </p:txBody>
@@ -26629,8 +26326,8 @@
         </p:nvSpPr>
         <p:spPr>
           <a:xfrm>
-            <a:off x="5437479" y="6126480"/>
-            <a:ext cx="1316736" cy="365760"/>
+            <a:off x="2982624" y="4268126"/>
+            <a:ext cx="1133856" cy="365760"/>
           </a:xfrm>
           <a:prstGeom prst="rect">
             <a:avLst/>
@@ -26656,7 +26353,7 @@
                 </a:solidFill>
                 <a:latin typeface="Inter"/>
               </a:rPr>
-              <a:t>Quality gates</a:t>
+              <a:t>Root cause analysis</a:t>
             </a:r>
           </a:p>
         </p:txBody>
@@ -26710,8 +26407,8 @@
         </p:nvSpPr>
         <p:spPr>
           <a:xfrm>
-            <a:off x="6916115" y="4889348"/>
-            <a:ext cx="1463040" cy="1005840"/>
+            <a:off x="3238464" y="4686300"/>
+            <a:ext cx="1280160" cy="868680"/>
           </a:xfrm>
           <a:prstGeom prst="rect">
             <a:avLst/>
@@ -26755,7 +26452,7 @@
         </p:nvSpPr>
         <p:spPr>
           <a:xfrm>
-            <a:off x="6989267" y="4962500"/>
+            <a:off x="3311616" y="4759452"/>
             <a:ext cx="365760" cy="365760"/>
           </a:xfrm>
           <a:prstGeom prst="ellipse">
@@ -26800,7 +26497,7 @@
         </p:nvSpPr>
         <p:spPr>
           <a:xfrm>
-            <a:off x="6989267" y="4962500"/>
+            <a:off x="3311616" y="4759452"/>
             <a:ext cx="365760" cy="365760"/>
           </a:xfrm>
           <a:prstGeom prst="rect">
@@ -26827,7 +26524,7 @@
                 </a:solidFill>
                 <a:latin typeface="Inter"/>
               </a:rPr>
-              <a:t>VA</a:t>
+              <a:t>QA</a:t>
             </a:r>
           </a:p>
         </p:txBody>
@@ -26840,8 +26537,8 @@
         </p:nvSpPr>
         <p:spPr>
           <a:xfrm>
-            <a:off x="7373315" y="4935068"/>
-            <a:ext cx="914400" cy="457200"/>
+            <a:off x="3695664" y="4732020"/>
+            <a:ext cx="731520" cy="457200"/>
           </a:xfrm>
           <a:prstGeom prst="rect">
             <a:avLst/>
@@ -26867,8 +26564,8 @@
                 </a:solidFill>
                 <a:latin typeface="Inter"/>
               </a:rPr>
-              <a:t>Verify
-App</a:t>
+              <a:t>Quality
+Auditor</a:t>
             </a:r>
           </a:p>
         </p:txBody>
@@ -26881,8 +26578,8 @@
         </p:nvSpPr>
         <p:spPr>
           <a:xfrm>
-            <a:off x="6989267" y="5483708"/>
-            <a:ext cx="1316736" cy="365760"/>
+            <a:off x="3311616" y="5280660"/>
+            <a:ext cx="1133856" cy="365760"/>
           </a:xfrm>
           <a:prstGeom prst="rect">
             <a:avLst/>
@@ -26908,7 +26605,7 @@
                 </a:solidFill>
                 <a:latin typeface="Inter"/>
               </a:rPr>
-              <a:t>E2E verification</a:t>
+              <a:t>Quality gates</a:t>
             </a:r>
           </a:p>
         </p:txBody>
@@ -26962,8 +26659,8 @@
         </p:nvSpPr>
         <p:spPr>
           <a:xfrm>
-            <a:off x="7558887" y="3337560"/>
-            <a:ext cx="1463040" cy="1005840"/>
+            <a:off x="3950848" y="5477482"/>
+            <a:ext cx="1280160" cy="868680"/>
           </a:xfrm>
           <a:prstGeom prst="rect">
             <a:avLst/>
@@ -27007,7 +26704,7 @@
         </p:nvSpPr>
         <p:spPr>
           <a:xfrm>
-            <a:off x="7632039" y="3410712"/>
+            <a:off x="4024000" y="5550634"/>
             <a:ext cx="365760" cy="365760"/>
           </a:xfrm>
           <a:prstGeom prst="ellipse">
@@ -27052,7 +26749,7 @@
         </p:nvSpPr>
         <p:spPr>
           <a:xfrm>
-            <a:off x="7632039" y="3410712"/>
+            <a:off x="4024000" y="5550634"/>
             <a:ext cx="365760" cy="365760"/>
           </a:xfrm>
           <a:prstGeom prst="rect">
@@ -27079,7 +26776,7 @@
                 </a:solidFill>
                 <a:latin typeface="Inter"/>
               </a:rPr>
-              <a:t>CM</a:t>
+              <a:t>VA</a:t>
             </a:r>
           </a:p>
         </p:txBody>
@@ -27092,8 +26789,8 @@
         </p:nvSpPr>
         <p:spPr>
           <a:xfrm>
-            <a:off x="8016087" y="3383280"/>
-            <a:ext cx="914400" cy="457200"/>
+            <a:off x="4408048" y="5523202"/>
+            <a:ext cx="731520" cy="457200"/>
           </a:xfrm>
           <a:prstGeom prst="rect">
             <a:avLst/>
@@ -27119,8 +26816,8 @@
                 </a:solidFill>
                 <a:latin typeface="Inter"/>
               </a:rPr>
-              <a:t>Codebase
-Mapper</a:t>
+              <a:t>Verify
+App</a:t>
             </a:r>
           </a:p>
         </p:txBody>
@@ -27133,8 +26830,8 @@
         </p:nvSpPr>
         <p:spPr>
           <a:xfrm>
-            <a:off x="7632039" y="3931920"/>
-            <a:ext cx="1316736" cy="365760"/>
+            <a:off x="4024000" y="6071842"/>
+            <a:ext cx="1133856" cy="365760"/>
           </a:xfrm>
           <a:prstGeom prst="rect">
             <a:avLst/>
@@ -27160,7 +26857,7 @@
                 </a:solidFill>
                 <a:latin typeface="Inter"/>
               </a:rPr>
-              <a:t>Structure mapping</a:t>
+              <a:t>E2E verification</a:t>
             </a:r>
           </a:p>
         </p:txBody>
@@ -27214,8 +26911,8 @@
         </p:nvSpPr>
         <p:spPr>
           <a:xfrm>
-            <a:off x="6916115" y="1785771"/>
-            <a:ext cx="1463040" cy="1005840"/>
+            <a:off x="4923446" y="5910510"/>
+            <a:ext cx="1280160" cy="868680"/>
           </a:xfrm>
           <a:prstGeom prst="rect">
             <a:avLst/>
@@ -27259,7 +26956,7 @@
         </p:nvSpPr>
         <p:spPr>
           <a:xfrm>
-            <a:off x="6989267" y="1858923"/>
+            <a:off x="4996598" y="5983662"/>
             <a:ext cx="365760" cy="365760"/>
           </a:xfrm>
           <a:prstGeom prst="ellipse">
@@ -27304,7 +27001,7 @@
         </p:nvSpPr>
         <p:spPr>
           <a:xfrm>
-            <a:off x="6989267" y="1858923"/>
+            <a:off x="4996598" y="5983662"/>
             <a:ext cx="365760" cy="365760"/>
           </a:xfrm>
           <a:prstGeom prst="rect">
@@ -27344,8 +27041,8 @@
         </p:nvSpPr>
         <p:spPr>
           <a:xfrm>
-            <a:off x="7373315" y="1831491"/>
-            <a:ext cx="914400" cy="457200"/>
+            <a:off x="5380646" y="5956230"/>
+            <a:ext cx="731520" cy="457200"/>
           </a:xfrm>
           <a:prstGeom prst="rect">
             <a:avLst/>
@@ -27385,8 +27082,8 @@
         </p:nvSpPr>
         <p:spPr>
           <a:xfrm>
-            <a:off x="6989267" y="2380131"/>
-            <a:ext cx="1316736" cy="365760"/>
+            <a:off x="4996598" y="6504870"/>
+            <a:ext cx="1133856" cy="365760"/>
           </a:xfrm>
           <a:prstGeom prst="rect">
             <a:avLst/>
@@ -27413,6 +27110,1768 @@
                 <a:latin typeface="Inter"/>
               </a:rPr>
               <a:t>Complexity reduction</a:t>
+            </a:r>
+          </a:p>
+        </p:txBody>
+      </p:sp>
+      <p:sp>
+        <p:nvSpPr>
+          <p:cNvPr id="54" name="Rectangle 53"/>
+          <p:cNvSpPr/>
+          <p:nvPr/>
+        </p:nvSpPr>
+        <p:spPr>
+          <a:xfrm>
+            <a:off x="6095847" y="3840480"/>
+            <a:ext cx="18288" cy="18288"/>
+          </a:xfrm>
+          <a:prstGeom prst="rect">
+            <a:avLst/>
+          </a:prstGeom>
+          <a:noFill/>
+          <a:ln>
+            <a:noFill/>
+          </a:ln>
+        </p:spPr>
+        <p:style>
+          <a:lnRef idx="1">
+            <a:schemeClr val="accent1"/>
+          </a:lnRef>
+          <a:fillRef idx="3">
+            <a:schemeClr val="accent1"/>
+          </a:fillRef>
+          <a:effectRef idx="2">
+            <a:schemeClr val="accent1"/>
+          </a:effectRef>
+          <a:fontRef idx="minor">
+            <a:schemeClr val="lt1"/>
+          </a:fontRef>
+        </p:style>
+        <p:txBody>
+          <a:bodyPr rtlCol="0" anchor="ctr"/>
+          <a:lstStyle/>
+          <a:p>
+            <a:pPr algn="ctr"/>
+          </a:p>
+        </p:txBody>
+      </p:sp>
+      <p:sp>
+        <p:nvSpPr>
+          <p:cNvPr id="55" name="Rectangle 54"/>
+          <p:cNvSpPr/>
+          <p:nvPr/>
+        </p:nvSpPr>
+        <p:spPr>
+          <a:xfrm>
+            <a:off x="5988087" y="5910510"/>
+            <a:ext cx="1280160" cy="868680"/>
+          </a:xfrm>
+          <a:prstGeom prst="rect">
+            <a:avLst/>
+          </a:prstGeom>
+          <a:solidFill>
+            <a:srgbClr val="1E293B"/>
+          </a:solidFill>
+          <a:ln w="12700">
+            <a:solidFill>
+              <a:srgbClr val="1A2A40"/>
+            </a:solidFill>
+          </a:ln>
+        </p:spPr>
+        <p:style>
+          <a:lnRef idx="1">
+            <a:schemeClr val="accent1"/>
+          </a:lnRef>
+          <a:fillRef idx="3">
+            <a:schemeClr val="accent1"/>
+          </a:fillRef>
+          <a:effectRef idx="2">
+            <a:schemeClr val="accent1"/>
+          </a:effectRef>
+          <a:fontRef idx="minor">
+            <a:schemeClr val="lt1"/>
+          </a:fontRef>
+        </p:style>
+        <p:txBody>
+          <a:bodyPr rtlCol="0" anchor="ctr"/>
+          <a:lstStyle/>
+          <a:p>
+            <a:pPr algn="ctr"/>
+          </a:p>
+        </p:txBody>
+      </p:sp>
+      <p:sp>
+        <p:nvSpPr>
+          <p:cNvPr id="56" name="Oval 55"/>
+          <p:cNvSpPr/>
+          <p:nvPr/>
+        </p:nvSpPr>
+        <p:spPr>
+          <a:xfrm>
+            <a:off x="6061239" y="5983662"/>
+            <a:ext cx="365760" cy="365760"/>
+          </a:xfrm>
+          <a:prstGeom prst="ellipse">
+            <a:avLst/>
+          </a:prstGeom>
+          <a:solidFill>
+            <a:srgbClr val="1E3A5F"/>
+          </a:solidFill>
+          <a:ln w="12700">
+            <a:solidFill>
+              <a:srgbClr val="00D4AA"/>
+            </a:solidFill>
+          </a:ln>
+        </p:spPr>
+        <p:style>
+          <a:lnRef idx="1">
+            <a:schemeClr val="accent1"/>
+          </a:lnRef>
+          <a:fillRef idx="3">
+            <a:schemeClr val="accent1"/>
+          </a:fillRef>
+          <a:effectRef idx="2">
+            <a:schemeClr val="accent1"/>
+          </a:effectRef>
+          <a:fontRef idx="minor">
+            <a:schemeClr val="lt1"/>
+          </a:fontRef>
+        </p:style>
+        <p:txBody>
+          <a:bodyPr rtlCol="0" anchor="ctr"/>
+          <a:lstStyle/>
+          <a:p>
+            <a:pPr algn="ctr"/>
+          </a:p>
+        </p:txBody>
+      </p:sp>
+      <p:sp>
+        <p:nvSpPr>
+          <p:cNvPr id="57" name="TextBox 56"/>
+          <p:cNvSpPr txBox="1"/>
+          <p:nvPr/>
+        </p:nvSpPr>
+        <p:spPr>
+          <a:xfrm>
+            <a:off x="6061239" y="5983662"/>
+            <a:ext cx="365760" cy="365760"/>
+          </a:xfrm>
+          <a:prstGeom prst="rect">
+            <a:avLst/>
+          </a:prstGeom>
+          <a:noFill/>
+        </p:spPr>
+        <p:txBody>
+          <a:bodyPr wrap="square" anchor="ctr"/>
+          <a:lstStyle/>
+          <a:p>
+            <a:pPr algn="ctr">
+              <a:spcBef>
+                <a:spcPts val="0"/>
+              </a:spcBef>
+              <a:spcAft>
+                <a:spcPts val="0"/>
+              </a:spcAft>
+            </a:pPr>
+            <a:r>
+              <a:rPr sz="900" b="1">
+                <a:solidFill>
+                  <a:srgbClr val="00D4AA"/>
+                </a:solidFill>
+                <a:latin typeface="Inter"/>
+              </a:rPr>
+              <a:t>OR</a:t>
+            </a:r>
+          </a:p>
+        </p:txBody>
+      </p:sp>
+      <p:sp>
+        <p:nvSpPr>
+          <p:cNvPr id="58" name="TextBox 57"/>
+          <p:cNvSpPr txBox="1"/>
+          <p:nvPr/>
+        </p:nvSpPr>
+        <p:spPr>
+          <a:xfrm>
+            <a:off x="6445287" y="5956230"/>
+            <a:ext cx="731520" cy="457200"/>
+          </a:xfrm>
+          <a:prstGeom prst="rect">
+            <a:avLst/>
+          </a:prstGeom>
+          <a:noFill/>
+        </p:spPr>
+        <p:txBody>
+          <a:bodyPr wrap="square" anchor="t"/>
+          <a:lstStyle/>
+          <a:p>
+            <a:pPr algn="l">
+              <a:spcBef>
+                <a:spcPts val="0"/>
+              </a:spcBef>
+              <a:spcAft>
+                <a:spcPts val="0"/>
+              </a:spcAft>
+            </a:pPr>
+            <a:r>
+              <a:rPr sz="1000" b="1">
+                <a:solidFill>
+                  <a:srgbClr val="E2E8F0"/>
+                </a:solidFill>
+                <a:latin typeface="Inter"/>
+              </a:rPr>
+              <a:t>Orchestrator</a:t>
+            </a:r>
+          </a:p>
+        </p:txBody>
+      </p:sp>
+      <p:sp>
+        <p:nvSpPr>
+          <p:cNvPr id="59" name="TextBox 58"/>
+          <p:cNvSpPr txBox="1"/>
+          <p:nvPr/>
+        </p:nvSpPr>
+        <p:spPr>
+          <a:xfrm>
+            <a:off x="6061239" y="6504870"/>
+            <a:ext cx="1133856" cy="365760"/>
+          </a:xfrm>
+          <a:prstGeom prst="rect">
+            <a:avLst/>
+          </a:prstGeom>
+          <a:noFill/>
+        </p:spPr>
+        <p:txBody>
+          <a:bodyPr wrap="square" anchor="t"/>
+          <a:lstStyle/>
+          <a:p>
+            <a:pPr algn="ctr">
+              <a:spcBef>
+                <a:spcPts val="0"/>
+              </a:spcBef>
+              <a:spcAft>
+                <a:spcPts val="0"/>
+              </a:spcAft>
+            </a:pPr>
+            <a:r>
+              <a:rPr sz="800" b="0">
+                <a:solidFill>
+                  <a:srgbClr val="64748B"/>
+                </a:solidFill>
+                <a:latin typeface="Inter"/>
+              </a:rPr>
+              <a:t>Multi-phase coord.</a:t>
+            </a:r>
+          </a:p>
+        </p:txBody>
+      </p:sp>
+      <p:sp>
+        <p:nvSpPr>
+          <p:cNvPr id="60" name="Rectangle 59"/>
+          <p:cNvSpPr/>
+          <p:nvPr/>
+        </p:nvSpPr>
+        <p:spPr>
+          <a:xfrm>
+            <a:off x="6095847" y="3840480"/>
+            <a:ext cx="18288" cy="18288"/>
+          </a:xfrm>
+          <a:prstGeom prst="rect">
+            <a:avLst/>
+          </a:prstGeom>
+          <a:noFill/>
+          <a:ln>
+            <a:noFill/>
+          </a:ln>
+        </p:spPr>
+        <p:style>
+          <a:lnRef idx="1">
+            <a:schemeClr val="accent1"/>
+          </a:lnRef>
+          <a:fillRef idx="3">
+            <a:schemeClr val="accent1"/>
+          </a:fillRef>
+          <a:effectRef idx="2">
+            <a:schemeClr val="accent1"/>
+          </a:effectRef>
+          <a:fontRef idx="minor">
+            <a:schemeClr val="lt1"/>
+          </a:fontRef>
+        </p:style>
+        <p:txBody>
+          <a:bodyPr rtlCol="0" anchor="ctr"/>
+          <a:lstStyle/>
+          <a:p>
+            <a:pPr algn="ctr"/>
+          </a:p>
+        </p:txBody>
+      </p:sp>
+      <p:sp>
+        <p:nvSpPr>
+          <p:cNvPr id="61" name="Rectangle 60"/>
+          <p:cNvSpPr/>
+          <p:nvPr/>
+        </p:nvSpPr>
+        <p:spPr>
+          <a:xfrm>
+            <a:off x="6960685" y="5477482"/>
+            <a:ext cx="1280160" cy="868680"/>
+          </a:xfrm>
+          <a:prstGeom prst="rect">
+            <a:avLst/>
+          </a:prstGeom>
+          <a:solidFill>
+            <a:srgbClr val="1E293B"/>
+          </a:solidFill>
+          <a:ln w="12700">
+            <a:solidFill>
+              <a:srgbClr val="1A2A40"/>
+            </a:solidFill>
+          </a:ln>
+        </p:spPr>
+        <p:style>
+          <a:lnRef idx="1">
+            <a:schemeClr val="accent1"/>
+          </a:lnRef>
+          <a:fillRef idx="3">
+            <a:schemeClr val="accent1"/>
+          </a:fillRef>
+          <a:effectRef idx="2">
+            <a:schemeClr val="accent1"/>
+          </a:effectRef>
+          <a:fontRef idx="minor">
+            <a:schemeClr val="lt1"/>
+          </a:fontRef>
+        </p:style>
+        <p:txBody>
+          <a:bodyPr rtlCol="0" anchor="ctr"/>
+          <a:lstStyle/>
+          <a:p>
+            <a:pPr algn="ctr"/>
+          </a:p>
+        </p:txBody>
+      </p:sp>
+      <p:sp>
+        <p:nvSpPr>
+          <p:cNvPr id="62" name="Oval 61"/>
+          <p:cNvSpPr/>
+          <p:nvPr/>
+        </p:nvSpPr>
+        <p:spPr>
+          <a:xfrm>
+            <a:off x="7033837" y="5550634"/>
+            <a:ext cx="365760" cy="365760"/>
+          </a:xfrm>
+          <a:prstGeom prst="ellipse">
+            <a:avLst/>
+          </a:prstGeom>
+          <a:solidFill>
+            <a:srgbClr val="1E3A5F"/>
+          </a:solidFill>
+          <a:ln w="12700">
+            <a:solidFill>
+              <a:srgbClr val="00D4AA"/>
+            </a:solidFill>
+          </a:ln>
+        </p:spPr>
+        <p:style>
+          <a:lnRef idx="1">
+            <a:schemeClr val="accent1"/>
+          </a:lnRef>
+          <a:fillRef idx="3">
+            <a:schemeClr val="accent1"/>
+          </a:fillRef>
+          <a:effectRef idx="2">
+            <a:schemeClr val="accent1"/>
+          </a:effectRef>
+          <a:fontRef idx="minor">
+            <a:schemeClr val="lt1"/>
+          </a:fontRef>
+        </p:style>
+        <p:txBody>
+          <a:bodyPr rtlCol="0" anchor="ctr"/>
+          <a:lstStyle/>
+          <a:p>
+            <a:pPr algn="ctr"/>
+          </a:p>
+        </p:txBody>
+      </p:sp>
+      <p:sp>
+        <p:nvSpPr>
+          <p:cNvPr id="63" name="TextBox 62"/>
+          <p:cNvSpPr txBox="1"/>
+          <p:nvPr/>
+        </p:nvSpPr>
+        <p:spPr>
+          <a:xfrm>
+            <a:off x="7033837" y="5550634"/>
+            <a:ext cx="365760" cy="365760"/>
+          </a:xfrm>
+          <a:prstGeom prst="rect">
+            <a:avLst/>
+          </a:prstGeom>
+          <a:noFill/>
+        </p:spPr>
+        <p:txBody>
+          <a:bodyPr wrap="square" anchor="ctr"/>
+          <a:lstStyle/>
+          <a:p>
+            <a:pPr algn="ctr">
+              <a:spcBef>
+                <a:spcPts val="0"/>
+              </a:spcBef>
+              <a:spcAft>
+                <a:spcPts val="0"/>
+              </a:spcAft>
+            </a:pPr>
+            <a:r>
+              <a:rPr sz="900" b="1">
+                <a:solidFill>
+                  <a:srgbClr val="00D4AA"/>
+                </a:solidFill>
+                <a:latin typeface="Inter"/>
+              </a:rPr>
+              <a:t>DE</a:t>
+            </a:r>
+          </a:p>
+        </p:txBody>
+      </p:sp>
+      <p:sp>
+        <p:nvSpPr>
+          <p:cNvPr id="64" name="TextBox 63"/>
+          <p:cNvSpPr txBox="1"/>
+          <p:nvPr/>
+        </p:nvSpPr>
+        <p:spPr>
+          <a:xfrm>
+            <a:off x="7417885" y="5523202"/>
+            <a:ext cx="731520" cy="457200"/>
+          </a:xfrm>
+          <a:prstGeom prst="rect">
+            <a:avLst/>
+          </a:prstGeom>
+          <a:noFill/>
+        </p:spPr>
+        <p:txBody>
+          <a:bodyPr wrap="square" anchor="t"/>
+          <a:lstStyle/>
+          <a:p>
+            <a:pPr algn="l">
+              <a:spcBef>
+                <a:spcPts val="0"/>
+              </a:spcBef>
+              <a:spcAft>
+                <a:spcPts val="0"/>
+              </a:spcAft>
+            </a:pPr>
+            <a:r>
+              <a:rPr sz="1000" b="1">
+                <a:solidFill>
+                  <a:srgbClr val="E2E8F0"/>
+                </a:solidFill>
+                <a:latin typeface="Inter"/>
+              </a:rPr>
+              <a:t>DevOps
+Engineer</a:t>
+            </a:r>
+          </a:p>
+        </p:txBody>
+      </p:sp>
+      <p:sp>
+        <p:nvSpPr>
+          <p:cNvPr id="65" name="TextBox 64"/>
+          <p:cNvSpPr txBox="1"/>
+          <p:nvPr/>
+        </p:nvSpPr>
+        <p:spPr>
+          <a:xfrm>
+            <a:off x="7033837" y="6071842"/>
+            <a:ext cx="1133856" cy="365760"/>
+          </a:xfrm>
+          <a:prstGeom prst="rect">
+            <a:avLst/>
+          </a:prstGeom>
+          <a:noFill/>
+        </p:spPr>
+        <p:txBody>
+          <a:bodyPr wrap="square" anchor="t"/>
+          <a:lstStyle/>
+          <a:p>
+            <a:pPr algn="ctr">
+              <a:spcBef>
+                <a:spcPts val="0"/>
+              </a:spcBef>
+              <a:spcAft>
+                <a:spcPts val="0"/>
+              </a:spcAft>
+            </a:pPr>
+            <a:r>
+              <a:rPr sz="800" b="0">
+                <a:solidFill>
+                  <a:srgbClr val="64748B"/>
+                </a:solidFill>
+                <a:latin typeface="Inter"/>
+              </a:rPr>
+              <a:t>CI/CD automation</a:t>
+            </a:r>
+          </a:p>
+        </p:txBody>
+      </p:sp>
+      <p:sp>
+        <p:nvSpPr>
+          <p:cNvPr id="66" name="Rectangle 65"/>
+          <p:cNvSpPr/>
+          <p:nvPr/>
+        </p:nvSpPr>
+        <p:spPr>
+          <a:xfrm>
+            <a:off x="6095847" y="3840480"/>
+            <a:ext cx="18288" cy="18288"/>
+          </a:xfrm>
+          <a:prstGeom prst="rect">
+            <a:avLst/>
+          </a:prstGeom>
+          <a:noFill/>
+          <a:ln>
+            <a:noFill/>
+          </a:ln>
+        </p:spPr>
+        <p:style>
+          <a:lnRef idx="1">
+            <a:schemeClr val="accent1"/>
+          </a:lnRef>
+          <a:fillRef idx="3">
+            <a:schemeClr val="accent1"/>
+          </a:fillRef>
+          <a:effectRef idx="2">
+            <a:schemeClr val="accent1"/>
+          </a:effectRef>
+          <a:fontRef idx="minor">
+            <a:schemeClr val="lt1"/>
+          </a:fontRef>
+        </p:style>
+        <p:txBody>
+          <a:bodyPr rtlCol="0" anchor="ctr"/>
+          <a:lstStyle/>
+          <a:p>
+            <a:pPr algn="ctr"/>
+          </a:p>
+        </p:txBody>
+      </p:sp>
+      <p:sp>
+        <p:nvSpPr>
+          <p:cNvPr id="67" name="Rectangle 66"/>
+          <p:cNvSpPr/>
+          <p:nvPr/>
+        </p:nvSpPr>
+        <p:spPr>
+          <a:xfrm>
+            <a:off x="7673069" y="4686300"/>
+            <a:ext cx="1280160" cy="868680"/>
+          </a:xfrm>
+          <a:prstGeom prst="rect">
+            <a:avLst/>
+          </a:prstGeom>
+          <a:solidFill>
+            <a:srgbClr val="1E293B"/>
+          </a:solidFill>
+          <a:ln w="12700">
+            <a:solidFill>
+              <a:srgbClr val="1A2A40"/>
+            </a:solidFill>
+          </a:ln>
+        </p:spPr>
+        <p:style>
+          <a:lnRef idx="1">
+            <a:schemeClr val="accent1"/>
+          </a:lnRef>
+          <a:fillRef idx="3">
+            <a:schemeClr val="accent1"/>
+          </a:fillRef>
+          <a:effectRef idx="2">
+            <a:schemeClr val="accent1"/>
+          </a:effectRef>
+          <a:fontRef idx="minor">
+            <a:schemeClr val="lt1"/>
+          </a:fontRef>
+        </p:style>
+        <p:txBody>
+          <a:bodyPr rtlCol="0" anchor="ctr"/>
+          <a:lstStyle/>
+          <a:p>
+            <a:pPr algn="ctr"/>
+          </a:p>
+        </p:txBody>
+      </p:sp>
+      <p:sp>
+        <p:nvSpPr>
+          <p:cNvPr id="68" name="Oval 67"/>
+          <p:cNvSpPr/>
+          <p:nvPr/>
+        </p:nvSpPr>
+        <p:spPr>
+          <a:xfrm>
+            <a:off x="7746221" y="4759452"/>
+            <a:ext cx="365760" cy="365760"/>
+          </a:xfrm>
+          <a:prstGeom prst="ellipse">
+            <a:avLst/>
+          </a:prstGeom>
+          <a:solidFill>
+            <a:srgbClr val="1E3A5F"/>
+          </a:solidFill>
+          <a:ln w="12700">
+            <a:solidFill>
+              <a:srgbClr val="00D4AA"/>
+            </a:solidFill>
+          </a:ln>
+        </p:spPr>
+        <p:style>
+          <a:lnRef idx="1">
+            <a:schemeClr val="accent1"/>
+          </a:lnRef>
+          <a:fillRef idx="3">
+            <a:schemeClr val="accent1"/>
+          </a:fillRef>
+          <a:effectRef idx="2">
+            <a:schemeClr val="accent1"/>
+          </a:effectRef>
+          <a:fontRef idx="minor">
+            <a:schemeClr val="lt1"/>
+          </a:fontRef>
+        </p:style>
+        <p:txBody>
+          <a:bodyPr rtlCol="0" anchor="ctr"/>
+          <a:lstStyle/>
+          <a:p>
+            <a:pPr algn="ctr"/>
+          </a:p>
+        </p:txBody>
+      </p:sp>
+      <p:sp>
+        <p:nvSpPr>
+          <p:cNvPr id="69" name="TextBox 68"/>
+          <p:cNvSpPr txBox="1"/>
+          <p:nvPr/>
+        </p:nvSpPr>
+        <p:spPr>
+          <a:xfrm>
+            <a:off x="7746221" y="4759452"/>
+            <a:ext cx="365760" cy="365760"/>
+          </a:xfrm>
+          <a:prstGeom prst="rect">
+            <a:avLst/>
+          </a:prstGeom>
+          <a:noFill/>
+        </p:spPr>
+        <p:txBody>
+          <a:bodyPr wrap="square" anchor="ctr"/>
+          <a:lstStyle/>
+          <a:p>
+            <a:pPr algn="ctr">
+              <a:spcBef>
+                <a:spcPts val="0"/>
+              </a:spcBef>
+              <a:spcAft>
+                <a:spcPts val="0"/>
+              </a:spcAft>
+            </a:pPr>
+            <a:r>
+              <a:rPr sz="900" b="1">
+                <a:solidFill>
+                  <a:srgbClr val="00D4AA"/>
+                </a:solidFill>
+                <a:latin typeface="Inter"/>
+              </a:rPr>
+              <a:t>PR</a:t>
+            </a:r>
+          </a:p>
+        </p:txBody>
+      </p:sp>
+      <p:sp>
+        <p:nvSpPr>
+          <p:cNvPr id="70" name="TextBox 69"/>
+          <p:cNvSpPr txBox="1"/>
+          <p:nvPr/>
+        </p:nvSpPr>
+        <p:spPr>
+          <a:xfrm>
+            <a:off x="8130269" y="4732020"/>
+            <a:ext cx="731520" cy="457200"/>
+          </a:xfrm>
+          <a:prstGeom prst="rect">
+            <a:avLst/>
+          </a:prstGeom>
+          <a:noFill/>
+        </p:spPr>
+        <p:txBody>
+          <a:bodyPr wrap="square" anchor="t"/>
+          <a:lstStyle/>
+          <a:p>
+            <a:pPr algn="l">
+              <a:spcBef>
+                <a:spcPts val="0"/>
+              </a:spcBef>
+              <a:spcAft>
+                <a:spcPts val="0"/>
+              </a:spcAft>
+            </a:pPr>
+            <a:r>
+              <a:rPr sz="1000" b="1">
+                <a:solidFill>
+                  <a:srgbClr val="E2E8F0"/>
+                </a:solidFill>
+                <a:latin typeface="Inter"/>
+              </a:rPr>
+              <a:t>PR
+Reviewer</a:t>
+            </a:r>
+          </a:p>
+        </p:txBody>
+      </p:sp>
+      <p:sp>
+        <p:nvSpPr>
+          <p:cNvPr id="71" name="TextBox 70"/>
+          <p:cNvSpPr txBox="1"/>
+          <p:nvPr/>
+        </p:nvSpPr>
+        <p:spPr>
+          <a:xfrm>
+            <a:off x="7746221" y="5280660"/>
+            <a:ext cx="1133856" cy="365760"/>
+          </a:xfrm>
+          <a:prstGeom prst="rect">
+            <a:avLst/>
+          </a:prstGeom>
+          <a:noFill/>
+        </p:spPr>
+        <p:txBody>
+          <a:bodyPr wrap="square" anchor="t"/>
+          <a:lstStyle/>
+          <a:p>
+            <a:pPr algn="ctr">
+              <a:spcBef>
+                <a:spcPts val="0"/>
+              </a:spcBef>
+              <a:spcAft>
+                <a:spcPts val="0"/>
+              </a:spcAft>
+            </a:pPr>
+            <a:r>
+              <a:rPr sz="800" b="0">
+                <a:solidFill>
+                  <a:srgbClr val="64748B"/>
+                </a:solidFill>
+                <a:latin typeface="Inter"/>
+              </a:rPr>
+              <a:t>Headless PR review</a:t>
+            </a:r>
+          </a:p>
+        </p:txBody>
+      </p:sp>
+      <p:sp>
+        <p:nvSpPr>
+          <p:cNvPr id="72" name="Rectangle 71"/>
+          <p:cNvSpPr/>
+          <p:nvPr/>
+        </p:nvSpPr>
+        <p:spPr>
+          <a:xfrm>
+            <a:off x="6095847" y="3840480"/>
+            <a:ext cx="18288" cy="18288"/>
+          </a:xfrm>
+          <a:prstGeom prst="rect">
+            <a:avLst/>
+          </a:prstGeom>
+          <a:noFill/>
+          <a:ln>
+            <a:noFill/>
+          </a:ln>
+        </p:spPr>
+        <p:style>
+          <a:lnRef idx="1">
+            <a:schemeClr val="accent1"/>
+          </a:lnRef>
+          <a:fillRef idx="3">
+            <a:schemeClr val="accent1"/>
+          </a:fillRef>
+          <a:effectRef idx="2">
+            <a:schemeClr val="accent1"/>
+          </a:effectRef>
+          <a:fontRef idx="minor">
+            <a:schemeClr val="lt1"/>
+          </a:fontRef>
+        </p:style>
+        <p:txBody>
+          <a:bodyPr rtlCol="0" anchor="ctr"/>
+          <a:lstStyle/>
+          <a:p>
+            <a:pPr algn="ctr"/>
+          </a:p>
+        </p:txBody>
+      </p:sp>
+      <p:sp>
+        <p:nvSpPr>
+          <p:cNvPr id="73" name="Rectangle 72"/>
+          <p:cNvSpPr/>
+          <p:nvPr/>
+        </p:nvSpPr>
+        <p:spPr>
+          <a:xfrm>
+            <a:off x="8002061" y="3673766"/>
+            <a:ext cx="1280160" cy="868680"/>
+          </a:xfrm>
+          <a:prstGeom prst="rect">
+            <a:avLst/>
+          </a:prstGeom>
+          <a:solidFill>
+            <a:srgbClr val="1E293B"/>
+          </a:solidFill>
+          <a:ln w="12700">
+            <a:solidFill>
+              <a:srgbClr val="1A2A40"/>
+            </a:solidFill>
+          </a:ln>
+        </p:spPr>
+        <p:style>
+          <a:lnRef idx="1">
+            <a:schemeClr val="accent1"/>
+          </a:lnRef>
+          <a:fillRef idx="3">
+            <a:schemeClr val="accent1"/>
+          </a:fillRef>
+          <a:effectRef idx="2">
+            <a:schemeClr val="accent1"/>
+          </a:effectRef>
+          <a:fontRef idx="minor">
+            <a:schemeClr val="lt1"/>
+          </a:fontRef>
+        </p:style>
+        <p:txBody>
+          <a:bodyPr rtlCol="0" anchor="ctr"/>
+          <a:lstStyle/>
+          <a:p>
+            <a:pPr algn="ctr"/>
+          </a:p>
+        </p:txBody>
+      </p:sp>
+      <p:sp>
+        <p:nvSpPr>
+          <p:cNvPr id="74" name="Oval 73"/>
+          <p:cNvSpPr/>
+          <p:nvPr/>
+        </p:nvSpPr>
+        <p:spPr>
+          <a:xfrm>
+            <a:off x="8075213" y="3746918"/>
+            <a:ext cx="365760" cy="365760"/>
+          </a:xfrm>
+          <a:prstGeom prst="ellipse">
+            <a:avLst/>
+          </a:prstGeom>
+          <a:solidFill>
+            <a:srgbClr val="1E3A5F"/>
+          </a:solidFill>
+          <a:ln w="12700">
+            <a:solidFill>
+              <a:srgbClr val="00D4AA"/>
+            </a:solidFill>
+          </a:ln>
+        </p:spPr>
+        <p:style>
+          <a:lnRef idx="1">
+            <a:schemeClr val="accent1"/>
+          </a:lnRef>
+          <a:fillRef idx="3">
+            <a:schemeClr val="accent1"/>
+          </a:fillRef>
+          <a:effectRef idx="2">
+            <a:schemeClr val="accent1"/>
+          </a:effectRef>
+          <a:fontRef idx="minor">
+            <a:schemeClr val="lt1"/>
+          </a:fontRef>
+        </p:style>
+        <p:txBody>
+          <a:bodyPr rtlCol="0" anchor="ctr"/>
+          <a:lstStyle/>
+          <a:p>
+            <a:pPr algn="ctr"/>
+          </a:p>
+        </p:txBody>
+      </p:sp>
+      <p:sp>
+        <p:nvSpPr>
+          <p:cNvPr id="75" name="TextBox 74"/>
+          <p:cNvSpPr txBox="1"/>
+          <p:nvPr/>
+        </p:nvSpPr>
+        <p:spPr>
+          <a:xfrm>
+            <a:off x="8075213" y="3746918"/>
+            <a:ext cx="365760" cy="365760"/>
+          </a:xfrm>
+          <a:prstGeom prst="rect">
+            <a:avLst/>
+          </a:prstGeom>
+          <a:noFill/>
+        </p:spPr>
+        <p:txBody>
+          <a:bodyPr wrap="square" anchor="ctr"/>
+          <a:lstStyle/>
+          <a:p>
+            <a:pPr algn="ctr">
+              <a:spcBef>
+                <a:spcPts val="0"/>
+              </a:spcBef>
+              <a:spcAft>
+                <a:spcPts val="0"/>
+              </a:spcAft>
+            </a:pPr>
+            <a:r>
+              <a:rPr sz="900" b="1">
+                <a:solidFill>
+                  <a:srgbClr val="00D4AA"/>
+                </a:solidFill>
+                <a:latin typeface="Inter"/>
+              </a:rPr>
+              <a:t>DW</a:t>
+            </a:r>
+          </a:p>
+        </p:txBody>
+      </p:sp>
+      <p:sp>
+        <p:nvSpPr>
+          <p:cNvPr id="76" name="TextBox 75"/>
+          <p:cNvSpPr txBox="1"/>
+          <p:nvPr/>
+        </p:nvSpPr>
+        <p:spPr>
+          <a:xfrm>
+            <a:off x="8459261" y="3719486"/>
+            <a:ext cx="731520" cy="457200"/>
+          </a:xfrm>
+          <a:prstGeom prst="rect">
+            <a:avLst/>
+          </a:prstGeom>
+          <a:noFill/>
+        </p:spPr>
+        <p:txBody>
+          <a:bodyPr wrap="square" anchor="t"/>
+          <a:lstStyle/>
+          <a:p>
+            <a:pPr algn="l">
+              <a:spcBef>
+                <a:spcPts val="0"/>
+              </a:spcBef>
+              <a:spcAft>
+                <a:spcPts val="0"/>
+              </a:spcAft>
+            </a:pPr>
+            <a:r>
+              <a:rPr sz="1000" b="1">
+                <a:solidFill>
+                  <a:srgbClr val="E2E8F0"/>
+                </a:solidFill>
+                <a:latin typeface="Inter"/>
+              </a:rPr>
+              <a:t>Docs
+Writer</a:t>
+            </a:r>
+          </a:p>
+        </p:txBody>
+      </p:sp>
+      <p:sp>
+        <p:nvSpPr>
+          <p:cNvPr id="77" name="TextBox 76"/>
+          <p:cNvSpPr txBox="1"/>
+          <p:nvPr/>
+        </p:nvSpPr>
+        <p:spPr>
+          <a:xfrm>
+            <a:off x="8075213" y="4268126"/>
+            <a:ext cx="1133856" cy="365760"/>
+          </a:xfrm>
+          <a:prstGeom prst="rect">
+            <a:avLst/>
+          </a:prstGeom>
+          <a:noFill/>
+        </p:spPr>
+        <p:txBody>
+          <a:bodyPr wrap="square" anchor="t"/>
+          <a:lstStyle/>
+          <a:p>
+            <a:pPr algn="ctr">
+              <a:spcBef>
+                <a:spcPts val="0"/>
+              </a:spcBef>
+              <a:spcAft>
+                <a:spcPts val="0"/>
+              </a:spcAft>
+            </a:pPr>
+            <a:r>
+              <a:rPr sz="800" b="0">
+                <a:solidFill>
+                  <a:srgbClr val="64748B"/>
+                </a:solidFill>
+                <a:latin typeface="Inter"/>
+              </a:rPr>
+              <a:t>Documentation</a:t>
+            </a:r>
+          </a:p>
+        </p:txBody>
+      </p:sp>
+      <p:sp>
+        <p:nvSpPr>
+          <p:cNvPr id="78" name="Rectangle 77"/>
+          <p:cNvSpPr/>
+          <p:nvPr/>
+        </p:nvSpPr>
+        <p:spPr>
+          <a:xfrm>
+            <a:off x="6095847" y="3840480"/>
+            <a:ext cx="18288" cy="18288"/>
+          </a:xfrm>
+          <a:prstGeom prst="rect">
+            <a:avLst/>
+          </a:prstGeom>
+          <a:noFill/>
+          <a:ln>
+            <a:noFill/>
+          </a:ln>
+        </p:spPr>
+        <p:style>
+          <a:lnRef idx="1">
+            <a:schemeClr val="accent1"/>
+          </a:lnRef>
+          <a:fillRef idx="3">
+            <a:schemeClr val="accent1"/>
+          </a:fillRef>
+          <a:effectRef idx="2">
+            <a:schemeClr val="accent1"/>
+          </a:effectRef>
+          <a:fontRef idx="minor">
+            <a:schemeClr val="lt1"/>
+          </a:fontRef>
+        </p:style>
+        <p:txBody>
+          <a:bodyPr rtlCol="0" anchor="ctr"/>
+          <a:lstStyle/>
+          <a:p>
+            <a:pPr algn="ctr"/>
+          </a:p>
+        </p:txBody>
+      </p:sp>
+      <p:sp>
+        <p:nvSpPr>
+          <p:cNvPr id="79" name="Rectangle 78"/>
+          <p:cNvSpPr/>
+          <p:nvPr/>
+        </p:nvSpPr>
+        <p:spPr>
+          <a:xfrm>
+            <a:off x="7890776" y="2614957"/>
+            <a:ext cx="1280160" cy="868680"/>
+          </a:xfrm>
+          <a:prstGeom prst="rect">
+            <a:avLst/>
+          </a:prstGeom>
+          <a:solidFill>
+            <a:srgbClr val="1E293B"/>
+          </a:solidFill>
+          <a:ln w="12700">
+            <a:solidFill>
+              <a:srgbClr val="1A2A40"/>
+            </a:solidFill>
+          </a:ln>
+        </p:spPr>
+        <p:style>
+          <a:lnRef idx="1">
+            <a:schemeClr val="accent1"/>
+          </a:lnRef>
+          <a:fillRef idx="3">
+            <a:schemeClr val="accent1"/>
+          </a:fillRef>
+          <a:effectRef idx="2">
+            <a:schemeClr val="accent1"/>
+          </a:effectRef>
+          <a:fontRef idx="minor">
+            <a:schemeClr val="lt1"/>
+          </a:fontRef>
+        </p:style>
+        <p:txBody>
+          <a:bodyPr rtlCol="0" anchor="ctr"/>
+          <a:lstStyle/>
+          <a:p>
+            <a:pPr algn="ctr"/>
+          </a:p>
+        </p:txBody>
+      </p:sp>
+      <p:sp>
+        <p:nvSpPr>
+          <p:cNvPr id="80" name="Oval 79"/>
+          <p:cNvSpPr/>
+          <p:nvPr/>
+        </p:nvSpPr>
+        <p:spPr>
+          <a:xfrm>
+            <a:off x="7963928" y="2688109"/>
+            <a:ext cx="365760" cy="365760"/>
+          </a:xfrm>
+          <a:prstGeom prst="ellipse">
+            <a:avLst/>
+          </a:prstGeom>
+          <a:solidFill>
+            <a:srgbClr val="1E3A5F"/>
+          </a:solidFill>
+          <a:ln w="12700">
+            <a:solidFill>
+              <a:srgbClr val="00D4AA"/>
+            </a:solidFill>
+          </a:ln>
+        </p:spPr>
+        <p:style>
+          <a:lnRef idx="1">
+            <a:schemeClr val="accent1"/>
+          </a:lnRef>
+          <a:fillRef idx="3">
+            <a:schemeClr val="accent1"/>
+          </a:fillRef>
+          <a:effectRef idx="2">
+            <a:schemeClr val="accent1"/>
+          </a:effectRef>
+          <a:fontRef idx="minor">
+            <a:schemeClr val="lt1"/>
+          </a:fontRef>
+        </p:style>
+        <p:txBody>
+          <a:bodyPr rtlCol="0" anchor="ctr"/>
+          <a:lstStyle/>
+          <a:p>
+            <a:pPr algn="ctr"/>
+          </a:p>
+        </p:txBody>
+      </p:sp>
+      <p:sp>
+        <p:nvSpPr>
+          <p:cNvPr id="81" name="TextBox 80"/>
+          <p:cNvSpPr txBox="1"/>
+          <p:nvPr/>
+        </p:nvSpPr>
+        <p:spPr>
+          <a:xfrm>
+            <a:off x="7963928" y="2688109"/>
+            <a:ext cx="365760" cy="365760"/>
+          </a:xfrm>
+          <a:prstGeom prst="rect">
+            <a:avLst/>
+          </a:prstGeom>
+          <a:noFill/>
+        </p:spPr>
+        <p:txBody>
+          <a:bodyPr wrap="square" anchor="ctr"/>
+          <a:lstStyle/>
+          <a:p>
+            <a:pPr algn="ctr">
+              <a:spcBef>
+                <a:spcPts val="0"/>
+              </a:spcBef>
+              <a:spcAft>
+                <a:spcPts val="0"/>
+              </a:spcAft>
+            </a:pPr>
+            <a:r>
+              <a:rPr sz="900" b="1">
+                <a:solidFill>
+                  <a:srgbClr val="00D4AA"/>
+                </a:solidFill>
+                <a:latin typeface="Inter"/>
+              </a:rPr>
+              <a:t>GS</a:t>
+            </a:r>
+          </a:p>
+        </p:txBody>
+      </p:sp>
+      <p:sp>
+        <p:nvSpPr>
+          <p:cNvPr id="82" name="TextBox 81"/>
+          <p:cNvSpPr txBox="1"/>
+          <p:nvPr/>
+        </p:nvSpPr>
+        <p:spPr>
+          <a:xfrm>
+            <a:off x="8347976" y="2660677"/>
+            <a:ext cx="731520" cy="457200"/>
+          </a:xfrm>
+          <a:prstGeom prst="rect">
+            <a:avLst/>
+          </a:prstGeom>
+          <a:noFill/>
+        </p:spPr>
+        <p:txBody>
+          <a:bodyPr wrap="square" anchor="t"/>
+          <a:lstStyle/>
+          <a:p>
+            <a:pPr algn="l">
+              <a:spcBef>
+                <a:spcPts val="0"/>
+              </a:spcBef>
+              <a:spcAft>
+                <a:spcPts val="0"/>
+              </a:spcAft>
+            </a:pPr>
+            <a:r>
+              <a:rPr sz="1000" b="1">
+                <a:solidFill>
+                  <a:srgbClr val="E2E8F0"/>
+                </a:solidFill>
+                <a:latin typeface="Inter"/>
+              </a:rPr>
+              <a:t>Governance
+Steward</a:t>
+            </a:r>
+          </a:p>
+        </p:txBody>
+      </p:sp>
+      <p:sp>
+        <p:nvSpPr>
+          <p:cNvPr id="83" name="TextBox 82"/>
+          <p:cNvSpPr txBox="1"/>
+          <p:nvPr/>
+        </p:nvSpPr>
+        <p:spPr>
+          <a:xfrm>
+            <a:off x="7963928" y="3209317"/>
+            <a:ext cx="1133856" cy="365760"/>
+          </a:xfrm>
+          <a:prstGeom prst="rect">
+            <a:avLst/>
+          </a:prstGeom>
+          <a:noFill/>
+        </p:spPr>
+        <p:txBody>
+          <a:bodyPr wrap="square" anchor="t"/>
+          <a:lstStyle/>
+          <a:p>
+            <a:pPr algn="ctr">
+              <a:spcBef>
+                <a:spcPts val="0"/>
+              </a:spcBef>
+              <a:spcAft>
+                <a:spcPts val="0"/>
+              </a:spcAft>
+            </a:pPr>
+            <a:r>
+              <a:rPr sz="800" b="0">
+                <a:solidFill>
+                  <a:srgbClr val="64748B"/>
+                </a:solidFill>
+                <a:latin typeface="Inter"/>
+              </a:rPr>
+              <a:t>Gov. lifecycle</a:t>
+            </a:r>
+          </a:p>
+        </p:txBody>
+      </p:sp>
+      <p:sp>
+        <p:nvSpPr>
+          <p:cNvPr id="84" name="Rectangle 83"/>
+          <p:cNvSpPr/>
+          <p:nvPr/>
+        </p:nvSpPr>
+        <p:spPr>
+          <a:xfrm>
+            <a:off x="6095847" y="3840480"/>
+            <a:ext cx="18288" cy="18288"/>
+          </a:xfrm>
+          <a:prstGeom prst="rect">
+            <a:avLst/>
+          </a:prstGeom>
+          <a:noFill/>
+          <a:ln>
+            <a:noFill/>
+          </a:ln>
+        </p:spPr>
+        <p:style>
+          <a:lnRef idx="1">
+            <a:schemeClr val="accent1"/>
+          </a:lnRef>
+          <a:fillRef idx="3">
+            <a:schemeClr val="accent1"/>
+          </a:fillRef>
+          <a:effectRef idx="2">
+            <a:schemeClr val="accent1"/>
+          </a:effectRef>
+          <a:fontRef idx="minor">
+            <a:schemeClr val="lt1"/>
+          </a:fontRef>
+        </p:style>
+        <p:txBody>
+          <a:bodyPr rtlCol="0" anchor="ctr"/>
+          <a:lstStyle/>
+          <a:p>
+            <a:pPr algn="ctr"/>
+          </a:p>
+        </p:txBody>
+      </p:sp>
+      <p:sp>
+        <p:nvSpPr>
+          <p:cNvPr id="85" name="Rectangle 84"/>
+          <p:cNvSpPr/>
+          <p:nvPr/>
+        </p:nvSpPr>
+        <p:spPr>
+          <a:xfrm>
+            <a:off x="7358455" y="1692951"/>
+            <a:ext cx="1280160" cy="868680"/>
+          </a:xfrm>
+          <a:prstGeom prst="rect">
+            <a:avLst/>
+          </a:prstGeom>
+          <a:solidFill>
+            <a:srgbClr val="1E293B"/>
+          </a:solidFill>
+          <a:ln w="12700">
+            <a:solidFill>
+              <a:srgbClr val="1A2A40"/>
+            </a:solidFill>
+          </a:ln>
+        </p:spPr>
+        <p:style>
+          <a:lnRef idx="1">
+            <a:schemeClr val="accent1"/>
+          </a:lnRef>
+          <a:fillRef idx="3">
+            <a:schemeClr val="accent1"/>
+          </a:fillRef>
+          <a:effectRef idx="2">
+            <a:schemeClr val="accent1"/>
+          </a:effectRef>
+          <a:fontRef idx="minor">
+            <a:schemeClr val="lt1"/>
+          </a:fontRef>
+        </p:style>
+        <p:txBody>
+          <a:bodyPr rtlCol="0" anchor="ctr"/>
+          <a:lstStyle/>
+          <a:p>
+            <a:pPr algn="ctr"/>
+          </a:p>
+        </p:txBody>
+      </p:sp>
+      <p:sp>
+        <p:nvSpPr>
+          <p:cNvPr id="86" name="Oval 85"/>
+          <p:cNvSpPr/>
+          <p:nvPr/>
+        </p:nvSpPr>
+        <p:spPr>
+          <a:xfrm>
+            <a:off x="7431607" y="1766103"/>
+            <a:ext cx="365760" cy="365760"/>
+          </a:xfrm>
+          <a:prstGeom prst="ellipse">
+            <a:avLst/>
+          </a:prstGeom>
+          <a:solidFill>
+            <a:srgbClr val="1E3A5F"/>
+          </a:solidFill>
+          <a:ln w="12700">
+            <a:solidFill>
+              <a:srgbClr val="00D4AA"/>
+            </a:solidFill>
+          </a:ln>
+        </p:spPr>
+        <p:style>
+          <a:lnRef idx="1">
+            <a:schemeClr val="accent1"/>
+          </a:lnRef>
+          <a:fillRef idx="3">
+            <a:schemeClr val="accent1"/>
+          </a:fillRef>
+          <a:effectRef idx="2">
+            <a:schemeClr val="accent1"/>
+          </a:effectRef>
+          <a:fontRef idx="minor">
+            <a:schemeClr val="lt1"/>
+          </a:fontRef>
+        </p:style>
+        <p:txBody>
+          <a:bodyPr rtlCol="0" anchor="ctr"/>
+          <a:lstStyle/>
+          <a:p>
+            <a:pPr algn="ctr"/>
+          </a:p>
+        </p:txBody>
+      </p:sp>
+      <p:sp>
+        <p:nvSpPr>
+          <p:cNvPr id="87" name="TextBox 86"/>
+          <p:cNvSpPr txBox="1"/>
+          <p:nvPr/>
+        </p:nvSpPr>
+        <p:spPr>
+          <a:xfrm>
+            <a:off x="7431607" y="1766103"/>
+            <a:ext cx="365760" cy="365760"/>
+          </a:xfrm>
+          <a:prstGeom prst="rect">
+            <a:avLst/>
+          </a:prstGeom>
+          <a:noFill/>
+        </p:spPr>
+        <p:txBody>
+          <a:bodyPr wrap="square" anchor="ctr"/>
+          <a:lstStyle/>
+          <a:p>
+            <a:pPr algn="ctr">
+              <a:spcBef>
+                <a:spcPts val="0"/>
+              </a:spcBef>
+              <a:spcAft>
+                <a:spcPts val="0"/>
+              </a:spcAft>
+            </a:pPr>
+            <a:r>
+              <a:rPr sz="900" b="1">
+                <a:solidFill>
+                  <a:srgbClr val="00D4AA"/>
+                </a:solidFill>
+                <a:latin typeface="Inter"/>
+              </a:rPr>
+              <a:t>NV</a:t>
+            </a:r>
+          </a:p>
+        </p:txBody>
+      </p:sp>
+      <p:sp>
+        <p:nvSpPr>
+          <p:cNvPr id="88" name="TextBox 87"/>
+          <p:cNvSpPr txBox="1"/>
+          <p:nvPr/>
+        </p:nvSpPr>
+        <p:spPr>
+          <a:xfrm>
+            <a:off x="7815655" y="1738671"/>
+            <a:ext cx="731520" cy="457200"/>
+          </a:xfrm>
+          <a:prstGeom prst="rect">
+            <a:avLst/>
+          </a:prstGeom>
+          <a:noFill/>
+        </p:spPr>
+        <p:txBody>
+          <a:bodyPr wrap="square" anchor="t"/>
+          <a:lstStyle/>
+          <a:p>
+            <a:pPr algn="l">
+              <a:spcBef>
+                <a:spcPts val="0"/>
+              </a:spcBef>
+              <a:spcAft>
+                <a:spcPts val="0"/>
+              </a:spcAft>
+            </a:pPr>
+            <a:r>
+              <a:rPr sz="1000" b="1">
+                <a:solidFill>
+                  <a:srgbClr val="E2E8F0"/>
+                </a:solidFill>
+                <a:latin typeface="Inter"/>
+              </a:rPr>
+              <a:t>Navigator</a:t>
+            </a:r>
+          </a:p>
+        </p:txBody>
+      </p:sp>
+      <p:sp>
+        <p:nvSpPr>
+          <p:cNvPr id="89" name="TextBox 88"/>
+          <p:cNvSpPr txBox="1"/>
+          <p:nvPr/>
+        </p:nvSpPr>
+        <p:spPr>
+          <a:xfrm>
+            <a:off x="7431607" y="2287311"/>
+            <a:ext cx="1133856" cy="365760"/>
+          </a:xfrm>
+          <a:prstGeom prst="rect">
+            <a:avLst/>
+          </a:prstGeom>
+          <a:noFill/>
+        </p:spPr>
+        <p:txBody>
+          <a:bodyPr wrap="square" anchor="t"/>
+          <a:lstStyle/>
+          <a:p>
+            <a:pPr algn="ctr">
+              <a:spcBef>
+                <a:spcPts val="0"/>
+              </a:spcBef>
+              <a:spcAft>
+                <a:spcPts val="0"/>
+              </a:spcAft>
+            </a:pPr>
+            <a:r>
+              <a:rPr sz="800" b="0">
+                <a:solidFill>
+                  <a:srgbClr val="64748B"/>
+                </a:solidFill>
+                <a:latin typeface="Inter"/>
+              </a:rPr>
+              <a:t>Strategic analysis</a:t>
+            </a:r>
+          </a:p>
+        </p:txBody>
+      </p:sp>
+      <p:sp>
+        <p:nvSpPr>
+          <p:cNvPr id="90" name="Rectangle 89"/>
+          <p:cNvSpPr/>
+          <p:nvPr/>
+        </p:nvSpPr>
+        <p:spPr>
+          <a:xfrm>
+            <a:off x="6095847" y="3840480"/>
+            <a:ext cx="18288" cy="18288"/>
+          </a:xfrm>
+          <a:prstGeom prst="rect">
+            <a:avLst/>
+          </a:prstGeom>
+          <a:noFill/>
+          <a:ln>
+            <a:noFill/>
+          </a:ln>
+        </p:spPr>
+        <p:style>
+          <a:lnRef idx="1">
+            <a:schemeClr val="accent1"/>
+          </a:lnRef>
+          <a:fillRef idx="3">
+            <a:schemeClr val="accent1"/>
+          </a:fillRef>
+          <a:effectRef idx="2">
+            <a:schemeClr val="accent1"/>
+          </a:effectRef>
+          <a:fontRef idx="minor">
+            <a:schemeClr val="lt1"/>
+          </a:fontRef>
+        </p:style>
+        <p:txBody>
+          <a:bodyPr rtlCol="0" anchor="ctr"/>
+          <a:lstStyle/>
+          <a:p>
+            <a:pPr algn="ctr"/>
+          </a:p>
+        </p:txBody>
+      </p:sp>
+      <p:sp>
+        <p:nvSpPr>
+          <p:cNvPr id="91" name="Rectangle 90"/>
+          <p:cNvSpPr/>
+          <p:nvPr/>
+        </p:nvSpPr>
+        <p:spPr>
+          <a:xfrm>
+            <a:off x="6497142" y="1067171"/>
+            <a:ext cx="1280160" cy="868680"/>
+          </a:xfrm>
+          <a:prstGeom prst="rect">
+            <a:avLst/>
+          </a:prstGeom>
+          <a:solidFill>
+            <a:srgbClr val="1E293B"/>
+          </a:solidFill>
+          <a:ln w="12700">
+            <a:solidFill>
+              <a:srgbClr val="1A2A40"/>
+            </a:solidFill>
+          </a:ln>
+        </p:spPr>
+        <p:style>
+          <a:lnRef idx="1">
+            <a:schemeClr val="accent1"/>
+          </a:lnRef>
+          <a:fillRef idx="3">
+            <a:schemeClr val="accent1"/>
+          </a:fillRef>
+          <a:effectRef idx="2">
+            <a:schemeClr val="accent1"/>
+          </a:effectRef>
+          <a:fontRef idx="minor">
+            <a:schemeClr val="lt1"/>
+          </a:fontRef>
+        </p:style>
+        <p:txBody>
+          <a:bodyPr rtlCol="0" anchor="ctr"/>
+          <a:lstStyle/>
+          <a:p>
+            <a:pPr algn="ctr"/>
+          </a:p>
+        </p:txBody>
+      </p:sp>
+      <p:sp>
+        <p:nvSpPr>
+          <p:cNvPr id="92" name="Oval 91"/>
+          <p:cNvSpPr/>
+          <p:nvPr/>
+        </p:nvSpPr>
+        <p:spPr>
+          <a:xfrm>
+            <a:off x="6570294" y="1140323"/>
+            <a:ext cx="365760" cy="365760"/>
+          </a:xfrm>
+          <a:prstGeom prst="ellipse">
+            <a:avLst/>
+          </a:prstGeom>
+          <a:solidFill>
+            <a:srgbClr val="1E3A5F"/>
+          </a:solidFill>
+          <a:ln w="12700">
+            <a:solidFill>
+              <a:srgbClr val="00D4AA"/>
+            </a:solidFill>
+          </a:ln>
+        </p:spPr>
+        <p:style>
+          <a:lnRef idx="1">
+            <a:schemeClr val="accent1"/>
+          </a:lnRef>
+          <a:fillRef idx="3">
+            <a:schemeClr val="accent1"/>
+          </a:fillRef>
+          <a:effectRef idx="2">
+            <a:schemeClr val="accent1"/>
+          </a:effectRef>
+          <a:fontRef idx="minor">
+            <a:schemeClr val="lt1"/>
+          </a:fontRef>
+        </p:style>
+        <p:txBody>
+          <a:bodyPr rtlCol="0" anchor="ctr"/>
+          <a:lstStyle/>
+          <a:p>
+            <a:pPr algn="ctr"/>
+          </a:p>
+        </p:txBody>
+      </p:sp>
+      <p:sp>
+        <p:nvSpPr>
+          <p:cNvPr id="93" name="TextBox 92"/>
+          <p:cNvSpPr txBox="1"/>
+          <p:nvPr/>
+        </p:nvSpPr>
+        <p:spPr>
+          <a:xfrm>
+            <a:off x="6570294" y="1140323"/>
+            <a:ext cx="365760" cy="365760"/>
+          </a:xfrm>
+          <a:prstGeom prst="rect">
+            <a:avLst/>
+          </a:prstGeom>
+          <a:noFill/>
+        </p:spPr>
+        <p:txBody>
+          <a:bodyPr wrap="square" anchor="ctr"/>
+          <a:lstStyle/>
+          <a:p>
+            <a:pPr algn="ctr">
+              <a:spcBef>
+                <a:spcPts val="0"/>
+              </a:spcBef>
+              <a:spcAft>
+                <a:spcPts val="0"/>
+              </a:spcAft>
+            </a:pPr>
+            <a:r>
+              <a:rPr sz="900" b="1">
+                <a:solidFill>
+                  <a:srgbClr val="00D4AA"/>
+                </a:solidFill>
+                <a:latin typeface="Inter"/>
+              </a:rPr>
+              <a:t>PA</a:t>
+            </a:r>
+          </a:p>
+        </p:txBody>
+      </p:sp>
+      <p:sp>
+        <p:nvSpPr>
+          <p:cNvPr id="94" name="TextBox 93"/>
+          <p:cNvSpPr txBox="1"/>
+          <p:nvPr/>
+        </p:nvSpPr>
+        <p:spPr>
+          <a:xfrm>
+            <a:off x="6954342" y="1112891"/>
+            <a:ext cx="731520" cy="457200"/>
+          </a:xfrm>
+          <a:prstGeom prst="rect">
+            <a:avLst/>
+          </a:prstGeom>
+          <a:noFill/>
+        </p:spPr>
+        <p:txBody>
+          <a:bodyPr wrap="square" anchor="t"/>
+          <a:lstStyle/>
+          <a:p>
+            <a:pPr algn="l">
+              <a:spcBef>
+                <a:spcPts val="0"/>
+              </a:spcBef>
+              <a:spcAft>
+                <a:spcPts val="0"/>
+              </a:spcAft>
+            </a:pPr>
+            <a:r>
+              <a:rPr sz="1000" b="1">
+                <a:solidFill>
+                  <a:srgbClr val="E2E8F0"/>
+                </a:solidFill>
+                <a:latin typeface="Inter"/>
+              </a:rPr>
+              <a:t>Platform
+Auditor</a:t>
+            </a:r>
+          </a:p>
+        </p:txBody>
+      </p:sp>
+      <p:sp>
+        <p:nvSpPr>
+          <p:cNvPr id="95" name="TextBox 94"/>
+          <p:cNvSpPr txBox="1"/>
+          <p:nvPr/>
+        </p:nvSpPr>
+        <p:spPr>
+          <a:xfrm>
+            <a:off x="6570294" y="1661531"/>
+            <a:ext cx="1133856" cy="365760"/>
+          </a:xfrm>
+          <a:prstGeom prst="rect">
+            <a:avLst/>
+          </a:prstGeom>
+          <a:noFill/>
+        </p:spPr>
+        <p:txBody>
+          <a:bodyPr wrap="square" anchor="t"/>
+          <a:lstStyle/>
+          <a:p>
+            <a:pPr algn="ctr">
+              <a:spcBef>
+                <a:spcPts val="0"/>
+              </a:spcBef>
+              <a:spcAft>
+                <a:spcPts val="0"/>
+              </a:spcAft>
+            </a:pPr>
+            <a:r>
+              <a:rPr sz="800" b="0">
+                <a:solidFill>
+                  <a:srgbClr val="64748B"/>
+                </a:solidFill>
+                <a:latin typeface="Inter"/>
+              </a:rPr>
+              <a:t>Full-spectrum audit</a:t>
             </a:r>
           </a:p>
         </p:txBody>

</xml_diff>